<commit_message>
Audit formal responses and publish corrected v4
</commit_message>
<xml_diff>
--- a/submission/Presentation-z5557885.pptx
+++ b/submission/Presentation-z5557885.pptx
@@ -2,116 +2,21 @@
 <file path=ppt/presentation.xml><?xml version="1.0" encoding="utf-8"?>
 <p:presentation xmlns:p="http://schemas.openxmlformats.org/presentationml/2006/main">
   <p:sldMasterIdLst>
-    <p:sldMasterId xmlns:r="http://schemas.openxmlformats.org/officeDocument/2006/relationships" id="2147483648" r:id="Rb544a2c6bd7a4d0f"/>
+    <p:sldMasterId xmlns:r="http://schemas.openxmlformats.org/officeDocument/2006/relationships" id="2147483648" r:id="Rf4f5d4f3e02d4008"/>
   </p:sldMasterIdLst>
   <p:notesMasterIdLst>
-    <p:notesMasterId xmlns:r="http://schemas.openxmlformats.org/officeDocument/2006/relationships" r:id="R5d93c4f3271b4ff9"/>
+    <p:notesMasterId xmlns:r="http://schemas.openxmlformats.org/officeDocument/2006/relationships" r:id="Ra040af5e7ede4d9e"/>
   </p:notesMasterIdLst>
   <p:sldIdLst>
-    <p:sldId xmlns:r="http://schemas.openxmlformats.org/officeDocument/2006/relationships" id="256" r:id="R367c6d0c6bf74a6f"/>
-    <p:sldId xmlns:r="http://schemas.openxmlformats.org/officeDocument/2006/relationships" id="257" r:id="R7329db6458e74f69"/>
-    <p:sldId xmlns:r="http://schemas.openxmlformats.org/officeDocument/2006/relationships" id="258" r:id="R619511fe60ba47de"/>
-    <p:sldId xmlns:r="http://schemas.openxmlformats.org/officeDocument/2006/relationships" id="259" r:id="Rdefa6265b7c4469f"/>
-    <p:sldId xmlns:r="http://schemas.openxmlformats.org/officeDocument/2006/relationships" id="260" r:id="Rabee4a365b8c49de"/>
-    <p:sldId xmlns:r="http://schemas.openxmlformats.org/officeDocument/2006/relationships" id="261" r:id="R95f675df09524b8a"/>
+    <p:sldId xmlns:r="http://schemas.openxmlformats.org/officeDocument/2006/relationships" id="256" r:id="R4924177061814cea"/>
+    <p:sldId xmlns:r="http://schemas.openxmlformats.org/officeDocument/2006/relationships" id="257" r:id="R5b0ba1dad3c14154"/>
+    <p:sldId xmlns:r="http://schemas.openxmlformats.org/officeDocument/2006/relationships" id="258" r:id="R903dd3e209fb41b0"/>
+    <p:sldId xmlns:r="http://schemas.openxmlformats.org/officeDocument/2006/relationships" id="259" r:id="Rdb57360c0d0d41d8"/>
+    <p:sldId xmlns:r="http://schemas.openxmlformats.org/officeDocument/2006/relationships" id="260" r:id="Raf2ddabb99644e17"/>
+    <p:sldId xmlns:r="http://schemas.openxmlformats.org/officeDocument/2006/relationships" id="261" r:id="R08fce0c38b824ff5"/>
   </p:sldIdLst>
   <p:sldSz cx="12192000" cy="6858000"/>
   <p:notesSz cx="6858000" cy="9144000"/>
-  <p:defaultTextStyle>
-    <a:defPPr xmlns:a="http://schemas.openxmlformats.org/drawingml/2006/main">
-      <a:defRPr lang="en-US"/>
-    </a:defPPr>
-    <a:lvl1pPr xmlns:a="http://schemas.openxmlformats.org/drawingml/2006/main" marL="0" indent="0" algn="l" defTabSz="914400">
-      <a:defRPr sz="1800" kern="1200">
-        <a:solidFill>
-          <a:schemeClr val="tx1"/>
-        </a:solidFill>
-        <a:latin typeface="+mn-lt"/>
-        <a:ea typeface="+mn-ea"/>
-        <a:cs typeface="+mn-cs"/>
-      </a:defRPr>
-    </a:lvl1pPr>
-    <a:lvl2pPr xmlns:a="http://schemas.openxmlformats.org/drawingml/2006/main" marL="457200" indent="0" algn="l" defTabSz="914400">
-      <a:defRPr sz="1800" kern="1200">
-        <a:solidFill>
-          <a:schemeClr val="tx1"/>
-        </a:solidFill>
-        <a:latin typeface="+mn-lt"/>
-        <a:ea typeface="+mn-ea"/>
-        <a:cs typeface="+mn-cs"/>
-      </a:defRPr>
-    </a:lvl2pPr>
-    <a:lvl3pPr xmlns:a="http://schemas.openxmlformats.org/drawingml/2006/main" marL="914400" indent="0" algn="l" defTabSz="914400">
-      <a:defRPr sz="1800" kern="1200">
-        <a:solidFill>
-          <a:schemeClr val="tx1"/>
-        </a:solidFill>
-        <a:latin typeface="+mn-lt"/>
-        <a:ea typeface="+mn-ea"/>
-        <a:cs typeface="+mn-cs"/>
-      </a:defRPr>
-    </a:lvl3pPr>
-    <a:lvl4pPr xmlns:a="http://schemas.openxmlformats.org/drawingml/2006/main" marL="1371600" indent="0" algn="l" defTabSz="914400">
-      <a:defRPr sz="1800" kern="1200">
-        <a:solidFill>
-          <a:schemeClr val="tx1"/>
-        </a:solidFill>
-        <a:latin typeface="+mn-lt"/>
-        <a:ea typeface="+mn-ea"/>
-        <a:cs typeface="+mn-cs"/>
-      </a:defRPr>
-    </a:lvl4pPr>
-    <a:lvl5pPr xmlns:a="http://schemas.openxmlformats.org/drawingml/2006/main" marL="1828800" indent="0" algn="l" defTabSz="914400">
-      <a:defRPr sz="1800" kern="1200">
-        <a:solidFill>
-          <a:schemeClr val="tx1"/>
-        </a:solidFill>
-        <a:latin typeface="+mn-lt"/>
-        <a:ea typeface="+mn-ea"/>
-        <a:cs typeface="+mn-cs"/>
-      </a:defRPr>
-    </a:lvl5pPr>
-    <a:lvl6pPr xmlns:a="http://schemas.openxmlformats.org/drawingml/2006/main" marL="2286000" indent="0" algn="l" defTabSz="914400">
-      <a:defRPr sz="1800" kern="1200">
-        <a:solidFill>
-          <a:schemeClr val="tx1"/>
-        </a:solidFill>
-        <a:latin typeface="+mn-lt"/>
-        <a:ea typeface="+mn-ea"/>
-        <a:cs typeface="+mn-cs"/>
-      </a:defRPr>
-    </a:lvl6pPr>
-    <a:lvl7pPr xmlns:a="http://schemas.openxmlformats.org/drawingml/2006/main" marL="2743200" indent="0" algn="l" defTabSz="914400">
-      <a:defRPr sz="1800" kern="1200">
-        <a:solidFill>
-          <a:schemeClr val="tx1"/>
-        </a:solidFill>
-        <a:latin typeface="+mn-lt"/>
-        <a:ea typeface="+mn-ea"/>
-        <a:cs typeface="+mn-cs"/>
-      </a:defRPr>
-    </a:lvl7pPr>
-    <a:lvl8pPr xmlns:a="http://schemas.openxmlformats.org/drawingml/2006/main" marL="3200400" indent="0" algn="l" defTabSz="914400">
-      <a:defRPr sz="1800" kern="1200">
-        <a:solidFill>
-          <a:schemeClr val="tx1"/>
-        </a:solidFill>
-        <a:latin typeface="+mn-lt"/>
-        <a:ea typeface="+mn-ea"/>
-        <a:cs typeface="+mn-cs"/>
-      </a:defRPr>
-    </a:lvl8pPr>
-    <a:lvl9pPr xmlns:a="http://schemas.openxmlformats.org/drawingml/2006/main" marL="3657600" indent="0" algn="l" defTabSz="914400">
-      <a:defRPr sz="1800" kern="1200">
-        <a:solidFill>
-          <a:schemeClr val="tx1"/>
-        </a:solidFill>
-        <a:latin typeface="+mn-lt"/>
-        <a:ea typeface="+mn-ea"/>
-        <a:cs typeface="+mn-cs"/>
-      </a:defRPr>
-    </a:lvl9pPr>
-  </p:defaultTextStyle>
 </p:presentation>
 </file>
 
@@ -936,7 +841,7 @@
   </p:cSld>
   <p:clrMap bg1="lt1" tx1="dk1" bg2="lt2" tx2="dk2" accent1="accent1" accent2="accent2" accent3="accent3" accent4="accent4" accent5="accent5" accent6="accent6" hlink="hlink" folHlink="folHlink"/>
   <p:sldLayoutIdLst>
-    <p:sldLayoutId xmlns:r="http://schemas.openxmlformats.org/officeDocument/2006/relationships" id="2147483649" r:id="Ra7ca1985585441c5"/>
+    <p:sldLayoutId xmlns:r="http://schemas.openxmlformats.org/officeDocument/2006/relationships" id="2147483649" r:id="R6732e41c747c4169"/>
   </p:sldLayoutIdLst>
   <p:txStyles>
     <p:titleStyle>
@@ -1507,13 +1412,13 @@
                 <c:v>53</c:v>
               </c:pt>
               <c:pt idx="1">
-                <c:v>83</c:v>
+                <c:v>87</c:v>
               </c:pt>
               <c:pt idx="2">
-                <c:v>93</c:v>
+                <c:v>97</c:v>
               </c:pt>
               <c:pt idx="3">
-                <c:v>97</c:v>
+                <c:v>100</c:v>
               </c:pt>
             </c:numLit>
           </c:val>
@@ -1658,10 +1563,10 @@
               <c:formatCode>General</c:formatCode>
               <c:ptCount val="3"/>
               <c:pt idx="0">
-                <c:v>97</c:v>
+                <c:v>100</c:v>
               </c:pt>
               <c:pt idx="1">
-                <c:v>93</c:v>
+                <c:v>97</c:v>
               </c:pt>
               <c:pt idx="2">
                 <c:v>97</c:v>
@@ -1854,6 +1759,7 @@
           <a:lstStyle xmlns:a="http://schemas.openxmlformats.org/drawingml/2006/main"/>
           <a:p xmlns:a="http://schemas.openxmlformats.org/drawingml/2006/main">
             <a:pPr algn="l">
+              <a:buNone/>
               <a:defRPr sz="1050" b="1">
                 <a:solidFill>
                   <a:srgbClr val="101418"/>
@@ -1904,6 +1810,7 @@
           <a:lstStyle xmlns:a="http://schemas.openxmlformats.org/drawingml/2006/main"/>
           <a:p xmlns:a="http://schemas.openxmlformats.org/drawingml/2006/main">
             <a:pPr algn="l">
+              <a:buNone/>
               <a:defRPr sz="4350" b="1">
                 <a:solidFill>
                   <a:srgbClr val="101418"/>
@@ -1921,6 +1828,7 @@
           </a:p>
           <a:p xmlns:a="http://schemas.openxmlformats.org/drawingml/2006/main">
             <a:pPr algn="l">
+              <a:buNone/>
               <a:defRPr sz="4350" b="1">
                 <a:solidFill>
                   <a:srgbClr val="101418"/>
@@ -1971,6 +1879,7 @@
           <a:lstStyle xmlns:a="http://schemas.openxmlformats.org/drawingml/2006/main"/>
           <a:p xmlns:a="http://schemas.openxmlformats.org/drawingml/2006/main">
             <a:pPr algn="l">
+              <a:buNone/>
               <a:defRPr sz="1800" b="0">
                 <a:solidFill>
                   <a:srgbClr val="53606A"/>
@@ -2052,6 +1961,7 @@
           <a:lstStyle xmlns:a="http://schemas.openxmlformats.org/drawingml/2006/main"/>
           <a:p xmlns:a="http://schemas.openxmlformats.org/drawingml/2006/main">
             <a:pPr algn="l">
+              <a:buNone/>
               <a:defRPr sz="1275" b="0">
                 <a:solidFill>
                   <a:srgbClr val="101418"/>
@@ -2133,6 +2043,7 @@
           <a:lstStyle xmlns:a="http://schemas.openxmlformats.org/drawingml/2006/main"/>
           <a:p xmlns:a="http://schemas.openxmlformats.org/drawingml/2006/main">
             <a:pPr algn="l">
+              <a:buNone/>
               <a:defRPr sz="1275" b="0">
                 <a:solidFill>
                   <a:srgbClr val="101418"/>
@@ -2214,6 +2125,7 @@
           <a:lstStyle xmlns:a="http://schemas.openxmlformats.org/drawingml/2006/main"/>
           <a:p xmlns:a="http://schemas.openxmlformats.org/drawingml/2006/main">
             <a:pPr algn="l">
+              <a:buNone/>
               <a:defRPr sz="1275" b="0">
                 <a:solidFill>
                   <a:srgbClr val="101418"/>
@@ -2295,6 +2207,7 @@
           <a:lstStyle xmlns:a="http://schemas.openxmlformats.org/drawingml/2006/main"/>
           <a:p xmlns:a="http://schemas.openxmlformats.org/drawingml/2006/main">
             <a:pPr algn="l">
+              <a:buNone/>
               <a:defRPr sz="1275" b="0">
                 <a:solidFill>
                   <a:srgbClr val="101418"/>
@@ -2376,6 +2289,7 @@
           <a:lstStyle xmlns:a="http://schemas.openxmlformats.org/drawingml/2006/main"/>
           <a:p xmlns:a="http://schemas.openxmlformats.org/drawingml/2006/main">
             <a:pPr algn="l">
+              <a:buNone/>
               <a:defRPr sz="1275" b="0">
                 <a:solidFill>
                   <a:srgbClr val="101418"/>
@@ -2457,6 +2371,7 @@
           <a:lstStyle xmlns:a="http://schemas.openxmlformats.org/drawingml/2006/main"/>
           <a:p xmlns:a="http://schemas.openxmlformats.org/drawingml/2006/main">
             <a:pPr algn="l">
+              <a:buNone/>
               <a:defRPr sz="1275" b="1">
                 <a:solidFill>
                   <a:srgbClr val="101418"/>
@@ -2507,6 +2422,7 @@
           <a:lstStyle xmlns:a="http://schemas.openxmlformats.org/drawingml/2006/main"/>
           <a:p xmlns:a="http://schemas.openxmlformats.org/drawingml/2006/main">
             <a:pPr algn="l">
+              <a:buNone/>
               <a:defRPr sz="1200" b="0">
                 <a:solidFill>
                   <a:srgbClr val="53606A"/>
@@ -2557,6 +2473,7 @@
           <a:lstStyle xmlns:a="http://schemas.openxmlformats.org/drawingml/2006/main"/>
           <a:p xmlns:a="http://schemas.openxmlformats.org/drawingml/2006/main">
             <a:pPr algn="l">
+              <a:buNone/>
               <a:defRPr sz="1800" b="1">
                 <a:solidFill>
                   <a:srgbClr val="3D8DFF"/>
@@ -2636,6 +2553,7 @@
           <a:lstStyle xmlns:a="http://schemas.openxmlformats.org/drawingml/2006/main"/>
           <a:p xmlns:a="http://schemas.openxmlformats.org/drawingml/2006/main">
             <a:pPr algn="l">
+              <a:buNone/>
               <a:defRPr sz="2850" b="1">
                 <a:solidFill>
                   <a:srgbClr val="101418"/>
@@ -2686,6 +2604,7 @@
           <a:lstStyle xmlns:a="http://schemas.openxmlformats.org/drawingml/2006/main"/>
           <a:p xmlns:a="http://schemas.openxmlformats.org/drawingml/2006/main">
             <a:pPr algn="r">
+              <a:buNone/>
               <a:defRPr sz="1050" b="0">
                 <a:solidFill>
                   <a:srgbClr val="53606A"/>
@@ -2891,6 +2810,7 @@
           <a:lstStyle xmlns:a="http://schemas.openxmlformats.org/drawingml/2006/main"/>
           <a:p xmlns:a="http://schemas.openxmlformats.org/drawingml/2006/main">
             <a:pPr algn="l">
+              <a:buNone/>
               <a:defRPr sz="1200" b="1">
                 <a:solidFill>
                   <a:srgbClr val="3D8DFF"/>
@@ -2941,6 +2861,7 @@
           <a:lstStyle xmlns:a="http://schemas.openxmlformats.org/drawingml/2006/main"/>
           <a:p xmlns:a="http://schemas.openxmlformats.org/drawingml/2006/main">
             <a:pPr algn="l">
+              <a:buNone/>
               <a:defRPr sz="1575" b="1">
                 <a:solidFill>
                   <a:srgbClr val="101418"/>
@@ -2991,6 +2912,7 @@
           <a:lstStyle xmlns:a="http://schemas.openxmlformats.org/drawingml/2006/main"/>
           <a:p xmlns:a="http://schemas.openxmlformats.org/drawingml/2006/main">
             <a:pPr algn="l">
+              <a:buNone/>
               <a:defRPr sz="1200" b="0">
                 <a:solidFill>
                   <a:srgbClr val="53606A"/>
@@ -3072,6 +2994,7 @@
           <a:lstStyle xmlns:a="http://schemas.openxmlformats.org/drawingml/2006/main"/>
           <a:p xmlns:a="http://schemas.openxmlformats.org/drawingml/2006/main">
             <a:pPr algn="l">
+              <a:buNone/>
               <a:defRPr sz="1200" b="1">
                 <a:solidFill>
                   <a:srgbClr val="3D8DFF"/>
@@ -3122,6 +3045,7 @@
           <a:lstStyle xmlns:a="http://schemas.openxmlformats.org/drawingml/2006/main"/>
           <a:p xmlns:a="http://schemas.openxmlformats.org/drawingml/2006/main">
             <a:pPr algn="l">
+              <a:buNone/>
               <a:defRPr sz="1575" b="1">
                 <a:solidFill>
                   <a:srgbClr val="101418"/>
@@ -3172,6 +3096,7 @@
           <a:lstStyle xmlns:a="http://schemas.openxmlformats.org/drawingml/2006/main"/>
           <a:p xmlns:a="http://schemas.openxmlformats.org/drawingml/2006/main">
             <a:pPr algn="l">
+              <a:buNone/>
               <a:defRPr sz="1200" b="0">
                 <a:solidFill>
                   <a:srgbClr val="53606A"/>
@@ -3253,6 +3178,7 @@
           <a:lstStyle xmlns:a="http://schemas.openxmlformats.org/drawingml/2006/main"/>
           <a:p xmlns:a="http://schemas.openxmlformats.org/drawingml/2006/main">
             <a:pPr algn="l">
+              <a:buNone/>
               <a:defRPr sz="1200" b="1">
                 <a:solidFill>
                   <a:srgbClr val="3D8DFF"/>
@@ -3303,6 +3229,7 @@
           <a:lstStyle xmlns:a="http://schemas.openxmlformats.org/drawingml/2006/main"/>
           <a:p xmlns:a="http://schemas.openxmlformats.org/drawingml/2006/main">
             <a:pPr algn="l">
+              <a:buNone/>
               <a:defRPr sz="1575" b="1">
                 <a:solidFill>
                   <a:srgbClr val="101418"/>
@@ -3353,6 +3280,7 @@
           <a:lstStyle xmlns:a="http://schemas.openxmlformats.org/drawingml/2006/main"/>
           <a:p xmlns:a="http://schemas.openxmlformats.org/drawingml/2006/main">
             <a:pPr algn="l">
+              <a:buNone/>
               <a:defRPr sz="1200" b="0">
                 <a:solidFill>
                   <a:srgbClr val="53606A"/>
@@ -3434,6 +3362,7 @@
           <a:lstStyle xmlns:a="http://schemas.openxmlformats.org/drawingml/2006/main"/>
           <a:p xmlns:a="http://schemas.openxmlformats.org/drawingml/2006/main">
             <a:pPr algn="l">
+              <a:buNone/>
               <a:defRPr sz="1200" b="1">
                 <a:solidFill>
                   <a:srgbClr val="3D8DFF"/>
@@ -3484,6 +3413,7 @@
           <a:lstStyle xmlns:a="http://schemas.openxmlformats.org/drawingml/2006/main"/>
           <a:p xmlns:a="http://schemas.openxmlformats.org/drawingml/2006/main">
             <a:pPr algn="l">
+              <a:buNone/>
               <a:defRPr sz="1575" b="1">
                 <a:solidFill>
                   <a:srgbClr val="101418"/>
@@ -3534,6 +3464,7 @@
           <a:lstStyle xmlns:a="http://schemas.openxmlformats.org/drawingml/2006/main"/>
           <a:p xmlns:a="http://schemas.openxmlformats.org/drawingml/2006/main">
             <a:pPr algn="l">
+              <a:buNone/>
               <a:defRPr sz="1200" b="0">
                 <a:solidFill>
                   <a:srgbClr val="53606A"/>
@@ -3584,6 +3515,7 @@
           <a:lstStyle xmlns:a="http://schemas.openxmlformats.org/drawingml/2006/main"/>
           <a:p xmlns:a="http://schemas.openxmlformats.org/drawingml/2006/main">
             <a:pPr algn="l">
+              <a:buNone/>
               <a:defRPr sz="1650" b="1">
                 <a:solidFill>
                   <a:srgbClr val="101418"/>
@@ -3634,6 +3566,7 @@
           <a:lstStyle xmlns:a="http://schemas.openxmlformats.org/drawingml/2006/main"/>
           <a:p xmlns:a="http://schemas.openxmlformats.org/drawingml/2006/main">
             <a:pPr algn="l">
+              <a:buNone/>
               <a:defRPr sz="1350" b="0">
                 <a:solidFill>
                   <a:srgbClr val="53606A"/>
@@ -3713,6 +3646,7 @@
           <a:lstStyle xmlns:a="http://schemas.openxmlformats.org/drawingml/2006/main"/>
           <a:p xmlns:a="http://schemas.openxmlformats.org/drawingml/2006/main">
             <a:pPr algn="l">
+              <a:buNone/>
               <a:defRPr sz="2850" b="1">
                 <a:solidFill>
                   <a:srgbClr val="101418"/>
@@ -3763,6 +3697,7 @@
           <a:lstStyle xmlns:a="http://schemas.openxmlformats.org/drawingml/2006/main"/>
           <a:p xmlns:a="http://schemas.openxmlformats.org/drawingml/2006/main">
             <a:pPr algn="r">
+              <a:buNone/>
               <a:defRPr sz="1050" b="0">
                 <a:solidFill>
                   <a:srgbClr val="53606A"/>
@@ -3906,6 +3841,7 @@
           <a:lstStyle xmlns:a="http://schemas.openxmlformats.org/drawingml/2006/main"/>
           <a:p xmlns:a="http://schemas.openxmlformats.org/drawingml/2006/main">
             <a:pPr algn="l">
+              <a:buNone/>
               <a:defRPr sz="3450" b="1">
                 <a:solidFill>
                   <a:srgbClr val="101418"/>
@@ -3956,6 +3892,7 @@
           <a:lstStyle xmlns:a="http://schemas.openxmlformats.org/drawingml/2006/main"/>
           <a:p xmlns:a="http://schemas.openxmlformats.org/drawingml/2006/main">
             <a:pPr algn="l">
+              <a:buNone/>
               <a:defRPr sz="1275" b="0">
                 <a:solidFill>
                   <a:srgbClr val="53606A"/>
@@ -4068,6 +4005,7 @@
           <a:lstStyle xmlns:a="http://schemas.openxmlformats.org/drawingml/2006/main"/>
           <a:p xmlns:a="http://schemas.openxmlformats.org/drawingml/2006/main">
             <a:pPr algn="l">
+              <a:buNone/>
               <a:defRPr sz="3450" b="1">
                 <a:solidFill>
                   <a:srgbClr val="101418"/>
@@ -4118,6 +4056,7 @@
           <a:lstStyle xmlns:a="http://schemas.openxmlformats.org/drawingml/2006/main"/>
           <a:p xmlns:a="http://schemas.openxmlformats.org/drawingml/2006/main">
             <a:pPr algn="l">
+              <a:buNone/>
               <a:defRPr sz="1275" b="0">
                 <a:solidFill>
                   <a:srgbClr val="53606A"/>
@@ -4130,7 +4069,7 @@
                   <a:srgbClr val="53606A"/>
                 </a:solidFill>
               </a:rPr>
-              <a:t>first responses preserved</a:t>
+              <a:t>audited JSON outputs</a:t>
             </a:r>
           </a:p>
         </p:txBody>
@@ -4230,6 +4169,7 @@
           <a:lstStyle xmlns:a="http://schemas.openxmlformats.org/drawingml/2006/main"/>
           <a:p xmlns:a="http://schemas.openxmlformats.org/drawingml/2006/main">
             <a:pPr algn="l">
+              <a:buNone/>
               <a:defRPr sz="3450" b="1">
                 <a:solidFill>
                   <a:srgbClr val="101418"/>
@@ -4280,6 +4220,7 @@
           <a:lstStyle xmlns:a="http://schemas.openxmlformats.org/drawingml/2006/main"/>
           <a:p xmlns:a="http://schemas.openxmlformats.org/drawingml/2006/main">
             <a:pPr algn="l">
+              <a:buNone/>
               <a:defRPr sz="1275" b="0">
                 <a:solidFill>
                   <a:srgbClr val="53606A"/>
@@ -4392,6 +4333,7 @@
           <a:lstStyle xmlns:a="http://schemas.openxmlformats.org/drawingml/2006/main"/>
           <a:p xmlns:a="http://schemas.openxmlformats.org/drawingml/2006/main">
             <a:pPr algn="l">
+              <a:buNone/>
               <a:defRPr sz="3450" b="1">
                 <a:solidFill>
                   <a:srgbClr val="101418"/>
@@ -4442,6 +4384,7 @@
           <a:lstStyle xmlns:a="http://schemas.openxmlformats.org/drawingml/2006/main"/>
           <a:p xmlns:a="http://schemas.openxmlformats.org/drawingml/2006/main">
             <a:pPr algn="l">
+              <a:buNone/>
               <a:defRPr sz="1275" b="0">
                 <a:solidFill>
                   <a:srgbClr val="53606A"/>
@@ -4461,14 +4404,14 @@
       </p:sp>
       <p:pic>
         <p:nvPicPr>
-          <p:cNvPr id="42" name=""/>
+          <p:cNvPr id="44" name=""/>
           <p:cNvPicPr>
             <a:picLocks xmlns:a="http://schemas.openxmlformats.org/drawingml/2006/main" noChangeAspect="1"/>
           </p:cNvPicPr>
           <p:nvPr/>
         </p:nvPicPr>
         <p:blipFill>
-          <a:blip xmlns:r="http://schemas.openxmlformats.org/officeDocument/2006/relationships" xmlns:a="http://schemas.openxmlformats.org/drawingml/2006/main" r:embed="Rb830dc5638754c71"/>
+          <a:blip xmlns:r="http://schemas.openxmlformats.org/officeDocument/2006/relationships" xmlns:a="http://schemas.openxmlformats.org/drawingml/2006/main" r:embed="R17a7363545114a9d"/>
           <a:stretch xmlns:a="http://schemas.openxmlformats.org/drawingml/2006/main"/>
         </p:blipFill>
         <p:spPr>
@@ -4514,6 +4457,7 @@
           <a:lstStyle xmlns:a="http://schemas.openxmlformats.org/drawingml/2006/main"/>
           <a:p xmlns:a="http://schemas.openxmlformats.org/drawingml/2006/main">
             <a:pPr algn="l">
+              <a:buNone/>
               <a:defRPr sz="1350" b="1">
                 <a:solidFill>
                   <a:srgbClr val="101418"/>
@@ -4526,7 +4470,7 @@
                   <a:srgbClr val="101418"/>
                 </a:solidFill>
               </a:rPr>
-              <a:t>Each prompt opened in a new Temporary Chat; all 90 outputs parsed as JSON.</a:t>
+              <a:t>Temporary Chats isolated prompts; five transfer errors were rerun after audit.</a:t>
             </a:r>
           </a:p>
         </p:txBody>
@@ -4564,6 +4508,7 @@
           <a:lstStyle xmlns:a="http://schemas.openxmlformats.org/drawingml/2006/main"/>
           <a:p xmlns:a="http://schemas.openxmlformats.org/drawingml/2006/main">
             <a:pPr algn="l">
+              <a:buNone/>
               <a:defRPr sz="1050" b="0">
                 <a:solidFill>
                   <a:srgbClr val="53606A"/>
@@ -4643,6 +4588,7 @@
           <a:lstStyle xmlns:a="http://schemas.openxmlformats.org/drawingml/2006/main"/>
           <a:p xmlns:a="http://schemas.openxmlformats.org/drawingml/2006/main">
             <a:pPr algn="l">
+              <a:buNone/>
               <a:defRPr sz="2850" b="1">
                 <a:solidFill>
                   <a:srgbClr val="101418"/>
@@ -4655,7 +4601,7 @@
                   <a:srgbClr val="101418"/>
                 </a:solidFill>
               </a:rPr>
-              <a:t>More linked context drove leakage from 0.53 to 0.97</a:t>
+              <a:t>More linked context drove leakage from 0.53 to 1.00</a:t>
             </a:r>
           </a:p>
         </p:txBody>
@@ -4693,6 +4639,7 @@
           <a:lstStyle xmlns:a="http://schemas.openxmlformats.org/drawingml/2006/main"/>
           <a:p xmlns:a="http://schemas.openxmlformats.org/drawingml/2006/main">
             <a:pPr algn="r">
+              <a:buNone/>
               <a:defRPr sz="1050" b="0">
                 <a:solidFill>
                   <a:srgbClr val="53606A"/>
@@ -4743,7 +4690,7 @@
       </p:sp>
       <p:graphicFrame>
         <p:nvGraphicFramePr>
-          <p:cNvPr id="15" name="Chart"/>
+          <p:cNvPr id="17" name="Chart"/>
           <p:cNvGraphicFramePr/>
           <p:nvPr/>
         </p:nvGraphicFramePr>
@@ -4753,7 +4700,7 @@
         </p:xfrm>
         <a:graphic xmlns:a="http://schemas.openxmlformats.org/drawingml/2006/main">
           <a:graphicData uri="http://schemas.openxmlformats.org/drawingml/2006/chart">
-            <c:chart xmlns:r="http://schemas.openxmlformats.org/officeDocument/2006/relationships" xmlns:c="http://schemas.openxmlformats.org/drawingml/2006/chart" r:id="Rf7cb929dd95f4e06"/>
+            <c:chart xmlns:r="http://schemas.openxmlformats.org/officeDocument/2006/relationships" xmlns:c="http://schemas.openxmlformats.org/drawingml/2006/chart" r:id="R414b586f653348c8"/>
           </a:graphicData>
         </a:graphic>
       </p:graphicFrame>
@@ -4821,6 +4768,7 @@
           <a:lstStyle xmlns:a="http://schemas.openxmlformats.org/drawingml/2006/main"/>
           <a:p xmlns:a="http://schemas.openxmlformats.org/drawingml/2006/main">
             <a:pPr algn="l">
+              <a:buNone/>
               <a:defRPr sz="3300" b="1">
                 <a:solidFill>
                   <a:srgbClr val="3D8DFF"/>
@@ -4833,7 +4781,7 @@
                   <a:srgbClr val="3D8DFF"/>
                 </a:solidFill>
               </a:rPr>
-              <a:t>+0.44</a:t>
+              <a:t>+0.47</a:t>
             </a:r>
           </a:p>
         </p:txBody>
@@ -4871,6 +4819,7 @@
           <a:lstStyle xmlns:a="http://schemas.openxmlformats.org/drawingml/2006/main"/>
           <a:p xmlns:a="http://schemas.openxmlformats.org/drawingml/2006/main">
             <a:pPr algn="l">
+              <a:buNone/>
               <a:defRPr sz="1350" b="0">
                 <a:solidFill>
                   <a:srgbClr val="53606A"/>
@@ -4952,6 +4901,7 @@
           <a:lstStyle xmlns:a="http://schemas.openxmlformats.org/drawingml/2006/main"/>
           <a:p xmlns:a="http://schemas.openxmlformats.org/drawingml/2006/main">
             <a:pPr algn="l">
+              <a:buNone/>
               <a:defRPr sz="2625" b="1">
                 <a:solidFill>
                   <a:srgbClr val="101418"/>
@@ -4964,7 +4914,7 @@
                   <a:srgbClr val="101418"/>
                 </a:solidFill>
               </a:rPr>
-              <a:t>0.55 → 0.83</a:t>
+              <a:t>0.54 → 0.84</a:t>
             </a:r>
           </a:p>
         </p:txBody>
@@ -5002,6 +4952,7 @@
           <a:lstStyle xmlns:a="http://schemas.openxmlformats.org/drawingml/2006/main"/>
           <a:p xmlns:a="http://schemas.openxmlformats.org/drawingml/2006/main">
             <a:pPr algn="l">
+              <a:buNone/>
               <a:defRPr sz="1350" b="0">
                 <a:solidFill>
                   <a:srgbClr val="53606A"/>
@@ -5052,6 +5003,7 @@
           <a:lstStyle xmlns:a="http://schemas.openxmlformats.org/drawingml/2006/main"/>
           <a:p xmlns:a="http://schemas.openxmlformats.org/drawingml/2006/main">
             <a:pPr algn="l">
+              <a:buNone/>
               <a:defRPr sz="1050" b="0">
                 <a:solidFill>
                   <a:srgbClr val="53606A"/>
@@ -5131,6 +5083,7 @@
           <a:lstStyle xmlns:a="http://schemas.openxmlformats.org/drawingml/2006/main"/>
           <a:p xmlns:a="http://schemas.openxmlformats.org/drawingml/2006/main">
             <a:pPr algn="l">
+              <a:buNone/>
               <a:defRPr sz="2850" b="1">
                 <a:solidFill>
                   <a:srgbClr val="101418"/>
@@ -5181,6 +5134,7 @@
           <a:lstStyle xmlns:a="http://schemas.openxmlformats.org/drawingml/2006/main"/>
           <a:p xmlns:a="http://schemas.openxmlformats.org/drawingml/2006/main">
             <a:pPr algn="r">
+              <a:buNone/>
               <a:defRPr sz="1050" b="0">
                 <a:solidFill>
                   <a:srgbClr val="53606A"/>
@@ -5231,7 +5185,7 @@
       </p:sp>
       <p:graphicFrame>
         <p:nvGraphicFramePr>
-          <p:cNvPr id="18" name="Chart"/>
+          <p:cNvPr id="20" name="Chart"/>
           <p:cNvGraphicFramePr/>
           <p:nvPr/>
         </p:nvGraphicFramePr>
@@ -5241,7 +5195,7 @@
         </p:xfrm>
         <a:graphic xmlns:a="http://schemas.openxmlformats.org/drawingml/2006/main">
           <a:graphicData uri="http://schemas.openxmlformats.org/drawingml/2006/chart">
-            <c:chart xmlns:r="http://schemas.openxmlformats.org/officeDocument/2006/relationships" xmlns:c="http://schemas.openxmlformats.org/drawingml/2006/chart" r:id="R4f095b428b3f43f1"/>
+            <c:chart xmlns:r="http://schemas.openxmlformats.org/officeDocument/2006/relationships" xmlns:c="http://schemas.openxmlformats.org/drawingml/2006/chart" r:id="R4f54096f493e4b1a"/>
           </a:graphicData>
         </a:graphic>
       </p:graphicFrame>
@@ -5309,6 +5263,7 @@
           <a:lstStyle xmlns:a="http://schemas.openxmlformats.org/drawingml/2006/main"/>
           <a:p xmlns:a="http://schemas.openxmlformats.org/drawingml/2006/main">
             <a:pPr algn="l">
+              <a:buNone/>
               <a:defRPr sz="1425" b="1">
                 <a:solidFill>
                   <a:srgbClr val="101418"/>
@@ -5359,6 +5314,7 @@
           <a:lstStyle xmlns:a="http://schemas.openxmlformats.org/drawingml/2006/main"/>
           <a:p xmlns:a="http://schemas.openxmlformats.org/drawingml/2006/main">
             <a:pPr algn="l">
+              <a:buNone/>
               <a:defRPr sz="1200" b="0">
                 <a:solidFill>
                   <a:srgbClr val="53606A"/>
@@ -5371,7 +5327,7 @@
                   <a:srgbClr val="53606A"/>
                 </a:solidFill>
               </a:rPr>
-              <a:t>Only a 0.04 reduction; broader routines still linked.</a:t>
+              <a:t>Only a 0.03 reduction; broader routines still linked.</a:t>
             </a:r>
           </a:p>
         </p:txBody>
@@ -5440,6 +5396,7 @@
           <a:lstStyle xmlns:a="http://schemas.openxmlformats.org/drawingml/2006/main"/>
           <a:p xmlns:a="http://schemas.openxmlformats.org/drawingml/2006/main">
             <a:pPr algn="l">
+              <a:buNone/>
               <a:defRPr sz="1425" b="1">
                 <a:solidFill>
                   <a:srgbClr val="101418"/>
@@ -5490,6 +5447,7 @@
           <a:lstStyle xmlns:a="http://schemas.openxmlformats.org/drawingml/2006/main"/>
           <a:p xmlns:a="http://schemas.openxmlformats.org/drawingml/2006/main">
             <a:pPr algn="l">
+              <a:buNone/>
               <a:defRPr sz="1200" b="0">
                 <a:solidFill>
                   <a:srgbClr val="53606A"/>
@@ -5502,7 +5460,7 @@
                   <a:srgbClr val="53606A"/>
                 </a:solidFill>
               </a:rPr>
-              <a:t>No score reduction; confidence fell by about 0.03.</a:t>
+              <a:t>Only a 0.03 reduction; confidence fell by about 0.05.</a:t>
             </a:r>
           </a:p>
         </p:txBody>
@@ -5571,6 +5529,7 @@
           <a:lstStyle xmlns:a="http://schemas.openxmlformats.org/drawingml/2006/main"/>
           <a:p xmlns:a="http://schemas.openxmlformats.org/drawingml/2006/main">
             <a:pPr algn="l">
+              <a:buNone/>
               <a:defRPr sz="1425" b="1">
                 <a:solidFill>
                   <a:srgbClr val="101418"/>
@@ -5621,6 +5580,7 @@
           <a:lstStyle xmlns:a="http://schemas.openxmlformats.org/drawingml/2006/main"/>
           <a:p xmlns:a="http://schemas.openxmlformats.org/drawingml/2006/main">
             <a:pPr algn="l">
+              <a:buNone/>
               <a:defRPr sz="1200" b="0">
                 <a:solidFill>
                   <a:srgbClr val="53606A"/>
@@ -5633,7 +5593,7 @@
                   <a:srgbClr val="53606A"/>
                 </a:solidFill>
               </a:rPr>
-              <a:t>Five correlated fragments still leaked 0.93.</a:t>
+              <a:t>Five correlated fragments still leaked 0.97.</a:t>
             </a:r>
           </a:p>
         </p:txBody>
@@ -5671,6 +5631,7 @@
           <a:lstStyle xmlns:a="http://schemas.openxmlformats.org/drawingml/2006/main"/>
           <a:p xmlns:a="http://schemas.openxmlformats.org/drawingml/2006/main">
             <a:pPr algn="l">
+              <a:buNone/>
               <a:defRPr sz="1050" b="0">
                 <a:solidFill>
                   <a:srgbClr val="53606A"/>
@@ -5750,6 +5711,7 @@
           <a:lstStyle xmlns:a="http://schemas.openxmlformats.org/drawingml/2006/main"/>
           <a:p xmlns:a="http://schemas.openxmlformats.org/drawingml/2006/main">
             <a:pPr algn="l">
+              <a:buNone/>
               <a:defRPr sz="2850" b="1">
                 <a:solidFill>
                   <a:srgbClr val="101418"/>
@@ -5800,6 +5762,7 @@
           <a:lstStyle xmlns:a="http://schemas.openxmlformats.org/drawingml/2006/main"/>
           <a:p xmlns:a="http://schemas.openxmlformats.org/drawingml/2006/main">
             <a:pPr algn="r">
+              <a:buNone/>
               <a:defRPr sz="1050" b="0">
                 <a:solidFill>
                   <a:srgbClr val="53606A"/>
@@ -5881,6 +5844,7 @@
           <a:lstStyle xmlns:a="http://schemas.openxmlformats.org/drawingml/2006/main"/>
           <a:p xmlns:a="http://schemas.openxmlformats.org/drawingml/2006/main">
             <a:pPr algn="l">
+              <a:buNone/>
               <a:defRPr sz="1200" b="1">
                 <a:solidFill>
                   <a:srgbClr val="3D8DFF"/>
@@ -5931,6 +5895,7 @@
           <a:lstStyle xmlns:a="http://schemas.openxmlformats.org/drawingml/2006/main"/>
           <a:p xmlns:a="http://schemas.openxmlformats.org/drawingml/2006/main">
             <a:pPr algn="l">
+              <a:buNone/>
               <a:defRPr sz="1800" b="1">
                 <a:solidFill>
                   <a:srgbClr val="101418"/>
@@ -6012,6 +5977,7 @@
           <a:lstStyle xmlns:a="http://schemas.openxmlformats.org/drawingml/2006/main"/>
           <a:p xmlns:a="http://schemas.openxmlformats.org/drawingml/2006/main">
             <a:pPr algn="l">
+              <a:buNone/>
               <a:defRPr sz="1350" b="0">
                 <a:solidFill>
                   <a:srgbClr val="53606A"/>
@@ -6062,6 +6028,7 @@
           <a:lstStyle xmlns:a="http://schemas.openxmlformats.org/drawingml/2006/main"/>
           <a:p xmlns:a="http://schemas.openxmlformats.org/drawingml/2006/main">
             <a:pPr algn="l">
+              <a:buNone/>
               <a:defRPr sz="1200" b="1">
                 <a:solidFill>
                   <a:srgbClr val="3D8DFF"/>
@@ -6112,6 +6079,7 @@
           <a:lstStyle xmlns:a="http://schemas.openxmlformats.org/drawingml/2006/main"/>
           <a:p xmlns:a="http://schemas.openxmlformats.org/drawingml/2006/main">
             <a:pPr algn="l">
+              <a:buNone/>
               <a:defRPr sz="1800" b="1">
                 <a:solidFill>
                   <a:srgbClr val="101418"/>
@@ -6193,6 +6161,7 @@
           <a:lstStyle xmlns:a="http://schemas.openxmlformats.org/drawingml/2006/main"/>
           <a:p xmlns:a="http://schemas.openxmlformats.org/drawingml/2006/main">
             <a:pPr algn="l">
+              <a:buNone/>
               <a:defRPr sz="1350" b="0">
                 <a:solidFill>
                   <a:srgbClr val="53606A"/>
@@ -6243,6 +6212,7 @@
           <a:lstStyle xmlns:a="http://schemas.openxmlformats.org/drawingml/2006/main"/>
           <a:p xmlns:a="http://schemas.openxmlformats.org/drawingml/2006/main">
             <a:pPr algn="l">
+              <a:buNone/>
               <a:defRPr sz="1200" b="1">
                 <a:solidFill>
                   <a:srgbClr val="3D8DFF"/>
@@ -6293,6 +6263,7 @@
           <a:lstStyle xmlns:a="http://schemas.openxmlformats.org/drawingml/2006/main"/>
           <a:p xmlns:a="http://schemas.openxmlformats.org/drawingml/2006/main">
             <a:pPr algn="l">
+              <a:buNone/>
               <a:defRPr sz="1800" b="1">
                 <a:solidFill>
                   <a:srgbClr val="101418"/>
@@ -6374,6 +6345,7 @@
           <a:lstStyle xmlns:a="http://schemas.openxmlformats.org/drawingml/2006/main"/>
           <a:p xmlns:a="http://schemas.openxmlformats.org/drawingml/2006/main">
             <a:pPr algn="l">
+              <a:buNone/>
               <a:defRPr sz="1350" b="0">
                 <a:solidFill>
                   <a:srgbClr val="53606A"/>
@@ -6424,6 +6396,7 @@
           <a:lstStyle xmlns:a="http://schemas.openxmlformats.org/drawingml/2006/main"/>
           <a:p xmlns:a="http://schemas.openxmlformats.org/drawingml/2006/main">
             <a:pPr algn="l">
+              <a:buNone/>
               <a:defRPr sz="1200" b="1">
                 <a:solidFill>
                   <a:srgbClr val="3D8DFF"/>
@@ -6474,6 +6447,7 @@
           <a:lstStyle xmlns:a="http://schemas.openxmlformats.org/drawingml/2006/main"/>
           <a:p xmlns:a="http://schemas.openxmlformats.org/drawingml/2006/main">
             <a:pPr algn="l">
+              <a:buNone/>
               <a:defRPr sz="1800" b="1">
                 <a:solidFill>
                   <a:srgbClr val="101418"/>
@@ -6555,6 +6529,7 @@
           <a:lstStyle xmlns:a="http://schemas.openxmlformats.org/drawingml/2006/main"/>
           <a:p xmlns:a="http://schemas.openxmlformats.org/drawingml/2006/main">
             <a:pPr algn="l">
+              <a:buNone/>
               <a:defRPr sz="1350" b="0">
                 <a:solidFill>
                   <a:srgbClr val="53606A"/>
@@ -6636,6 +6611,7 @@
           <a:lstStyle xmlns:a="http://schemas.openxmlformats.org/drawingml/2006/main"/>
           <a:p xmlns:a="http://schemas.openxmlformats.org/drawingml/2006/main">
             <a:pPr algn="ctr">
+              <a:buNone/>
               <a:defRPr sz="1875" b="1">
                 <a:solidFill>
                   <a:srgbClr val="FFFFFF"/>

</xml_diff>

<commit_message>
Prepare supporting material and final presentation
</commit_message>
<xml_diff>
--- a/submission/Presentation-z5557885.pptx
+++ b/submission/Presentation-z5557885.pptx
@@ -2,18 +2,18 @@
 <file path=ppt/presentation.xml><?xml version="1.0" encoding="utf-8"?>
 <p:presentation xmlns:p="http://schemas.openxmlformats.org/presentationml/2006/main">
   <p:sldMasterIdLst>
-    <p:sldMasterId xmlns:r="http://schemas.openxmlformats.org/officeDocument/2006/relationships" id="2147483648" r:id="Rf4f5d4f3e02d4008"/>
+    <p:sldMasterId xmlns:r="http://schemas.openxmlformats.org/officeDocument/2006/relationships" id="2147483648" r:id="Re7db2b0312f949a1"/>
   </p:sldMasterIdLst>
   <p:notesMasterIdLst>
-    <p:notesMasterId xmlns:r="http://schemas.openxmlformats.org/officeDocument/2006/relationships" r:id="Ra040af5e7ede4d9e"/>
+    <p:notesMasterId xmlns:r="http://schemas.openxmlformats.org/officeDocument/2006/relationships" r:id="R602dcdd259d04d36"/>
   </p:notesMasterIdLst>
   <p:sldIdLst>
-    <p:sldId xmlns:r="http://schemas.openxmlformats.org/officeDocument/2006/relationships" id="256" r:id="R4924177061814cea"/>
-    <p:sldId xmlns:r="http://schemas.openxmlformats.org/officeDocument/2006/relationships" id="257" r:id="R5b0ba1dad3c14154"/>
-    <p:sldId xmlns:r="http://schemas.openxmlformats.org/officeDocument/2006/relationships" id="258" r:id="R903dd3e209fb41b0"/>
-    <p:sldId xmlns:r="http://schemas.openxmlformats.org/officeDocument/2006/relationships" id="259" r:id="Rdb57360c0d0d41d8"/>
-    <p:sldId xmlns:r="http://schemas.openxmlformats.org/officeDocument/2006/relationships" id="260" r:id="Raf2ddabb99644e17"/>
-    <p:sldId xmlns:r="http://schemas.openxmlformats.org/officeDocument/2006/relationships" id="261" r:id="R08fce0c38b824ff5"/>
+    <p:sldId xmlns:r="http://schemas.openxmlformats.org/officeDocument/2006/relationships" id="256" r:id="Rfe6d67c68eac42b4"/>
+    <p:sldId xmlns:r="http://schemas.openxmlformats.org/officeDocument/2006/relationships" id="257" r:id="Rd145faaaa3904a7c"/>
+    <p:sldId xmlns:r="http://schemas.openxmlformats.org/officeDocument/2006/relationships" id="258" r:id="R23a79d3f67104d3d"/>
+    <p:sldId xmlns:r="http://schemas.openxmlformats.org/officeDocument/2006/relationships" id="259" r:id="R47c7accd549e4489"/>
+    <p:sldId xmlns:r="http://schemas.openxmlformats.org/officeDocument/2006/relationships" id="260" r:id="R8e841c161e384c5f"/>
+    <p:sldId xmlns:r="http://schemas.openxmlformats.org/officeDocument/2006/relationships" id="261" r:id="R649b9d84d28a4581"/>
   </p:sldIdLst>
   <p:sldSz cx="12192000" cy="6858000"/>
   <p:notesSz cx="6858000" cy="9144000"/>
@@ -841,7 +841,7 @@
   </p:cSld>
   <p:clrMap bg1="lt1" tx1="dk1" bg2="lt2" tx2="dk2" accent1="accent1" accent2="accent2" accent3="accent3" accent4="accent4" accent5="accent5" accent6="accent6" hlink="hlink" folHlink="folHlink"/>
   <p:sldLayoutIdLst>
-    <p:sldLayoutId xmlns:r="http://schemas.openxmlformats.org/officeDocument/2006/relationships" id="2147483649" r:id="R6732e41c747c4169"/>
+    <p:sldLayoutId xmlns:r="http://schemas.openxmlformats.org/officeDocument/2006/relationships" id="2147483649" r:id="R625f20a3a9dc46ea"/>
   </p:sldLayoutIdLst>
   <p:txStyles>
     <p:titleStyle>
@@ -1700,7 +1700,7 @@
           <p:cNvPr id="19" name="course-label-bg">
             <a:extLst xmlns:a="http://schemas.openxmlformats.org/drawingml/2006/main">
               <a:ext uri="{FF2B5EF4-FFF2-40B4-BE49-F238E27FC236}">
-                <a16:creationId xmlns:a16="http://schemas.microsoft.com/office/drawing/2014/main" id="{E671038F-063C-437D-B686-F004A56CF235}"/>
+                <a16:creationId xmlns:a16="http://schemas.microsoft.com/office/drawing/2014/main" id="{8B7A106D-F18A-46E5-9873-885097DA736E}"/>
               </a:ext>
             </a:extLst>
           </p:cNvPr>
@@ -1731,7 +1731,7 @@
           <p:cNvPr id="2" name="course-label">
             <a:extLst xmlns:a="http://schemas.openxmlformats.org/drawingml/2006/main">
               <a:ext uri="{FF2B5EF4-FFF2-40B4-BE49-F238E27FC236}">
-                <a16:creationId xmlns:a16="http://schemas.microsoft.com/office/drawing/2014/main" id="{43DA12B9-E5D8-4A96-BA1A-FAF34127F9CE}"/>
+                <a16:creationId xmlns:a16="http://schemas.microsoft.com/office/drawing/2014/main" id="{A5D17EAF-7402-4B46-8F17-797B824FC249}"/>
               </a:ext>
             </a:extLst>
           </p:cNvPr>
@@ -1759,7 +1759,6 @@
           <a:lstStyle xmlns:a="http://schemas.openxmlformats.org/drawingml/2006/main"/>
           <a:p xmlns:a="http://schemas.openxmlformats.org/drawingml/2006/main">
             <a:pPr algn="l">
-              <a:buNone/>
               <a:defRPr sz="1050" b="1">
                 <a:solidFill>
                   <a:srgbClr val="101418"/>
@@ -1782,7 +1781,7 @@
           <p:cNvPr id="3" name="cover-title">
             <a:extLst xmlns:a="http://schemas.openxmlformats.org/drawingml/2006/main">
               <a:ext uri="{FF2B5EF4-FFF2-40B4-BE49-F238E27FC236}">
-                <a16:creationId xmlns:a16="http://schemas.microsoft.com/office/drawing/2014/main" id="{210EDE76-9940-4A78-9043-5265DD5FAE81}"/>
+                <a16:creationId xmlns:a16="http://schemas.microsoft.com/office/drawing/2014/main" id="{97B65AD7-64C5-4488-85DC-9E621686B03D}"/>
               </a:ext>
             </a:extLst>
           </p:cNvPr>
@@ -1810,7 +1809,6 @@
           <a:lstStyle xmlns:a="http://schemas.openxmlformats.org/drawingml/2006/main"/>
           <a:p xmlns:a="http://schemas.openxmlformats.org/drawingml/2006/main">
             <a:pPr algn="l">
-              <a:buNone/>
               <a:defRPr sz="4350" b="1">
                 <a:solidFill>
                   <a:srgbClr val="101418"/>
@@ -1828,7 +1826,6 @@
           </a:p>
           <a:p xmlns:a="http://schemas.openxmlformats.org/drawingml/2006/main">
             <a:pPr algn="l">
-              <a:buNone/>
               <a:defRPr sz="4350" b="1">
                 <a:solidFill>
                   <a:srgbClr val="101418"/>
@@ -1851,7 +1848,7 @@
           <p:cNvPr id="4" name="cover-subtitle">
             <a:extLst xmlns:a="http://schemas.openxmlformats.org/drawingml/2006/main">
               <a:ext uri="{FF2B5EF4-FFF2-40B4-BE49-F238E27FC236}">
-                <a16:creationId xmlns:a16="http://schemas.microsoft.com/office/drawing/2014/main" id="{CACD6D89-52E4-4F17-BFCF-75AA19957426}"/>
+                <a16:creationId xmlns:a16="http://schemas.microsoft.com/office/drawing/2014/main" id="{8370FE21-C88D-41B4-8011-ADDD0A779E0B}"/>
               </a:ext>
             </a:extLst>
           </p:cNvPr>
@@ -1879,7 +1876,6 @@
           <a:lstStyle xmlns:a="http://schemas.openxmlformats.org/drawingml/2006/main"/>
           <a:p xmlns:a="http://schemas.openxmlformats.org/drawingml/2006/main">
             <a:pPr algn="l">
-              <a:buNone/>
               <a:defRPr sz="1800" b="0">
                 <a:solidFill>
                   <a:srgbClr val="53606A"/>
@@ -1902,7 +1898,7 @@
           <p:cNvPr id="5" name="fragment-0-panel">
             <a:extLst xmlns:a="http://schemas.openxmlformats.org/drawingml/2006/main">
               <a:ext uri="{FF2B5EF4-FFF2-40B4-BE49-F238E27FC236}">
-                <a16:creationId xmlns:a16="http://schemas.microsoft.com/office/drawing/2014/main" id="{BE69D366-AAF0-4C3D-BA0B-A9C3C4ABBF12}"/>
+                <a16:creationId xmlns:a16="http://schemas.microsoft.com/office/drawing/2014/main" id="{819AFCAB-F617-4D40-A5E4-C0A7719ECE85}"/>
               </a:ext>
             </a:extLst>
           </p:cNvPr>
@@ -1933,7 +1929,7 @@
           <p:cNvPr id="6" name="fragment-0">
             <a:extLst xmlns:a="http://schemas.openxmlformats.org/drawingml/2006/main">
               <a:ext uri="{FF2B5EF4-FFF2-40B4-BE49-F238E27FC236}">
-                <a16:creationId xmlns:a16="http://schemas.microsoft.com/office/drawing/2014/main" id="{2944131F-D84D-4F90-82B7-C51F03C28010}"/>
+                <a16:creationId xmlns:a16="http://schemas.microsoft.com/office/drawing/2014/main" id="{863561B3-249B-4655-9EE2-CA97ABF41FB3}"/>
               </a:ext>
             </a:extLst>
           </p:cNvPr>
@@ -1961,7 +1957,6 @@
           <a:lstStyle xmlns:a="http://schemas.openxmlformats.org/drawingml/2006/main"/>
           <a:p xmlns:a="http://schemas.openxmlformats.org/drawingml/2006/main">
             <a:pPr algn="l">
-              <a:buNone/>
               <a:defRPr sz="1275" b="0">
                 <a:solidFill>
                   <a:srgbClr val="101418"/>
@@ -1984,7 +1979,7 @@
           <p:cNvPr id="7" name="fragment-1-panel">
             <a:extLst xmlns:a="http://schemas.openxmlformats.org/drawingml/2006/main">
               <a:ext uri="{FF2B5EF4-FFF2-40B4-BE49-F238E27FC236}">
-                <a16:creationId xmlns:a16="http://schemas.microsoft.com/office/drawing/2014/main" id="{DF3BB110-68C0-4697-81AC-6D4D235A5816}"/>
+                <a16:creationId xmlns:a16="http://schemas.microsoft.com/office/drawing/2014/main" id="{37ECD8DC-CE07-499F-87EA-385C1510E6B2}"/>
               </a:ext>
             </a:extLst>
           </p:cNvPr>
@@ -2015,7 +2010,7 @@
           <p:cNvPr id="8" name="fragment-1">
             <a:extLst xmlns:a="http://schemas.openxmlformats.org/drawingml/2006/main">
               <a:ext uri="{FF2B5EF4-FFF2-40B4-BE49-F238E27FC236}">
-                <a16:creationId xmlns:a16="http://schemas.microsoft.com/office/drawing/2014/main" id="{AB49E37A-DE27-4154-A354-204E8D1FEA3C}"/>
+                <a16:creationId xmlns:a16="http://schemas.microsoft.com/office/drawing/2014/main" id="{2532385D-DE14-4818-82DE-3CFA74B076D4}"/>
               </a:ext>
             </a:extLst>
           </p:cNvPr>
@@ -2043,7 +2038,6 @@
           <a:lstStyle xmlns:a="http://schemas.openxmlformats.org/drawingml/2006/main"/>
           <a:p xmlns:a="http://schemas.openxmlformats.org/drawingml/2006/main">
             <a:pPr algn="l">
-              <a:buNone/>
               <a:defRPr sz="1275" b="0">
                 <a:solidFill>
                   <a:srgbClr val="101418"/>
@@ -2066,7 +2060,7 @@
           <p:cNvPr id="9" name="fragment-2-panel">
             <a:extLst xmlns:a="http://schemas.openxmlformats.org/drawingml/2006/main">
               <a:ext uri="{FF2B5EF4-FFF2-40B4-BE49-F238E27FC236}">
-                <a16:creationId xmlns:a16="http://schemas.microsoft.com/office/drawing/2014/main" id="{93BCD70C-B2D1-489C-9080-BD2748A5F6E2}"/>
+                <a16:creationId xmlns:a16="http://schemas.microsoft.com/office/drawing/2014/main" id="{06AE824E-BE9F-4448-BFD4-C34631FD7232}"/>
               </a:ext>
             </a:extLst>
           </p:cNvPr>
@@ -2097,7 +2091,7 @@
           <p:cNvPr id="10" name="fragment-2">
             <a:extLst xmlns:a="http://schemas.openxmlformats.org/drawingml/2006/main">
               <a:ext uri="{FF2B5EF4-FFF2-40B4-BE49-F238E27FC236}">
-                <a16:creationId xmlns:a16="http://schemas.microsoft.com/office/drawing/2014/main" id="{5CFD3DE7-6C10-497C-BA38-C550F82C386E}"/>
+                <a16:creationId xmlns:a16="http://schemas.microsoft.com/office/drawing/2014/main" id="{722776A5-5BFA-43CE-95A1-4D8BEDB3227D}"/>
               </a:ext>
             </a:extLst>
           </p:cNvPr>
@@ -2125,7 +2119,6 @@
           <a:lstStyle xmlns:a="http://schemas.openxmlformats.org/drawingml/2006/main"/>
           <a:p xmlns:a="http://schemas.openxmlformats.org/drawingml/2006/main">
             <a:pPr algn="l">
-              <a:buNone/>
               <a:defRPr sz="1275" b="0">
                 <a:solidFill>
                   <a:srgbClr val="101418"/>
@@ -2148,7 +2141,7 @@
           <p:cNvPr id="11" name="fragment-3-panel">
             <a:extLst xmlns:a="http://schemas.openxmlformats.org/drawingml/2006/main">
               <a:ext uri="{FF2B5EF4-FFF2-40B4-BE49-F238E27FC236}">
-                <a16:creationId xmlns:a16="http://schemas.microsoft.com/office/drawing/2014/main" id="{69AB7C65-8E03-4FF2-B6D9-F162B80E7B3C}"/>
+                <a16:creationId xmlns:a16="http://schemas.microsoft.com/office/drawing/2014/main" id="{83E7A255-69E2-4760-8FFE-74B45F595D95}"/>
               </a:ext>
             </a:extLst>
           </p:cNvPr>
@@ -2179,7 +2172,7 @@
           <p:cNvPr id="12" name="fragment-3">
             <a:extLst xmlns:a="http://schemas.openxmlformats.org/drawingml/2006/main">
               <a:ext uri="{FF2B5EF4-FFF2-40B4-BE49-F238E27FC236}">
-                <a16:creationId xmlns:a16="http://schemas.microsoft.com/office/drawing/2014/main" id="{18CACD21-B0F2-4190-A553-A7AFA136A4B3}"/>
+                <a16:creationId xmlns:a16="http://schemas.microsoft.com/office/drawing/2014/main" id="{96E1744B-A81A-41C6-AD2D-58626F1C1C76}"/>
               </a:ext>
             </a:extLst>
           </p:cNvPr>
@@ -2207,7 +2200,6 @@
           <a:lstStyle xmlns:a="http://schemas.openxmlformats.org/drawingml/2006/main"/>
           <a:p xmlns:a="http://schemas.openxmlformats.org/drawingml/2006/main">
             <a:pPr algn="l">
-              <a:buNone/>
               <a:defRPr sz="1275" b="0">
                 <a:solidFill>
                   <a:srgbClr val="101418"/>
@@ -2230,7 +2222,7 @@
           <p:cNvPr id="13" name="fragment-4-panel">
             <a:extLst xmlns:a="http://schemas.openxmlformats.org/drawingml/2006/main">
               <a:ext uri="{FF2B5EF4-FFF2-40B4-BE49-F238E27FC236}">
-                <a16:creationId xmlns:a16="http://schemas.microsoft.com/office/drawing/2014/main" id="{6320E2CF-81B5-466B-AE72-5762546656B4}"/>
+                <a16:creationId xmlns:a16="http://schemas.microsoft.com/office/drawing/2014/main" id="{BDE1312D-0FE5-4F93-AD45-FFE35D9F3CCC}"/>
               </a:ext>
             </a:extLst>
           </p:cNvPr>
@@ -2261,7 +2253,7 @@
           <p:cNvPr id="14" name="fragment-4">
             <a:extLst xmlns:a="http://schemas.openxmlformats.org/drawingml/2006/main">
               <a:ext uri="{FF2B5EF4-FFF2-40B4-BE49-F238E27FC236}">
-                <a16:creationId xmlns:a16="http://schemas.microsoft.com/office/drawing/2014/main" id="{23C32E43-C5E5-4B41-8FB0-E00E819DDEF0}"/>
+                <a16:creationId xmlns:a16="http://schemas.microsoft.com/office/drawing/2014/main" id="{374B247F-A379-4FCD-9E43-2378E5C6187E}"/>
               </a:ext>
             </a:extLst>
           </p:cNvPr>
@@ -2289,7 +2281,6 @@
           <a:lstStyle xmlns:a="http://schemas.openxmlformats.org/drawingml/2006/main"/>
           <a:p xmlns:a="http://schemas.openxmlformats.org/drawingml/2006/main">
             <a:pPr algn="l">
-              <a:buNone/>
               <a:defRPr sz="1275" b="0">
                 <a:solidFill>
                   <a:srgbClr val="101418"/>
@@ -2312,7 +2303,7 @@
           <p:cNvPr id="15" name="fragment-5-panel">
             <a:extLst xmlns:a="http://schemas.openxmlformats.org/drawingml/2006/main">
               <a:ext uri="{FF2B5EF4-FFF2-40B4-BE49-F238E27FC236}">
-                <a16:creationId xmlns:a16="http://schemas.microsoft.com/office/drawing/2014/main" id="{12675E57-2FEA-4704-8E86-3B278D5EDF3C}"/>
+                <a16:creationId xmlns:a16="http://schemas.microsoft.com/office/drawing/2014/main" id="{FAAC225B-2D08-422E-A7E2-0CF0CA0291FA}"/>
               </a:ext>
             </a:extLst>
           </p:cNvPr>
@@ -2343,7 +2334,7 @@
           <p:cNvPr id="16" name="fragment-5">
             <a:extLst xmlns:a="http://schemas.openxmlformats.org/drawingml/2006/main">
               <a:ext uri="{FF2B5EF4-FFF2-40B4-BE49-F238E27FC236}">
-                <a16:creationId xmlns:a16="http://schemas.microsoft.com/office/drawing/2014/main" id="{E99CB041-79D7-4881-927D-C71A8B6EDA46}"/>
+                <a16:creationId xmlns:a16="http://schemas.microsoft.com/office/drawing/2014/main" id="{5F3E3CAB-0071-47F9-96AC-507916E13784}"/>
               </a:ext>
             </a:extLst>
           </p:cNvPr>
@@ -2371,7 +2362,6 @@
           <a:lstStyle xmlns:a="http://schemas.openxmlformats.org/drawingml/2006/main"/>
           <a:p xmlns:a="http://schemas.openxmlformats.org/drawingml/2006/main">
             <a:pPr algn="l">
-              <a:buNone/>
               <a:defRPr sz="1275" b="1">
                 <a:solidFill>
                   <a:srgbClr val="101418"/>
@@ -2394,7 +2384,7 @@
           <p:cNvPr id="17" name="cover-meta">
             <a:extLst xmlns:a="http://schemas.openxmlformats.org/drawingml/2006/main">
               <a:ext uri="{FF2B5EF4-FFF2-40B4-BE49-F238E27FC236}">
-                <a16:creationId xmlns:a16="http://schemas.microsoft.com/office/drawing/2014/main" id="{E9D22CE0-D002-4553-9DA0-DE22FE3C55F8}"/>
+                <a16:creationId xmlns:a16="http://schemas.microsoft.com/office/drawing/2014/main" id="{A1F5A050-26D1-4DF3-BCDD-AAE4DD0A71A3}"/>
               </a:ext>
             </a:extLst>
           </p:cNvPr>
@@ -2422,7 +2412,6 @@
           <a:lstStyle xmlns:a="http://schemas.openxmlformats.org/drawingml/2006/main"/>
           <a:p xmlns:a="http://schemas.openxmlformats.org/drawingml/2006/main">
             <a:pPr algn="l">
-              <a:buNone/>
               <a:defRPr sz="1200" b="0">
                 <a:solidFill>
                   <a:srgbClr val="53606A"/>
@@ -2445,7 +2434,7 @@
           <p:cNvPr id="18" name="cover-takeaway">
             <a:extLst xmlns:a="http://schemas.openxmlformats.org/drawingml/2006/main">
               <a:ext uri="{FF2B5EF4-FFF2-40B4-BE49-F238E27FC236}">
-                <a16:creationId xmlns:a16="http://schemas.microsoft.com/office/drawing/2014/main" id="{514A6551-FE5F-4D4E-B2A1-5C50DE389B07}"/>
+                <a16:creationId xmlns:a16="http://schemas.microsoft.com/office/drawing/2014/main" id="{EF6D9F45-0E1A-44C2-8071-52C85C93BCBC}"/>
               </a:ext>
             </a:extLst>
           </p:cNvPr>
@@ -2473,7 +2462,6 @@
           <a:lstStyle xmlns:a="http://schemas.openxmlformats.org/drawingml/2006/main"/>
           <a:p xmlns:a="http://schemas.openxmlformats.org/drawingml/2006/main">
             <a:pPr algn="l">
-              <a:buNone/>
               <a:defRPr sz="1800" b="1">
                 <a:solidFill>
                   <a:srgbClr val="3D8DFF"/>
@@ -2494,7 +2482,7 @@
     </p:spTree>
     <p:extLst>
       <p:ext uri="{BB962C8B-B14F-4D97-AF65-F5344CB8AC3E}">
-        <p14:creationId xmlns:p14="http://schemas.microsoft.com/office/powerpoint/2010/main" val="576281101"/>
+        <p14:creationId xmlns:p14="http://schemas.microsoft.com/office/powerpoint/2010/main" val="1083164121"/>
       </p:ext>
     </p:extLst>
   </p:cSld>
@@ -2525,7 +2513,7 @@
           <p:cNvPr id="25" name="slide-2-title">
             <a:extLst xmlns:a="http://schemas.openxmlformats.org/drawingml/2006/main">
               <a:ext uri="{FF2B5EF4-FFF2-40B4-BE49-F238E27FC236}">
-                <a16:creationId xmlns:a16="http://schemas.microsoft.com/office/drawing/2014/main" id="{2007ACAD-635F-4BD0-AFDC-26F7CA7DCF5E}"/>
+                <a16:creationId xmlns:a16="http://schemas.microsoft.com/office/drawing/2014/main" id="{C27C25DC-79E0-4214-ABAE-A996F59D9A7A}"/>
               </a:ext>
             </a:extLst>
           </p:cNvPr>
@@ -2553,7 +2541,6 @@
           <a:lstStyle xmlns:a="http://schemas.openxmlformats.org/drawingml/2006/main"/>
           <a:p xmlns:a="http://schemas.openxmlformats.org/drawingml/2006/main">
             <a:pPr algn="l">
-              <a:buNone/>
               <a:defRPr sz="2850" b="1">
                 <a:solidFill>
                   <a:srgbClr val="101418"/>
@@ -2576,7 +2563,7 @@
           <p:cNvPr id="2" name="slide-2-number">
             <a:extLst xmlns:a="http://schemas.openxmlformats.org/drawingml/2006/main">
               <a:ext uri="{FF2B5EF4-FFF2-40B4-BE49-F238E27FC236}">
-                <a16:creationId xmlns:a16="http://schemas.microsoft.com/office/drawing/2014/main" id="{17CEAE34-8C5C-4DB8-8193-924FD8362003}"/>
+                <a16:creationId xmlns:a16="http://schemas.microsoft.com/office/drawing/2014/main" id="{2F3F3E9B-2726-4529-AB9B-202A26B07A45}"/>
               </a:ext>
             </a:extLst>
           </p:cNvPr>
@@ -2604,7 +2591,6 @@
           <a:lstStyle xmlns:a="http://schemas.openxmlformats.org/drawingml/2006/main"/>
           <a:p xmlns:a="http://schemas.openxmlformats.org/drawingml/2006/main">
             <a:pPr algn="r">
-              <a:buNone/>
               <a:defRPr sz="1050" b="0">
                 <a:solidFill>
                   <a:srgbClr val="53606A"/>
@@ -2627,7 +2613,7 @@
           <p:cNvPr id="3" name="slide-2-rule">
             <a:extLst xmlns:a="http://schemas.openxmlformats.org/drawingml/2006/main">
               <a:ext uri="{FF2B5EF4-FFF2-40B4-BE49-F238E27FC236}">
-                <a16:creationId xmlns:a16="http://schemas.microsoft.com/office/drawing/2014/main" id="{BE3E0986-A0D2-40B7-9BF3-E7DF19964F1A}"/>
+                <a16:creationId xmlns:a16="http://schemas.microsoft.com/office/drawing/2014/main" id="{50C15724-0FF7-45B5-95B8-4073481FB675}"/>
               </a:ext>
             </a:extLst>
           </p:cNvPr>
@@ -2658,7 +2644,7 @@
           <p:cNvPr id="4" name="flow-arrow-0">
             <a:extLst xmlns:a="http://schemas.openxmlformats.org/drawingml/2006/main">
               <a:ext uri="{FF2B5EF4-FFF2-40B4-BE49-F238E27FC236}">
-                <a16:creationId xmlns:a16="http://schemas.microsoft.com/office/drawing/2014/main" id="{3CF8C000-71F2-4649-9517-7EA224D67FFC}"/>
+                <a16:creationId xmlns:a16="http://schemas.microsoft.com/office/drawing/2014/main" id="{DC4FC518-55B1-4534-844A-2324A6F932D0}"/>
               </a:ext>
             </a:extLst>
           </p:cNvPr>
@@ -2689,7 +2675,7 @@
           <p:cNvPr id="5" name="flow-arrow-1">
             <a:extLst xmlns:a="http://schemas.openxmlformats.org/drawingml/2006/main">
               <a:ext uri="{FF2B5EF4-FFF2-40B4-BE49-F238E27FC236}">
-                <a16:creationId xmlns:a16="http://schemas.microsoft.com/office/drawing/2014/main" id="{E0DF0349-FCC5-4F47-A0A8-1619C623FE43}"/>
+                <a16:creationId xmlns:a16="http://schemas.microsoft.com/office/drawing/2014/main" id="{B1358B6A-B73E-4EED-881A-8E2A2CA5F777}"/>
               </a:ext>
             </a:extLst>
           </p:cNvPr>
@@ -2720,7 +2706,7 @@
           <p:cNvPr id="6" name="flow-arrow-2">
             <a:extLst xmlns:a="http://schemas.openxmlformats.org/drawingml/2006/main">
               <a:ext uri="{FF2B5EF4-FFF2-40B4-BE49-F238E27FC236}">
-                <a16:creationId xmlns:a16="http://schemas.microsoft.com/office/drawing/2014/main" id="{3E96C418-07D5-4623-9339-404FD70AC038}"/>
+                <a16:creationId xmlns:a16="http://schemas.microsoft.com/office/drawing/2014/main" id="{35E783A4-DD10-463C-BF54-433F2AC2C62A}"/>
               </a:ext>
             </a:extLst>
           </p:cNvPr>
@@ -2751,7 +2737,7 @@
           <p:cNvPr id="7" name="flow-0-panel">
             <a:extLst xmlns:a="http://schemas.openxmlformats.org/drawingml/2006/main">
               <a:ext uri="{FF2B5EF4-FFF2-40B4-BE49-F238E27FC236}">
-                <a16:creationId xmlns:a16="http://schemas.microsoft.com/office/drawing/2014/main" id="{010C57AA-81BA-4757-8DD7-3C5B84EE9E95}"/>
+                <a16:creationId xmlns:a16="http://schemas.microsoft.com/office/drawing/2014/main" id="{10E6F4CD-283F-4E90-9768-51042B0181B0}"/>
               </a:ext>
             </a:extLst>
           </p:cNvPr>
@@ -2782,7 +2768,7 @@
           <p:cNvPr id="8" name="flow-0-number">
             <a:extLst xmlns:a="http://schemas.openxmlformats.org/drawingml/2006/main">
               <a:ext uri="{FF2B5EF4-FFF2-40B4-BE49-F238E27FC236}">
-                <a16:creationId xmlns:a16="http://schemas.microsoft.com/office/drawing/2014/main" id="{AD0A5773-7D5F-4E5D-A38E-A041B402DECC}"/>
+                <a16:creationId xmlns:a16="http://schemas.microsoft.com/office/drawing/2014/main" id="{8CA6A71D-8742-4BC9-980D-25C81EFB8B8E}"/>
               </a:ext>
             </a:extLst>
           </p:cNvPr>
@@ -2810,7 +2796,6 @@
           <a:lstStyle xmlns:a="http://schemas.openxmlformats.org/drawingml/2006/main"/>
           <a:p xmlns:a="http://schemas.openxmlformats.org/drawingml/2006/main">
             <a:pPr algn="l">
-              <a:buNone/>
               <a:defRPr sz="1200" b="1">
                 <a:solidFill>
                   <a:srgbClr val="3D8DFF"/>
@@ -2833,7 +2818,7 @@
           <p:cNvPr id="9" name="flow-0-heading">
             <a:extLst xmlns:a="http://schemas.openxmlformats.org/drawingml/2006/main">
               <a:ext uri="{FF2B5EF4-FFF2-40B4-BE49-F238E27FC236}">
-                <a16:creationId xmlns:a16="http://schemas.microsoft.com/office/drawing/2014/main" id="{4D8EED07-A9C7-4E66-9CCB-F77BA635542A}"/>
+                <a16:creationId xmlns:a16="http://schemas.microsoft.com/office/drawing/2014/main" id="{85B88CE4-CE8D-42D2-B209-F5DFDF060300}"/>
               </a:ext>
             </a:extLst>
           </p:cNvPr>
@@ -2861,7 +2846,6 @@
           <a:lstStyle xmlns:a="http://schemas.openxmlformats.org/drawingml/2006/main"/>
           <a:p xmlns:a="http://schemas.openxmlformats.org/drawingml/2006/main">
             <a:pPr algn="l">
-              <a:buNone/>
               <a:defRPr sz="1575" b="1">
                 <a:solidFill>
                   <a:srgbClr val="101418"/>
@@ -2884,7 +2868,7 @@
           <p:cNvPr id="10" name="flow-0-body">
             <a:extLst xmlns:a="http://schemas.openxmlformats.org/drawingml/2006/main">
               <a:ext uri="{FF2B5EF4-FFF2-40B4-BE49-F238E27FC236}">
-                <a16:creationId xmlns:a16="http://schemas.microsoft.com/office/drawing/2014/main" id="{73462801-79A3-458E-A968-3C8161FF78D3}"/>
+                <a16:creationId xmlns:a16="http://schemas.microsoft.com/office/drawing/2014/main" id="{D28215E4-1E4A-49C0-9A2B-F8AE02A02FA9}"/>
               </a:ext>
             </a:extLst>
           </p:cNvPr>
@@ -2912,7 +2896,6 @@
           <a:lstStyle xmlns:a="http://schemas.openxmlformats.org/drawingml/2006/main"/>
           <a:p xmlns:a="http://schemas.openxmlformats.org/drawingml/2006/main">
             <a:pPr algn="l">
-              <a:buNone/>
               <a:defRPr sz="1200" b="0">
                 <a:solidFill>
                   <a:srgbClr val="53606A"/>
@@ -2935,7 +2918,7 @@
           <p:cNvPr id="11" name="flow-1-panel">
             <a:extLst xmlns:a="http://schemas.openxmlformats.org/drawingml/2006/main">
               <a:ext uri="{FF2B5EF4-FFF2-40B4-BE49-F238E27FC236}">
-                <a16:creationId xmlns:a16="http://schemas.microsoft.com/office/drawing/2014/main" id="{5C92DA1D-CF3C-40EE-BBC8-90ED15107E04}"/>
+                <a16:creationId xmlns:a16="http://schemas.microsoft.com/office/drawing/2014/main" id="{16167B75-9675-43C1-B543-41B81DAED3FE}"/>
               </a:ext>
             </a:extLst>
           </p:cNvPr>
@@ -2966,7 +2949,7 @@
           <p:cNvPr id="12" name="flow-1-number">
             <a:extLst xmlns:a="http://schemas.openxmlformats.org/drawingml/2006/main">
               <a:ext uri="{FF2B5EF4-FFF2-40B4-BE49-F238E27FC236}">
-                <a16:creationId xmlns:a16="http://schemas.microsoft.com/office/drawing/2014/main" id="{828B631A-AC08-44B6-9A88-123ED3AC2F01}"/>
+                <a16:creationId xmlns:a16="http://schemas.microsoft.com/office/drawing/2014/main" id="{7AB388B0-9D3B-470C-B713-2A66D3080604}"/>
               </a:ext>
             </a:extLst>
           </p:cNvPr>
@@ -2994,7 +2977,6 @@
           <a:lstStyle xmlns:a="http://schemas.openxmlformats.org/drawingml/2006/main"/>
           <a:p xmlns:a="http://schemas.openxmlformats.org/drawingml/2006/main">
             <a:pPr algn="l">
-              <a:buNone/>
               <a:defRPr sz="1200" b="1">
                 <a:solidFill>
                   <a:srgbClr val="3D8DFF"/>
@@ -3017,7 +2999,7 @@
           <p:cNvPr id="13" name="flow-1-heading">
             <a:extLst xmlns:a="http://schemas.openxmlformats.org/drawingml/2006/main">
               <a:ext uri="{FF2B5EF4-FFF2-40B4-BE49-F238E27FC236}">
-                <a16:creationId xmlns:a16="http://schemas.microsoft.com/office/drawing/2014/main" id="{B55CCC06-5C38-44DC-AA04-2116E0413969}"/>
+                <a16:creationId xmlns:a16="http://schemas.microsoft.com/office/drawing/2014/main" id="{25C9801D-C627-4180-81A9-D2732C32BB35}"/>
               </a:ext>
             </a:extLst>
           </p:cNvPr>
@@ -3045,7 +3027,6 @@
           <a:lstStyle xmlns:a="http://schemas.openxmlformats.org/drawingml/2006/main"/>
           <a:p xmlns:a="http://schemas.openxmlformats.org/drawingml/2006/main">
             <a:pPr algn="l">
-              <a:buNone/>
               <a:defRPr sz="1575" b="1">
                 <a:solidFill>
                   <a:srgbClr val="101418"/>
@@ -3068,7 +3049,7 @@
           <p:cNvPr id="14" name="flow-1-body">
             <a:extLst xmlns:a="http://schemas.openxmlformats.org/drawingml/2006/main">
               <a:ext uri="{FF2B5EF4-FFF2-40B4-BE49-F238E27FC236}">
-                <a16:creationId xmlns:a16="http://schemas.microsoft.com/office/drawing/2014/main" id="{683B1FEA-8CC9-4827-837B-E8A31A6B6109}"/>
+                <a16:creationId xmlns:a16="http://schemas.microsoft.com/office/drawing/2014/main" id="{F635560F-4A98-4A40-83E1-6BD06B3BB1C5}"/>
               </a:ext>
             </a:extLst>
           </p:cNvPr>
@@ -3096,7 +3077,6 @@
           <a:lstStyle xmlns:a="http://schemas.openxmlformats.org/drawingml/2006/main"/>
           <a:p xmlns:a="http://schemas.openxmlformats.org/drawingml/2006/main">
             <a:pPr algn="l">
-              <a:buNone/>
               <a:defRPr sz="1200" b="0">
                 <a:solidFill>
                   <a:srgbClr val="53606A"/>
@@ -3119,7 +3099,7 @@
           <p:cNvPr id="15" name="flow-2-panel">
             <a:extLst xmlns:a="http://schemas.openxmlformats.org/drawingml/2006/main">
               <a:ext uri="{FF2B5EF4-FFF2-40B4-BE49-F238E27FC236}">
-                <a16:creationId xmlns:a16="http://schemas.microsoft.com/office/drawing/2014/main" id="{D3349DA9-E405-406F-9A33-25EA1FD06C9A}"/>
+                <a16:creationId xmlns:a16="http://schemas.microsoft.com/office/drawing/2014/main" id="{BE19AB75-F457-4B84-BFDF-02D7CBE746FD}"/>
               </a:ext>
             </a:extLst>
           </p:cNvPr>
@@ -3150,7 +3130,7 @@
           <p:cNvPr id="16" name="flow-2-number">
             <a:extLst xmlns:a="http://schemas.openxmlformats.org/drawingml/2006/main">
               <a:ext uri="{FF2B5EF4-FFF2-40B4-BE49-F238E27FC236}">
-                <a16:creationId xmlns:a16="http://schemas.microsoft.com/office/drawing/2014/main" id="{7FDD8B8E-4E8F-4E04-9559-57B70D02199C}"/>
+                <a16:creationId xmlns:a16="http://schemas.microsoft.com/office/drawing/2014/main" id="{37DA0FBE-1B09-4910-B9D7-096CCA245E06}"/>
               </a:ext>
             </a:extLst>
           </p:cNvPr>
@@ -3178,7 +3158,6 @@
           <a:lstStyle xmlns:a="http://schemas.openxmlformats.org/drawingml/2006/main"/>
           <a:p xmlns:a="http://schemas.openxmlformats.org/drawingml/2006/main">
             <a:pPr algn="l">
-              <a:buNone/>
               <a:defRPr sz="1200" b="1">
                 <a:solidFill>
                   <a:srgbClr val="3D8DFF"/>
@@ -3201,7 +3180,7 @@
           <p:cNvPr id="17" name="flow-2-heading">
             <a:extLst xmlns:a="http://schemas.openxmlformats.org/drawingml/2006/main">
               <a:ext uri="{FF2B5EF4-FFF2-40B4-BE49-F238E27FC236}">
-                <a16:creationId xmlns:a16="http://schemas.microsoft.com/office/drawing/2014/main" id="{7DCDCBB6-406E-4198-99F0-73E5E8ABD430}"/>
+                <a16:creationId xmlns:a16="http://schemas.microsoft.com/office/drawing/2014/main" id="{7AAA00DD-B13A-409D-8328-DD3597120F49}"/>
               </a:ext>
             </a:extLst>
           </p:cNvPr>
@@ -3229,7 +3208,6 @@
           <a:lstStyle xmlns:a="http://schemas.openxmlformats.org/drawingml/2006/main"/>
           <a:p xmlns:a="http://schemas.openxmlformats.org/drawingml/2006/main">
             <a:pPr algn="l">
-              <a:buNone/>
               <a:defRPr sz="1575" b="1">
                 <a:solidFill>
                   <a:srgbClr val="101418"/>
@@ -3252,7 +3230,7 @@
           <p:cNvPr id="18" name="flow-2-body">
             <a:extLst xmlns:a="http://schemas.openxmlformats.org/drawingml/2006/main">
               <a:ext uri="{FF2B5EF4-FFF2-40B4-BE49-F238E27FC236}">
-                <a16:creationId xmlns:a16="http://schemas.microsoft.com/office/drawing/2014/main" id="{D578EC5A-779B-48F9-910B-4507B70B5A09}"/>
+                <a16:creationId xmlns:a16="http://schemas.microsoft.com/office/drawing/2014/main" id="{E8CBD3FE-4D4C-4E7A-AA55-CFA73F051FB5}"/>
               </a:ext>
             </a:extLst>
           </p:cNvPr>
@@ -3280,7 +3258,6 @@
           <a:lstStyle xmlns:a="http://schemas.openxmlformats.org/drawingml/2006/main"/>
           <a:p xmlns:a="http://schemas.openxmlformats.org/drawingml/2006/main">
             <a:pPr algn="l">
-              <a:buNone/>
               <a:defRPr sz="1200" b="0">
                 <a:solidFill>
                   <a:srgbClr val="53606A"/>
@@ -3303,7 +3280,7 @@
           <p:cNvPr id="19" name="flow-3-panel">
             <a:extLst xmlns:a="http://schemas.openxmlformats.org/drawingml/2006/main">
               <a:ext uri="{FF2B5EF4-FFF2-40B4-BE49-F238E27FC236}">
-                <a16:creationId xmlns:a16="http://schemas.microsoft.com/office/drawing/2014/main" id="{9C96CF35-B391-4E7F-A677-DADE4C3F2C12}"/>
+                <a16:creationId xmlns:a16="http://schemas.microsoft.com/office/drawing/2014/main" id="{867D6E20-54E7-47E5-A325-6057270DFFF4}"/>
               </a:ext>
             </a:extLst>
           </p:cNvPr>
@@ -3334,7 +3311,7 @@
           <p:cNvPr id="20" name="flow-3-number">
             <a:extLst xmlns:a="http://schemas.openxmlformats.org/drawingml/2006/main">
               <a:ext uri="{FF2B5EF4-FFF2-40B4-BE49-F238E27FC236}">
-                <a16:creationId xmlns:a16="http://schemas.microsoft.com/office/drawing/2014/main" id="{ACB6567C-99E4-4DC1-A056-7D7D212EF61F}"/>
+                <a16:creationId xmlns:a16="http://schemas.microsoft.com/office/drawing/2014/main" id="{7DF999C1-7017-46DC-882D-BEC2775994AC}"/>
               </a:ext>
             </a:extLst>
           </p:cNvPr>
@@ -3362,7 +3339,6 @@
           <a:lstStyle xmlns:a="http://schemas.openxmlformats.org/drawingml/2006/main"/>
           <a:p xmlns:a="http://schemas.openxmlformats.org/drawingml/2006/main">
             <a:pPr algn="l">
-              <a:buNone/>
               <a:defRPr sz="1200" b="1">
                 <a:solidFill>
                   <a:srgbClr val="3D8DFF"/>
@@ -3385,7 +3361,7 @@
           <p:cNvPr id="21" name="flow-3-heading">
             <a:extLst xmlns:a="http://schemas.openxmlformats.org/drawingml/2006/main">
               <a:ext uri="{FF2B5EF4-FFF2-40B4-BE49-F238E27FC236}">
-                <a16:creationId xmlns:a16="http://schemas.microsoft.com/office/drawing/2014/main" id="{7F17CAC2-03B6-42AC-9F18-F96BA0B1502D}"/>
+                <a16:creationId xmlns:a16="http://schemas.microsoft.com/office/drawing/2014/main" id="{ADDBE1EC-D0F7-4E25-8B73-BA9BDE8261AB}"/>
               </a:ext>
             </a:extLst>
           </p:cNvPr>
@@ -3413,7 +3389,6 @@
           <a:lstStyle xmlns:a="http://schemas.openxmlformats.org/drawingml/2006/main"/>
           <a:p xmlns:a="http://schemas.openxmlformats.org/drawingml/2006/main">
             <a:pPr algn="l">
-              <a:buNone/>
               <a:defRPr sz="1575" b="1">
                 <a:solidFill>
                   <a:srgbClr val="101418"/>
@@ -3436,7 +3411,7 @@
           <p:cNvPr id="22" name="flow-3-body">
             <a:extLst xmlns:a="http://schemas.openxmlformats.org/drawingml/2006/main">
               <a:ext uri="{FF2B5EF4-FFF2-40B4-BE49-F238E27FC236}">
-                <a16:creationId xmlns:a16="http://schemas.microsoft.com/office/drawing/2014/main" id="{ABCFF89F-22BD-4934-9A7E-DD83F6871D0A}"/>
+                <a16:creationId xmlns:a16="http://schemas.microsoft.com/office/drawing/2014/main" id="{136A3998-19B7-470C-B379-64429558B900}"/>
               </a:ext>
             </a:extLst>
           </p:cNvPr>
@@ -3464,7 +3439,6 @@
           <a:lstStyle xmlns:a="http://schemas.openxmlformats.org/drawingml/2006/main"/>
           <a:p xmlns:a="http://schemas.openxmlformats.org/drawingml/2006/main">
             <a:pPr algn="l">
-              <a:buNone/>
               <a:defRPr sz="1200" b="0">
                 <a:solidFill>
                   <a:srgbClr val="53606A"/>
@@ -3487,7 +3461,7 @@
           <p:cNvPr id="23" name="linddun">
             <a:extLst xmlns:a="http://schemas.openxmlformats.org/drawingml/2006/main">
               <a:ext uri="{FF2B5EF4-FFF2-40B4-BE49-F238E27FC236}">
-                <a16:creationId xmlns:a16="http://schemas.microsoft.com/office/drawing/2014/main" id="{4445CAA6-4A1A-4202-8F29-57B718C7D292}"/>
+                <a16:creationId xmlns:a16="http://schemas.microsoft.com/office/drawing/2014/main" id="{13BE897B-FB25-40B1-A1BA-B11E92DEFCF7}"/>
               </a:ext>
             </a:extLst>
           </p:cNvPr>
@@ -3515,7 +3489,6 @@
           <a:lstStyle xmlns:a="http://schemas.openxmlformats.org/drawingml/2006/main"/>
           <a:p xmlns:a="http://schemas.openxmlformats.org/drawingml/2006/main">
             <a:pPr algn="l">
-              <a:buNone/>
               <a:defRPr sz="1650" b="1">
                 <a:solidFill>
                   <a:srgbClr val="101418"/>
@@ -3538,7 +3511,7 @@
           <p:cNvPr id="24" name="scope">
             <a:extLst xmlns:a="http://schemas.openxmlformats.org/drawingml/2006/main">
               <a:ext uri="{FF2B5EF4-FFF2-40B4-BE49-F238E27FC236}">
-                <a16:creationId xmlns:a16="http://schemas.microsoft.com/office/drawing/2014/main" id="{6F8BD253-4549-4602-968B-903BEA5DB783}"/>
+                <a16:creationId xmlns:a16="http://schemas.microsoft.com/office/drawing/2014/main" id="{99925CEF-2F3D-409C-AE62-392B381E7694}"/>
               </a:ext>
             </a:extLst>
           </p:cNvPr>
@@ -3566,7 +3539,6 @@
           <a:lstStyle xmlns:a="http://schemas.openxmlformats.org/drawingml/2006/main"/>
           <a:p xmlns:a="http://schemas.openxmlformats.org/drawingml/2006/main">
             <a:pPr algn="l">
-              <a:buNone/>
               <a:defRPr sz="1350" b="0">
                 <a:solidFill>
                   <a:srgbClr val="53606A"/>
@@ -3587,7 +3559,7 @@
     </p:spTree>
     <p:extLst>
       <p:ext uri="{BB962C8B-B14F-4D97-AF65-F5344CB8AC3E}">
-        <p14:creationId xmlns:p14="http://schemas.microsoft.com/office/powerpoint/2010/main" val="461001883"/>
+        <p14:creationId xmlns:p14="http://schemas.microsoft.com/office/powerpoint/2010/main" val="1862135816"/>
       </p:ext>
     </p:extLst>
   </p:cSld>
@@ -3618,7 +3590,7 @@
           <p:cNvPr id="23" name="slide-3-title">
             <a:extLst xmlns:a="http://schemas.openxmlformats.org/drawingml/2006/main">
               <a:ext uri="{FF2B5EF4-FFF2-40B4-BE49-F238E27FC236}">
-                <a16:creationId xmlns:a16="http://schemas.microsoft.com/office/drawing/2014/main" id="{3A876A8B-DBA6-4153-88C6-38638D651C12}"/>
+                <a16:creationId xmlns:a16="http://schemas.microsoft.com/office/drawing/2014/main" id="{CF0103D1-7500-4172-B8F6-A31961BCAFAE}"/>
               </a:ext>
             </a:extLst>
           </p:cNvPr>
@@ -3646,7 +3618,6 @@
           <a:lstStyle xmlns:a="http://schemas.openxmlformats.org/drawingml/2006/main"/>
           <a:p xmlns:a="http://schemas.openxmlformats.org/drawingml/2006/main">
             <a:pPr algn="l">
-              <a:buNone/>
               <a:defRPr sz="2850" b="1">
                 <a:solidFill>
                   <a:srgbClr val="101418"/>
@@ -3669,7 +3640,7 @@
           <p:cNvPr id="2" name="slide-3-number">
             <a:extLst xmlns:a="http://schemas.openxmlformats.org/drawingml/2006/main">
               <a:ext uri="{FF2B5EF4-FFF2-40B4-BE49-F238E27FC236}">
-                <a16:creationId xmlns:a16="http://schemas.microsoft.com/office/drawing/2014/main" id="{CF4E4FA0-A4B0-4BF3-A2D1-5AFB7AF77F6C}"/>
+                <a16:creationId xmlns:a16="http://schemas.microsoft.com/office/drawing/2014/main" id="{3E3D1880-9E8E-446E-AF90-94683067A82B}"/>
               </a:ext>
             </a:extLst>
           </p:cNvPr>
@@ -3697,7 +3668,6 @@
           <a:lstStyle xmlns:a="http://schemas.openxmlformats.org/drawingml/2006/main"/>
           <a:p xmlns:a="http://schemas.openxmlformats.org/drawingml/2006/main">
             <a:pPr algn="r">
-              <a:buNone/>
               <a:defRPr sz="1050" b="0">
                 <a:solidFill>
                   <a:srgbClr val="53606A"/>
@@ -3720,7 +3690,7 @@
           <p:cNvPr id="3" name="slide-3-rule">
             <a:extLst xmlns:a="http://schemas.openxmlformats.org/drawingml/2006/main">
               <a:ext uri="{FF2B5EF4-FFF2-40B4-BE49-F238E27FC236}">
-                <a16:creationId xmlns:a16="http://schemas.microsoft.com/office/drawing/2014/main" id="{ED81ED3D-32BE-4790-A31C-23F9B7086584}"/>
+                <a16:creationId xmlns:a16="http://schemas.microsoft.com/office/drawing/2014/main" id="{A7DA0AB7-C4B8-4CBC-9779-3D411B0B4504}"/>
               </a:ext>
             </a:extLst>
           </p:cNvPr>
@@ -3751,7 +3721,7 @@
           <p:cNvPr id="4" name="profiles-panel">
             <a:extLst xmlns:a="http://schemas.openxmlformats.org/drawingml/2006/main">
               <a:ext uri="{FF2B5EF4-FFF2-40B4-BE49-F238E27FC236}">
-                <a16:creationId xmlns:a16="http://schemas.microsoft.com/office/drawing/2014/main" id="{AA9F06D6-4DE1-45F9-96A2-640048BB0705}"/>
+                <a16:creationId xmlns:a16="http://schemas.microsoft.com/office/drawing/2014/main" id="{A446391B-BAFD-4051-9371-C0E44DC7CE35}"/>
               </a:ext>
             </a:extLst>
           </p:cNvPr>
@@ -3782,7 +3752,7 @@
           <p:cNvPr id="5" name="profiles-accent">
             <a:extLst xmlns:a="http://schemas.openxmlformats.org/drawingml/2006/main">
               <a:ext uri="{FF2B5EF4-FFF2-40B4-BE49-F238E27FC236}">
-                <a16:creationId xmlns:a16="http://schemas.microsoft.com/office/drawing/2014/main" id="{2A39FAE3-A6BD-49D4-B71C-58D0A5D9719A}"/>
+                <a16:creationId xmlns:a16="http://schemas.microsoft.com/office/drawing/2014/main" id="{B169FE19-F5CB-446C-91AE-EE639D3BF8BF}"/>
               </a:ext>
             </a:extLst>
           </p:cNvPr>
@@ -3813,7 +3783,7 @@
           <p:cNvPr id="6" name="profiles-value">
             <a:extLst xmlns:a="http://schemas.openxmlformats.org/drawingml/2006/main">
               <a:ext uri="{FF2B5EF4-FFF2-40B4-BE49-F238E27FC236}">
-                <a16:creationId xmlns:a16="http://schemas.microsoft.com/office/drawing/2014/main" id="{89D35C25-EEAC-484F-A5FB-9731CE12191D}"/>
+                <a16:creationId xmlns:a16="http://schemas.microsoft.com/office/drawing/2014/main" id="{8F0FC5E0-C21F-49C8-B5AA-0F8D8641138F}"/>
               </a:ext>
             </a:extLst>
           </p:cNvPr>
@@ -3841,7 +3811,6 @@
           <a:lstStyle xmlns:a="http://schemas.openxmlformats.org/drawingml/2006/main"/>
           <a:p xmlns:a="http://schemas.openxmlformats.org/drawingml/2006/main">
             <a:pPr algn="l">
-              <a:buNone/>
               <a:defRPr sz="3450" b="1">
                 <a:solidFill>
                   <a:srgbClr val="101418"/>
@@ -3864,7 +3833,7 @@
           <p:cNvPr id="7" name="profiles-label">
             <a:extLst xmlns:a="http://schemas.openxmlformats.org/drawingml/2006/main">
               <a:ext uri="{FF2B5EF4-FFF2-40B4-BE49-F238E27FC236}">
-                <a16:creationId xmlns:a16="http://schemas.microsoft.com/office/drawing/2014/main" id="{1D808DEA-6D74-4A59-A919-1B9EAC16FE86}"/>
+                <a16:creationId xmlns:a16="http://schemas.microsoft.com/office/drawing/2014/main" id="{6AC5043B-1A83-40FF-9528-AD6DC990F6D2}"/>
               </a:ext>
             </a:extLst>
           </p:cNvPr>
@@ -3892,7 +3861,6 @@
           <a:lstStyle xmlns:a="http://schemas.openxmlformats.org/drawingml/2006/main"/>
           <a:p xmlns:a="http://schemas.openxmlformats.org/drawingml/2006/main">
             <a:pPr algn="l">
-              <a:buNone/>
               <a:defRPr sz="1275" b="0">
                 <a:solidFill>
                   <a:srgbClr val="53606A"/>
@@ -3915,7 +3883,7 @@
           <p:cNvPr id="8" name="prompts-panel">
             <a:extLst xmlns:a="http://schemas.openxmlformats.org/drawingml/2006/main">
               <a:ext uri="{FF2B5EF4-FFF2-40B4-BE49-F238E27FC236}">
-                <a16:creationId xmlns:a16="http://schemas.microsoft.com/office/drawing/2014/main" id="{0537B676-93C9-4EA7-A75D-FD12BFAFF9AC}"/>
+                <a16:creationId xmlns:a16="http://schemas.microsoft.com/office/drawing/2014/main" id="{0DBE084B-CA21-4D38-8DCD-4CCAD07B4A5D}"/>
               </a:ext>
             </a:extLst>
           </p:cNvPr>
@@ -3946,7 +3914,7 @@
           <p:cNvPr id="9" name="prompts-accent">
             <a:extLst xmlns:a="http://schemas.openxmlformats.org/drawingml/2006/main">
               <a:ext uri="{FF2B5EF4-FFF2-40B4-BE49-F238E27FC236}">
-                <a16:creationId xmlns:a16="http://schemas.microsoft.com/office/drawing/2014/main" id="{82897A5E-F421-4866-B14B-34DBA37749FB}"/>
+                <a16:creationId xmlns:a16="http://schemas.microsoft.com/office/drawing/2014/main" id="{699C4731-CFA3-422E-8023-90BF2516740B}"/>
               </a:ext>
             </a:extLst>
           </p:cNvPr>
@@ -3977,7 +3945,7 @@
           <p:cNvPr id="10" name="prompts-value">
             <a:extLst xmlns:a="http://schemas.openxmlformats.org/drawingml/2006/main">
               <a:ext uri="{FF2B5EF4-FFF2-40B4-BE49-F238E27FC236}">
-                <a16:creationId xmlns:a16="http://schemas.microsoft.com/office/drawing/2014/main" id="{F32AB2E5-C1AD-4C5E-AB03-6B63B870B5D1}"/>
+                <a16:creationId xmlns:a16="http://schemas.microsoft.com/office/drawing/2014/main" id="{16A22899-6F42-495B-93B0-B154F8B469E0}"/>
               </a:ext>
             </a:extLst>
           </p:cNvPr>
@@ -4005,7 +3973,6 @@
           <a:lstStyle xmlns:a="http://schemas.openxmlformats.org/drawingml/2006/main"/>
           <a:p xmlns:a="http://schemas.openxmlformats.org/drawingml/2006/main">
             <a:pPr algn="l">
-              <a:buNone/>
               <a:defRPr sz="3450" b="1">
                 <a:solidFill>
                   <a:srgbClr val="101418"/>
@@ -4028,7 +3995,7 @@
           <p:cNvPr id="11" name="prompts-label">
             <a:extLst xmlns:a="http://schemas.openxmlformats.org/drawingml/2006/main">
               <a:ext uri="{FF2B5EF4-FFF2-40B4-BE49-F238E27FC236}">
-                <a16:creationId xmlns:a16="http://schemas.microsoft.com/office/drawing/2014/main" id="{47A817E6-FEC1-48DE-A429-AF5BFA5587AA}"/>
+                <a16:creationId xmlns:a16="http://schemas.microsoft.com/office/drawing/2014/main" id="{AE7303BE-0ABF-4DAD-ADE7-4A82216DB744}"/>
               </a:ext>
             </a:extLst>
           </p:cNvPr>
@@ -4056,7 +4023,6 @@
           <a:lstStyle xmlns:a="http://schemas.openxmlformats.org/drawingml/2006/main"/>
           <a:p xmlns:a="http://schemas.openxmlformats.org/drawingml/2006/main">
             <a:pPr algn="l">
-              <a:buNone/>
               <a:defRPr sz="1275" b="0">
                 <a:solidFill>
                   <a:srgbClr val="53606A"/>
@@ -4069,7 +4035,7 @@
                   <a:srgbClr val="53606A"/>
                 </a:solidFill>
               </a:rPr>
-              <a:t>audited JSON outputs</a:t>
+              <a:t>first responses preserved</a:t>
             </a:r>
           </a:p>
         </p:txBody>
@@ -4079,7 +4045,7 @@
           <p:cNvPr id="12" name="baseline-panel">
             <a:extLst xmlns:a="http://schemas.openxmlformats.org/drawingml/2006/main">
               <a:ext uri="{FF2B5EF4-FFF2-40B4-BE49-F238E27FC236}">
-                <a16:creationId xmlns:a16="http://schemas.microsoft.com/office/drawing/2014/main" id="{6051F794-36EC-446C-962A-757A29A534D2}"/>
+                <a16:creationId xmlns:a16="http://schemas.microsoft.com/office/drawing/2014/main" id="{F32949A0-A7A8-4BAD-9596-95EFDB926570}"/>
               </a:ext>
             </a:extLst>
           </p:cNvPr>
@@ -4110,7 +4076,7 @@
           <p:cNvPr id="13" name="baseline-accent">
             <a:extLst xmlns:a="http://schemas.openxmlformats.org/drawingml/2006/main">
               <a:ext uri="{FF2B5EF4-FFF2-40B4-BE49-F238E27FC236}">
-                <a16:creationId xmlns:a16="http://schemas.microsoft.com/office/drawing/2014/main" id="{3697E256-3E79-41E1-B8D1-81222BF4C8FB}"/>
+                <a16:creationId xmlns:a16="http://schemas.microsoft.com/office/drawing/2014/main" id="{4D3F1457-58BA-45AE-B469-1C52DBE5D31E}"/>
               </a:ext>
             </a:extLst>
           </p:cNvPr>
@@ -4141,7 +4107,7 @@
           <p:cNvPr id="14" name="baseline-value">
             <a:extLst xmlns:a="http://schemas.openxmlformats.org/drawingml/2006/main">
               <a:ext uri="{FF2B5EF4-FFF2-40B4-BE49-F238E27FC236}">
-                <a16:creationId xmlns:a16="http://schemas.microsoft.com/office/drawing/2014/main" id="{9F9E2CCB-563D-4D45-8214-46AA9AB6D987}"/>
+                <a16:creationId xmlns:a16="http://schemas.microsoft.com/office/drawing/2014/main" id="{3EC445B8-6565-4357-B2FD-17779B487C9A}"/>
               </a:ext>
             </a:extLst>
           </p:cNvPr>
@@ -4169,7 +4135,6 @@
           <a:lstStyle xmlns:a="http://schemas.openxmlformats.org/drawingml/2006/main"/>
           <a:p xmlns:a="http://schemas.openxmlformats.org/drawingml/2006/main">
             <a:pPr algn="l">
-              <a:buNone/>
               <a:defRPr sz="3450" b="1">
                 <a:solidFill>
                   <a:srgbClr val="101418"/>
@@ -4192,7 +4157,7 @@
           <p:cNvPr id="15" name="baseline-label">
             <a:extLst xmlns:a="http://schemas.openxmlformats.org/drawingml/2006/main">
               <a:ext uri="{FF2B5EF4-FFF2-40B4-BE49-F238E27FC236}">
-                <a16:creationId xmlns:a16="http://schemas.microsoft.com/office/drawing/2014/main" id="{166399EB-AE50-455A-92F4-0854AEE7605E}"/>
+                <a16:creationId xmlns:a16="http://schemas.microsoft.com/office/drawing/2014/main" id="{DDB06FF9-E494-46C0-A2A3-EF03D98005E0}"/>
               </a:ext>
             </a:extLst>
           </p:cNvPr>
@@ -4220,7 +4185,6 @@
           <a:lstStyle xmlns:a="http://schemas.openxmlformats.org/drawingml/2006/main"/>
           <a:p xmlns:a="http://schemas.openxmlformats.org/drawingml/2006/main">
             <a:pPr algn="l">
-              <a:buNone/>
               <a:defRPr sz="1275" b="0">
                 <a:solidFill>
                   <a:srgbClr val="53606A"/>
@@ -4243,7 +4207,7 @@
           <p:cNvPr id="16" name="mitigation-panel">
             <a:extLst xmlns:a="http://schemas.openxmlformats.org/drawingml/2006/main">
               <a:ext uri="{FF2B5EF4-FFF2-40B4-BE49-F238E27FC236}">
-                <a16:creationId xmlns:a16="http://schemas.microsoft.com/office/drawing/2014/main" id="{BF6AF429-9B49-47B6-B566-25007F04D774}"/>
+                <a16:creationId xmlns:a16="http://schemas.microsoft.com/office/drawing/2014/main" id="{965E33FC-67FC-48A7-8A78-FE73C623290A}"/>
               </a:ext>
             </a:extLst>
           </p:cNvPr>
@@ -4274,7 +4238,7 @@
           <p:cNvPr id="17" name="mitigation-accent">
             <a:extLst xmlns:a="http://schemas.openxmlformats.org/drawingml/2006/main">
               <a:ext uri="{FF2B5EF4-FFF2-40B4-BE49-F238E27FC236}">
-                <a16:creationId xmlns:a16="http://schemas.microsoft.com/office/drawing/2014/main" id="{0D7DA909-2FAC-4FD0-85E9-11A716B1B728}"/>
+                <a16:creationId xmlns:a16="http://schemas.microsoft.com/office/drawing/2014/main" id="{840D22EB-0024-4197-B77B-82CAE454810C}"/>
               </a:ext>
             </a:extLst>
           </p:cNvPr>
@@ -4305,7 +4269,7 @@
           <p:cNvPr id="18" name="mitigation-value">
             <a:extLst xmlns:a="http://schemas.openxmlformats.org/drawingml/2006/main">
               <a:ext uri="{FF2B5EF4-FFF2-40B4-BE49-F238E27FC236}">
-                <a16:creationId xmlns:a16="http://schemas.microsoft.com/office/drawing/2014/main" id="{4C5B74CC-4489-4A8C-BD35-7C0AA91EA123}"/>
+                <a16:creationId xmlns:a16="http://schemas.microsoft.com/office/drawing/2014/main" id="{F4EEA5B9-EAFD-41A7-9B99-021F5761E200}"/>
               </a:ext>
             </a:extLst>
           </p:cNvPr>
@@ -4333,7 +4297,6 @@
           <a:lstStyle xmlns:a="http://schemas.openxmlformats.org/drawingml/2006/main"/>
           <a:p xmlns:a="http://schemas.openxmlformats.org/drawingml/2006/main">
             <a:pPr algn="l">
-              <a:buNone/>
               <a:defRPr sz="3450" b="1">
                 <a:solidFill>
                   <a:srgbClr val="101418"/>
@@ -4356,7 +4319,7 @@
           <p:cNvPr id="19" name="mitigation-label">
             <a:extLst xmlns:a="http://schemas.openxmlformats.org/drawingml/2006/main">
               <a:ext uri="{FF2B5EF4-FFF2-40B4-BE49-F238E27FC236}">
-                <a16:creationId xmlns:a16="http://schemas.microsoft.com/office/drawing/2014/main" id="{ED7C2926-DCEC-4950-A648-C747B0466B8B}"/>
+                <a16:creationId xmlns:a16="http://schemas.microsoft.com/office/drawing/2014/main" id="{2F76C50D-ABAE-49C9-80B0-7EFA919B9290}"/>
               </a:ext>
             </a:extLst>
           </p:cNvPr>
@@ -4384,7 +4347,6 @@
           <a:lstStyle xmlns:a="http://schemas.openxmlformats.org/drawingml/2006/main"/>
           <a:p xmlns:a="http://schemas.openxmlformats.org/drawingml/2006/main">
             <a:pPr algn="l">
-              <a:buNone/>
               <a:defRPr sz="1275" b="0">
                 <a:solidFill>
                   <a:srgbClr val="53606A"/>
@@ -4404,14 +4366,14 @@
       </p:sp>
       <p:pic>
         <p:nvPicPr>
-          <p:cNvPr id="44" name=""/>
+          <p:cNvPr id="42" name=""/>
           <p:cNvPicPr>
             <a:picLocks xmlns:a="http://schemas.openxmlformats.org/drawingml/2006/main" noChangeAspect="1"/>
           </p:cNvPicPr>
           <p:nvPr/>
         </p:nvPicPr>
         <p:blipFill>
-          <a:blip xmlns:r="http://schemas.openxmlformats.org/officeDocument/2006/relationships" xmlns:a="http://schemas.openxmlformats.org/drawingml/2006/main" r:embed="R17a7363545114a9d"/>
+          <a:blip xmlns:r="http://schemas.openxmlformats.org/officeDocument/2006/relationships" xmlns:a="http://schemas.openxmlformats.org/drawingml/2006/main" r:embed="R52727c9038594ff3"/>
           <a:stretch xmlns:a="http://schemas.openxmlformats.org/drawingml/2006/main"/>
         </p:blipFill>
         <p:spPr>
@@ -4429,7 +4391,7 @@
           <p:cNvPr id="21" name="method-caption">
             <a:extLst xmlns:a="http://schemas.openxmlformats.org/drawingml/2006/main">
               <a:ext uri="{FF2B5EF4-FFF2-40B4-BE49-F238E27FC236}">
-                <a16:creationId xmlns:a16="http://schemas.microsoft.com/office/drawing/2014/main" id="{F6021877-4DD6-4F67-8041-3AE742017308}"/>
+                <a16:creationId xmlns:a16="http://schemas.microsoft.com/office/drawing/2014/main" id="{6711CE1E-C2A6-461B-86CD-20448A0AAF28}"/>
               </a:ext>
             </a:extLst>
           </p:cNvPr>
@@ -4457,7 +4419,6 @@
           <a:lstStyle xmlns:a="http://schemas.openxmlformats.org/drawingml/2006/main"/>
           <a:p xmlns:a="http://schemas.openxmlformats.org/drawingml/2006/main">
             <a:pPr algn="l">
-              <a:buNone/>
               <a:defRPr sz="1350" b="1">
                 <a:solidFill>
                   <a:srgbClr val="101418"/>
@@ -4470,7 +4431,7 @@
                   <a:srgbClr val="101418"/>
                 </a:solidFill>
               </a:rPr>
-              <a:t>Temporary Chats isolated prompts; five transfer errors were rerun after audit.</a:t>
+              <a:t>Each prompt opened in a new Temporary Chat; all 90 outputs parsed as JSON.</a:t>
             </a:r>
           </a:p>
         </p:txBody>
@@ -4480,7 +4441,7 @@
           <p:cNvPr id="22" name="method-model">
             <a:extLst xmlns:a="http://schemas.openxmlformats.org/drawingml/2006/main">
               <a:ext uri="{FF2B5EF4-FFF2-40B4-BE49-F238E27FC236}">
-                <a16:creationId xmlns:a16="http://schemas.microsoft.com/office/drawing/2014/main" id="{4D21BC91-43D2-49A8-9F13-F649CF32D709}"/>
+                <a16:creationId xmlns:a16="http://schemas.microsoft.com/office/drawing/2014/main" id="{26A9463C-FA12-4EBF-B112-4EFDD60C8434}"/>
               </a:ext>
             </a:extLst>
           </p:cNvPr>
@@ -4508,7 +4469,6 @@
           <a:lstStyle xmlns:a="http://schemas.openxmlformats.org/drawingml/2006/main"/>
           <a:p xmlns:a="http://schemas.openxmlformats.org/drawingml/2006/main">
             <a:pPr algn="l">
-              <a:buNone/>
               <a:defRPr sz="1050" b="0">
                 <a:solidFill>
                   <a:srgbClr val="53606A"/>
@@ -4529,7 +4489,7 @@
     </p:spTree>
     <p:extLst>
       <p:ext uri="{BB962C8B-B14F-4D97-AF65-F5344CB8AC3E}">
-        <p14:creationId xmlns:p14="http://schemas.microsoft.com/office/powerpoint/2010/main" val="932456732"/>
+        <p14:creationId xmlns:p14="http://schemas.microsoft.com/office/powerpoint/2010/main" val="472455524"/>
       </p:ext>
     </p:extLst>
   </p:cSld>
@@ -4560,7 +4520,7 @@
           <p:cNvPr id="12" name="slide-4-title">
             <a:extLst xmlns:a="http://schemas.openxmlformats.org/drawingml/2006/main">
               <a:ext uri="{FF2B5EF4-FFF2-40B4-BE49-F238E27FC236}">
-                <a16:creationId xmlns:a16="http://schemas.microsoft.com/office/drawing/2014/main" id="{42F9D224-909C-419C-8329-C8E6E72E5A62}"/>
+                <a16:creationId xmlns:a16="http://schemas.microsoft.com/office/drawing/2014/main" id="{5177AE07-BF90-41A7-A274-8E156D9A5F29}"/>
               </a:ext>
             </a:extLst>
           </p:cNvPr>
@@ -4588,7 +4548,6 @@
           <a:lstStyle xmlns:a="http://schemas.openxmlformats.org/drawingml/2006/main"/>
           <a:p xmlns:a="http://schemas.openxmlformats.org/drawingml/2006/main">
             <a:pPr algn="l">
-              <a:buNone/>
               <a:defRPr sz="2850" b="1">
                 <a:solidFill>
                   <a:srgbClr val="101418"/>
@@ -4611,7 +4570,7 @@
           <p:cNvPr id="2" name="slide-4-number">
             <a:extLst xmlns:a="http://schemas.openxmlformats.org/drawingml/2006/main">
               <a:ext uri="{FF2B5EF4-FFF2-40B4-BE49-F238E27FC236}">
-                <a16:creationId xmlns:a16="http://schemas.microsoft.com/office/drawing/2014/main" id="{733FE866-905D-466D-A611-145C4A192AB0}"/>
+                <a16:creationId xmlns:a16="http://schemas.microsoft.com/office/drawing/2014/main" id="{4D4144CA-95AB-49B0-B2E8-0AB62841F3AD}"/>
               </a:ext>
             </a:extLst>
           </p:cNvPr>
@@ -4639,7 +4598,6 @@
           <a:lstStyle xmlns:a="http://schemas.openxmlformats.org/drawingml/2006/main"/>
           <a:p xmlns:a="http://schemas.openxmlformats.org/drawingml/2006/main">
             <a:pPr algn="r">
-              <a:buNone/>
               <a:defRPr sz="1050" b="0">
                 <a:solidFill>
                   <a:srgbClr val="53606A"/>
@@ -4662,7 +4620,7 @@
           <p:cNvPr id="3" name="slide-4-rule">
             <a:extLst xmlns:a="http://schemas.openxmlformats.org/drawingml/2006/main">
               <a:ext uri="{FF2B5EF4-FFF2-40B4-BE49-F238E27FC236}">
-                <a16:creationId xmlns:a16="http://schemas.microsoft.com/office/drawing/2014/main" id="{F778091E-D4DE-4DC0-A323-17E1AF81D03D}"/>
+                <a16:creationId xmlns:a16="http://schemas.microsoft.com/office/drawing/2014/main" id="{CAC2B587-2C30-47B9-8A2B-115C634E3CDA}"/>
               </a:ext>
             </a:extLst>
           </p:cNvPr>
@@ -4690,7 +4648,7 @@
       </p:sp>
       <p:graphicFrame>
         <p:nvGraphicFramePr>
-          <p:cNvPr id="17" name="Chart"/>
+          <p:cNvPr id="15" name="Chart"/>
           <p:cNvGraphicFramePr/>
           <p:nvPr/>
         </p:nvGraphicFramePr>
@@ -4700,7 +4658,7 @@
         </p:xfrm>
         <a:graphic xmlns:a="http://schemas.openxmlformats.org/drawingml/2006/main">
           <a:graphicData uri="http://schemas.openxmlformats.org/drawingml/2006/chart">
-            <c:chart xmlns:r="http://schemas.openxmlformats.org/officeDocument/2006/relationships" xmlns:c="http://schemas.openxmlformats.org/drawingml/2006/chart" r:id="R414b586f653348c8"/>
+            <c:chart xmlns:r="http://schemas.openxmlformats.org/officeDocument/2006/relationships" xmlns:c="http://schemas.openxmlformats.org/drawingml/2006/chart" r:id="Rd39966e1e48f4442"/>
           </a:graphicData>
         </a:graphic>
       </p:graphicFrame>
@@ -4709,7 +4667,7 @@
           <p:cNvPr id="5" name="result-callout">
             <a:extLst xmlns:a="http://schemas.openxmlformats.org/drawingml/2006/main">
               <a:ext uri="{FF2B5EF4-FFF2-40B4-BE49-F238E27FC236}">
-                <a16:creationId xmlns:a16="http://schemas.microsoft.com/office/drawing/2014/main" id="{A350EEC6-5EF2-47C9-8830-91B732ACEB07}"/>
+                <a16:creationId xmlns:a16="http://schemas.microsoft.com/office/drawing/2014/main" id="{1740E78B-8B86-4767-96BA-F38737E10C69}"/>
               </a:ext>
             </a:extLst>
           </p:cNvPr>
@@ -4740,7 +4698,7 @@
           <p:cNvPr id="6" name="result-value">
             <a:extLst xmlns:a="http://schemas.openxmlformats.org/drawingml/2006/main">
               <a:ext uri="{FF2B5EF4-FFF2-40B4-BE49-F238E27FC236}">
-                <a16:creationId xmlns:a16="http://schemas.microsoft.com/office/drawing/2014/main" id="{4C005CB8-96EB-4B55-A2E0-2587B68390B0}"/>
+                <a16:creationId xmlns:a16="http://schemas.microsoft.com/office/drawing/2014/main" id="{B6B6EB66-179E-492A-8CBA-A2BCDD578D70}"/>
               </a:ext>
             </a:extLst>
           </p:cNvPr>
@@ -4768,7 +4726,6 @@
           <a:lstStyle xmlns:a="http://schemas.openxmlformats.org/drawingml/2006/main"/>
           <a:p xmlns:a="http://schemas.openxmlformats.org/drawingml/2006/main">
             <a:pPr algn="l">
-              <a:buNone/>
               <a:defRPr sz="3300" b="1">
                 <a:solidFill>
                   <a:srgbClr val="3D8DFF"/>
@@ -4791,7 +4748,7 @@
           <p:cNvPr id="7" name="result-copy">
             <a:extLst xmlns:a="http://schemas.openxmlformats.org/drawingml/2006/main">
               <a:ext uri="{FF2B5EF4-FFF2-40B4-BE49-F238E27FC236}">
-                <a16:creationId xmlns:a16="http://schemas.microsoft.com/office/drawing/2014/main" id="{C039E732-1E60-4B31-A347-11FC782B3AB7}"/>
+                <a16:creationId xmlns:a16="http://schemas.microsoft.com/office/drawing/2014/main" id="{68102DE2-8274-4F18-9792-1C47888C4F87}"/>
               </a:ext>
             </a:extLst>
           </p:cNvPr>
@@ -4819,7 +4776,6 @@
           <a:lstStyle xmlns:a="http://schemas.openxmlformats.org/drawingml/2006/main"/>
           <a:p xmlns:a="http://schemas.openxmlformats.org/drawingml/2006/main">
             <a:pPr algn="l">
-              <a:buNone/>
               <a:defRPr sz="1350" b="0">
                 <a:solidFill>
                   <a:srgbClr val="53606A"/>
@@ -4842,7 +4798,7 @@
           <p:cNvPr id="8" name="confidence-callout">
             <a:extLst xmlns:a="http://schemas.openxmlformats.org/drawingml/2006/main">
               <a:ext uri="{FF2B5EF4-FFF2-40B4-BE49-F238E27FC236}">
-                <a16:creationId xmlns:a16="http://schemas.microsoft.com/office/drawing/2014/main" id="{F5DBA340-0288-4C2C-AD03-29CB984075CA}"/>
+                <a16:creationId xmlns:a16="http://schemas.microsoft.com/office/drawing/2014/main" id="{61A554CF-E1C3-419E-AD7D-A55677FFA089}"/>
               </a:ext>
             </a:extLst>
           </p:cNvPr>
@@ -4873,7 +4829,7 @@
           <p:cNvPr id="9" name="confidence-value">
             <a:extLst xmlns:a="http://schemas.openxmlformats.org/drawingml/2006/main">
               <a:ext uri="{FF2B5EF4-FFF2-40B4-BE49-F238E27FC236}">
-                <a16:creationId xmlns:a16="http://schemas.microsoft.com/office/drawing/2014/main" id="{E4B792B1-4112-4A6F-98F5-65279B52F11F}"/>
+                <a16:creationId xmlns:a16="http://schemas.microsoft.com/office/drawing/2014/main" id="{04121FFB-AA42-4A5C-AEF6-A69888FF7114}"/>
               </a:ext>
             </a:extLst>
           </p:cNvPr>
@@ -4901,7 +4857,6 @@
           <a:lstStyle xmlns:a="http://schemas.openxmlformats.org/drawingml/2006/main"/>
           <a:p xmlns:a="http://schemas.openxmlformats.org/drawingml/2006/main">
             <a:pPr algn="l">
-              <a:buNone/>
               <a:defRPr sz="2625" b="1">
                 <a:solidFill>
                   <a:srgbClr val="101418"/>
@@ -4924,7 +4879,7 @@
           <p:cNvPr id="10" name="confidence-copy">
             <a:extLst xmlns:a="http://schemas.openxmlformats.org/drawingml/2006/main">
               <a:ext uri="{FF2B5EF4-FFF2-40B4-BE49-F238E27FC236}">
-                <a16:creationId xmlns:a16="http://schemas.microsoft.com/office/drawing/2014/main" id="{6E60D7DD-5290-48F6-9D5E-32AA16AEC2BF}"/>
+                <a16:creationId xmlns:a16="http://schemas.microsoft.com/office/drawing/2014/main" id="{0CBCAD9F-B342-4524-A704-5B1C9364141B}"/>
               </a:ext>
             </a:extLst>
           </p:cNvPr>
@@ -4952,7 +4907,6 @@
           <a:lstStyle xmlns:a="http://schemas.openxmlformats.org/drawingml/2006/main"/>
           <a:p xmlns:a="http://schemas.openxmlformats.org/drawingml/2006/main">
             <a:pPr algn="l">
-              <a:buNone/>
               <a:defRPr sz="1350" b="0">
                 <a:solidFill>
                   <a:srgbClr val="53606A"/>
@@ -4975,7 +4929,7 @@
           <p:cNvPr id="11" name="result-footnote">
             <a:extLst xmlns:a="http://schemas.openxmlformats.org/drawingml/2006/main">
               <a:ext uri="{FF2B5EF4-FFF2-40B4-BE49-F238E27FC236}">
-                <a16:creationId xmlns:a16="http://schemas.microsoft.com/office/drawing/2014/main" id="{72EB367E-3492-491D-BD07-C378B0B9D96D}"/>
+                <a16:creationId xmlns:a16="http://schemas.microsoft.com/office/drawing/2014/main" id="{088CB3A7-E2D6-46E0-8264-EB27576514A5}"/>
               </a:ext>
             </a:extLst>
           </p:cNvPr>
@@ -5003,7 +4957,6 @@
           <a:lstStyle xmlns:a="http://schemas.openxmlformats.org/drawingml/2006/main"/>
           <a:p xmlns:a="http://schemas.openxmlformats.org/drawingml/2006/main">
             <a:pPr algn="l">
-              <a:buNone/>
               <a:defRPr sz="1050" b="0">
                 <a:solidFill>
                   <a:srgbClr val="53606A"/>
@@ -5024,7 +4977,7 @@
     </p:spTree>
     <p:extLst>
       <p:ext uri="{BB962C8B-B14F-4D97-AF65-F5344CB8AC3E}">
-        <p14:creationId xmlns:p14="http://schemas.microsoft.com/office/powerpoint/2010/main" val="389382007"/>
+        <p14:creationId xmlns:p14="http://schemas.microsoft.com/office/powerpoint/2010/main" val="788351671"/>
       </p:ext>
     </p:extLst>
   </p:cSld>
@@ -5055,7 +5008,7 @@
           <p:cNvPr id="15" name="slide-5-title">
             <a:extLst xmlns:a="http://schemas.openxmlformats.org/drawingml/2006/main">
               <a:ext uri="{FF2B5EF4-FFF2-40B4-BE49-F238E27FC236}">
-                <a16:creationId xmlns:a16="http://schemas.microsoft.com/office/drawing/2014/main" id="{E62FEF91-CDA4-4B24-95DB-E15BA948A7D0}"/>
+                <a16:creationId xmlns:a16="http://schemas.microsoft.com/office/drawing/2014/main" id="{CA8E061A-4A82-4A51-AAFB-544DC35B9B98}"/>
               </a:ext>
             </a:extLst>
           </p:cNvPr>
@@ -5083,7 +5036,6 @@
           <a:lstStyle xmlns:a="http://schemas.openxmlformats.org/drawingml/2006/main"/>
           <a:p xmlns:a="http://schemas.openxmlformats.org/drawingml/2006/main">
             <a:pPr algn="l">
-              <a:buNone/>
               <a:defRPr sz="2850" b="1">
                 <a:solidFill>
                   <a:srgbClr val="101418"/>
@@ -5106,7 +5058,7 @@
           <p:cNvPr id="2" name="slide-5-number">
             <a:extLst xmlns:a="http://schemas.openxmlformats.org/drawingml/2006/main">
               <a:ext uri="{FF2B5EF4-FFF2-40B4-BE49-F238E27FC236}">
-                <a16:creationId xmlns:a16="http://schemas.microsoft.com/office/drawing/2014/main" id="{2EACF183-77E6-4493-B38B-47F46EAE0E1E}"/>
+                <a16:creationId xmlns:a16="http://schemas.microsoft.com/office/drawing/2014/main" id="{A1305CDA-5842-479D-BCC6-17AA67D1AA40}"/>
               </a:ext>
             </a:extLst>
           </p:cNvPr>
@@ -5134,7 +5086,6 @@
           <a:lstStyle xmlns:a="http://schemas.openxmlformats.org/drawingml/2006/main"/>
           <a:p xmlns:a="http://schemas.openxmlformats.org/drawingml/2006/main">
             <a:pPr algn="r">
-              <a:buNone/>
               <a:defRPr sz="1050" b="0">
                 <a:solidFill>
                   <a:srgbClr val="53606A"/>
@@ -5157,7 +5108,7 @@
           <p:cNvPr id="3" name="slide-5-rule">
             <a:extLst xmlns:a="http://schemas.openxmlformats.org/drawingml/2006/main">
               <a:ext uri="{FF2B5EF4-FFF2-40B4-BE49-F238E27FC236}">
-                <a16:creationId xmlns:a16="http://schemas.microsoft.com/office/drawing/2014/main" id="{DAD6299D-831F-41EB-AD62-637DE0ED6CFD}"/>
+                <a16:creationId xmlns:a16="http://schemas.microsoft.com/office/drawing/2014/main" id="{9CAF9D3B-C3D3-46D5-AF0B-F3F0D7D8E5DC}"/>
               </a:ext>
             </a:extLst>
           </p:cNvPr>
@@ -5185,7 +5136,7 @@
       </p:sp>
       <p:graphicFrame>
         <p:nvGraphicFramePr>
-          <p:cNvPr id="20" name="Chart"/>
+          <p:cNvPr id="18" name="Chart"/>
           <p:cNvGraphicFramePr/>
           <p:nvPr/>
         </p:nvGraphicFramePr>
@@ -5195,7 +5146,7 @@
         </p:xfrm>
         <a:graphic xmlns:a="http://schemas.openxmlformats.org/drawingml/2006/main">
           <a:graphicData uri="http://schemas.openxmlformats.org/drawingml/2006/chart">
-            <c:chart xmlns:r="http://schemas.openxmlformats.org/officeDocument/2006/relationships" xmlns:c="http://schemas.openxmlformats.org/drawingml/2006/chart" r:id="R4f54096f493e4b1a"/>
+            <c:chart xmlns:r="http://schemas.openxmlformats.org/officeDocument/2006/relationships" xmlns:c="http://schemas.openxmlformats.org/drawingml/2006/chart" r:id="R91e4d109f0044f35"/>
           </a:graphicData>
         </a:graphic>
       </p:graphicFrame>
@@ -5204,7 +5155,7 @@
           <p:cNvPr id="5" name="finding-0-panel">
             <a:extLst xmlns:a="http://schemas.openxmlformats.org/drawingml/2006/main">
               <a:ext uri="{FF2B5EF4-FFF2-40B4-BE49-F238E27FC236}">
-                <a16:creationId xmlns:a16="http://schemas.microsoft.com/office/drawing/2014/main" id="{3036D74E-83E1-4C86-90F5-AB74AC8E50D4}"/>
+                <a16:creationId xmlns:a16="http://schemas.microsoft.com/office/drawing/2014/main" id="{0AAE9CC5-6DCB-44B6-8979-1E2E37C2E131}"/>
               </a:ext>
             </a:extLst>
           </p:cNvPr>
@@ -5235,7 +5186,7 @@
           <p:cNvPr id="6" name="finding-0-title">
             <a:extLst xmlns:a="http://schemas.openxmlformats.org/drawingml/2006/main">
               <a:ext uri="{FF2B5EF4-FFF2-40B4-BE49-F238E27FC236}">
-                <a16:creationId xmlns:a16="http://schemas.microsoft.com/office/drawing/2014/main" id="{AC7BD2E1-D6CA-4572-ADB5-AFC3A7DCB0E7}"/>
+                <a16:creationId xmlns:a16="http://schemas.microsoft.com/office/drawing/2014/main" id="{8F80B17E-F43B-4CA5-8DBB-E907EA155265}"/>
               </a:ext>
             </a:extLst>
           </p:cNvPr>
@@ -5263,7 +5214,6 @@
           <a:lstStyle xmlns:a="http://schemas.openxmlformats.org/drawingml/2006/main"/>
           <a:p xmlns:a="http://schemas.openxmlformats.org/drawingml/2006/main">
             <a:pPr algn="l">
-              <a:buNone/>
               <a:defRPr sz="1425" b="1">
                 <a:solidFill>
                   <a:srgbClr val="101418"/>
@@ -5286,7 +5236,7 @@
           <p:cNvPr id="7" name="finding-0-body">
             <a:extLst xmlns:a="http://schemas.openxmlformats.org/drawingml/2006/main">
               <a:ext uri="{FF2B5EF4-FFF2-40B4-BE49-F238E27FC236}">
-                <a16:creationId xmlns:a16="http://schemas.microsoft.com/office/drawing/2014/main" id="{24ED501D-A4A3-4B02-A38F-3C1D599461E7}"/>
+                <a16:creationId xmlns:a16="http://schemas.microsoft.com/office/drawing/2014/main" id="{2971C9EE-7778-457F-B5FD-FB0C522002C4}"/>
               </a:ext>
             </a:extLst>
           </p:cNvPr>
@@ -5314,7 +5264,6 @@
           <a:lstStyle xmlns:a="http://schemas.openxmlformats.org/drawingml/2006/main"/>
           <a:p xmlns:a="http://schemas.openxmlformats.org/drawingml/2006/main">
             <a:pPr algn="l">
-              <a:buNone/>
               <a:defRPr sz="1200" b="0">
                 <a:solidFill>
                   <a:srgbClr val="53606A"/>
@@ -5337,7 +5286,7 @@
           <p:cNvPr id="8" name="finding-1-panel">
             <a:extLst xmlns:a="http://schemas.openxmlformats.org/drawingml/2006/main">
               <a:ext uri="{FF2B5EF4-FFF2-40B4-BE49-F238E27FC236}">
-                <a16:creationId xmlns:a16="http://schemas.microsoft.com/office/drawing/2014/main" id="{C5AADD6B-BC69-4432-A0C5-ED0690F27543}"/>
+                <a16:creationId xmlns:a16="http://schemas.microsoft.com/office/drawing/2014/main" id="{4EB592A6-BCC0-4286-A307-15B4008335FE}"/>
               </a:ext>
             </a:extLst>
           </p:cNvPr>
@@ -5368,7 +5317,7 @@
           <p:cNvPr id="9" name="finding-1-title">
             <a:extLst xmlns:a="http://schemas.openxmlformats.org/drawingml/2006/main">
               <a:ext uri="{FF2B5EF4-FFF2-40B4-BE49-F238E27FC236}">
-                <a16:creationId xmlns:a16="http://schemas.microsoft.com/office/drawing/2014/main" id="{6821ACA9-6B0B-4C3E-8FA4-6A1DD9E94AAA}"/>
+                <a16:creationId xmlns:a16="http://schemas.microsoft.com/office/drawing/2014/main" id="{43F976D3-24E7-49E5-BE4D-1399295EBE07}"/>
               </a:ext>
             </a:extLst>
           </p:cNvPr>
@@ -5396,7 +5345,6 @@
           <a:lstStyle xmlns:a="http://schemas.openxmlformats.org/drawingml/2006/main"/>
           <a:p xmlns:a="http://schemas.openxmlformats.org/drawingml/2006/main">
             <a:pPr algn="l">
-              <a:buNone/>
               <a:defRPr sz="1425" b="1">
                 <a:solidFill>
                   <a:srgbClr val="101418"/>
@@ -5419,7 +5367,7 @@
           <p:cNvPr id="10" name="finding-1-body">
             <a:extLst xmlns:a="http://schemas.openxmlformats.org/drawingml/2006/main">
               <a:ext uri="{FF2B5EF4-FFF2-40B4-BE49-F238E27FC236}">
-                <a16:creationId xmlns:a16="http://schemas.microsoft.com/office/drawing/2014/main" id="{1A28145A-ED2F-46B0-9392-466AA1694119}"/>
+                <a16:creationId xmlns:a16="http://schemas.microsoft.com/office/drawing/2014/main" id="{5954F0B3-4640-4B8F-8B04-AC4CFCE0FB02}"/>
               </a:ext>
             </a:extLst>
           </p:cNvPr>
@@ -5447,7 +5395,6 @@
           <a:lstStyle xmlns:a="http://schemas.openxmlformats.org/drawingml/2006/main"/>
           <a:p xmlns:a="http://schemas.openxmlformats.org/drawingml/2006/main">
             <a:pPr algn="l">
-              <a:buNone/>
               <a:defRPr sz="1200" b="0">
                 <a:solidFill>
                   <a:srgbClr val="53606A"/>
@@ -5470,7 +5417,7 @@
           <p:cNvPr id="11" name="finding-2-panel">
             <a:extLst xmlns:a="http://schemas.openxmlformats.org/drawingml/2006/main">
               <a:ext uri="{FF2B5EF4-FFF2-40B4-BE49-F238E27FC236}">
-                <a16:creationId xmlns:a16="http://schemas.microsoft.com/office/drawing/2014/main" id="{73AAABA6-1317-4220-822D-B2D5F399AD7B}"/>
+                <a16:creationId xmlns:a16="http://schemas.microsoft.com/office/drawing/2014/main" id="{912B610B-C2CF-4ECA-8BAC-AE4E8363C367}"/>
               </a:ext>
             </a:extLst>
           </p:cNvPr>
@@ -5501,7 +5448,7 @@
           <p:cNvPr id="12" name="finding-2-title">
             <a:extLst xmlns:a="http://schemas.openxmlformats.org/drawingml/2006/main">
               <a:ext uri="{FF2B5EF4-FFF2-40B4-BE49-F238E27FC236}">
-                <a16:creationId xmlns:a16="http://schemas.microsoft.com/office/drawing/2014/main" id="{5071A023-EF31-4FF1-AC50-CAFE65BFE93A}"/>
+                <a16:creationId xmlns:a16="http://schemas.microsoft.com/office/drawing/2014/main" id="{9A199862-A105-4333-AC76-DD2664377B22}"/>
               </a:ext>
             </a:extLst>
           </p:cNvPr>
@@ -5529,7 +5476,6 @@
           <a:lstStyle xmlns:a="http://schemas.openxmlformats.org/drawingml/2006/main"/>
           <a:p xmlns:a="http://schemas.openxmlformats.org/drawingml/2006/main">
             <a:pPr algn="l">
-              <a:buNone/>
               <a:defRPr sz="1425" b="1">
                 <a:solidFill>
                   <a:srgbClr val="101418"/>
@@ -5552,7 +5498,7 @@
           <p:cNvPr id="13" name="finding-2-body">
             <a:extLst xmlns:a="http://schemas.openxmlformats.org/drawingml/2006/main">
               <a:ext uri="{FF2B5EF4-FFF2-40B4-BE49-F238E27FC236}">
-                <a16:creationId xmlns:a16="http://schemas.microsoft.com/office/drawing/2014/main" id="{AA4A84D4-0C86-4507-B9E9-17071F9C5FC4}"/>
+                <a16:creationId xmlns:a16="http://schemas.microsoft.com/office/drawing/2014/main" id="{529CB17C-C55F-4893-92AD-7F2A40381BCE}"/>
               </a:ext>
             </a:extLst>
           </p:cNvPr>
@@ -5580,7 +5526,6 @@
           <a:lstStyle xmlns:a="http://schemas.openxmlformats.org/drawingml/2006/main"/>
           <a:p xmlns:a="http://schemas.openxmlformats.org/drawingml/2006/main">
             <a:pPr algn="l">
-              <a:buNone/>
               <a:defRPr sz="1200" b="0">
                 <a:solidFill>
                   <a:srgbClr val="53606A"/>
@@ -5603,7 +5548,7 @@
           <p:cNvPr id="14" name="mitigation-footnote">
             <a:extLst xmlns:a="http://schemas.openxmlformats.org/drawingml/2006/main">
               <a:ext uri="{FF2B5EF4-FFF2-40B4-BE49-F238E27FC236}">
-                <a16:creationId xmlns:a16="http://schemas.microsoft.com/office/drawing/2014/main" id="{EABE7327-9B85-445C-93CE-07EAFE608E86}"/>
+                <a16:creationId xmlns:a16="http://schemas.microsoft.com/office/drawing/2014/main" id="{7E67D18C-14B9-4534-9ECE-1FDF846EE019}"/>
               </a:ext>
             </a:extLst>
           </p:cNvPr>
@@ -5631,7 +5576,6 @@
           <a:lstStyle xmlns:a="http://schemas.openxmlformats.org/drawingml/2006/main"/>
           <a:p xmlns:a="http://schemas.openxmlformats.org/drawingml/2006/main">
             <a:pPr algn="l">
-              <a:buNone/>
               <a:defRPr sz="1050" b="0">
                 <a:solidFill>
                   <a:srgbClr val="53606A"/>
@@ -5652,7 +5596,7 @@
     </p:spTree>
     <p:extLst>
       <p:ext uri="{BB962C8B-B14F-4D97-AF65-F5344CB8AC3E}">
-        <p14:creationId xmlns:p14="http://schemas.microsoft.com/office/powerpoint/2010/main" val="1965476266"/>
+        <p14:creationId xmlns:p14="http://schemas.microsoft.com/office/powerpoint/2010/main" val="2133355930"/>
       </p:ext>
     </p:extLst>
   </p:cSld>
@@ -5683,7 +5627,7 @@
           <p:cNvPr id="22" name="slide-6-title">
             <a:extLst xmlns:a="http://schemas.openxmlformats.org/drawingml/2006/main">
               <a:ext uri="{FF2B5EF4-FFF2-40B4-BE49-F238E27FC236}">
-                <a16:creationId xmlns:a16="http://schemas.microsoft.com/office/drawing/2014/main" id="{030B389C-D8DD-4004-BAC8-96426B4B8514}"/>
+                <a16:creationId xmlns:a16="http://schemas.microsoft.com/office/drawing/2014/main" id="{65030833-ABE2-4A87-B659-B817930E9771}"/>
               </a:ext>
             </a:extLst>
           </p:cNvPr>
@@ -5711,7 +5655,6 @@
           <a:lstStyle xmlns:a="http://schemas.openxmlformats.org/drawingml/2006/main"/>
           <a:p xmlns:a="http://schemas.openxmlformats.org/drawingml/2006/main">
             <a:pPr algn="l">
-              <a:buNone/>
               <a:defRPr sz="2850" b="1">
                 <a:solidFill>
                   <a:srgbClr val="101418"/>
@@ -5734,7 +5677,7 @@
           <p:cNvPr id="2" name="slide-6-number">
             <a:extLst xmlns:a="http://schemas.openxmlformats.org/drawingml/2006/main">
               <a:ext uri="{FF2B5EF4-FFF2-40B4-BE49-F238E27FC236}">
-                <a16:creationId xmlns:a16="http://schemas.microsoft.com/office/drawing/2014/main" id="{DAE11279-709E-422D-9E46-5866071AD9D3}"/>
+                <a16:creationId xmlns:a16="http://schemas.microsoft.com/office/drawing/2014/main" id="{1858E37D-0591-4DEF-BB33-05C6EC5EA849}"/>
               </a:ext>
             </a:extLst>
           </p:cNvPr>
@@ -5762,7 +5705,6 @@
           <a:lstStyle xmlns:a="http://schemas.openxmlformats.org/drawingml/2006/main"/>
           <a:p xmlns:a="http://schemas.openxmlformats.org/drawingml/2006/main">
             <a:pPr algn="r">
-              <a:buNone/>
               <a:defRPr sz="1050" b="0">
                 <a:solidFill>
                   <a:srgbClr val="53606A"/>
@@ -5785,7 +5727,7 @@
           <p:cNvPr id="3" name="slide-6-rule">
             <a:extLst xmlns:a="http://schemas.openxmlformats.org/drawingml/2006/main">
               <a:ext uri="{FF2B5EF4-FFF2-40B4-BE49-F238E27FC236}">
-                <a16:creationId xmlns:a16="http://schemas.microsoft.com/office/drawing/2014/main" id="{5F35181C-F848-4754-BF54-8818553A9E4A}"/>
+                <a16:creationId xmlns:a16="http://schemas.microsoft.com/office/drawing/2014/main" id="{BA671149-44EB-4483-8EBA-D22C84D9C4A0}"/>
               </a:ext>
             </a:extLst>
           </p:cNvPr>
@@ -5816,7 +5758,7 @@
           <p:cNvPr id="4" name="rec-0-number">
             <a:extLst xmlns:a="http://schemas.openxmlformats.org/drawingml/2006/main">
               <a:ext uri="{FF2B5EF4-FFF2-40B4-BE49-F238E27FC236}">
-                <a16:creationId xmlns:a16="http://schemas.microsoft.com/office/drawing/2014/main" id="{4A32B3E1-0C15-4F5B-AD4D-DC807BF69A00}"/>
+                <a16:creationId xmlns:a16="http://schemas.microsoft.com/office/drawing/2014/main" id="{C6CD347A-8A0C-461B-AAB4-651FED8661E4}"/>
               </a:ext>
             </a:extLst>
           </p:cNvPr>
@@ -5844,7 +5786,6 @@
           <a:lstStyle xmlns:a="http://schemas.openxmlformats.org/drawingml/2006/main"/>
           <a:p xmlns:a="http://schemas.openxmlformats.org/drawingml/2006/main">
             <a:pPr algn="l">
-              <a:buNone/>
               <a:defRPr sz="1200" b="1">
                 <a:solidFill>
                   <a:srgbClr val="3D8DFF"/>
@@ -5867,7 +5808,7 @@
           <p:cNvPr id="5" name="rec-0-title">
             <a:extLst xmlns:a="http://schemas.openxmlformats.org/drawingml/2006/main">
               <a:ext uri="{FF2B5EF4-FFF2-40B4-BE49-F238E27FC236}">
-                <a16:creationId xmlns:a16="http://schemas.microsoft.com/office/drawing/2014/main" id="{F4BAA5AF-0F5C-4274-BA1B-2F5135262DD6}"/>
+                <a16:creationId xmlns:a16="http://schemas.microsoft.com/office/drawing/2014/main" id="{D6B9E1B4-9617-4954-BE9D-6C1A2B3F8558}"/>
               </a:ext>
             </a:extLst>
           </p:cNvPr>
@@ -5895,7 +5836,6 @@
           <a:lstStyle xmlns:a="http://schemas.openxmlformats.org/drawingml/2006/main"/>
           <a:p xmlns:a="http://schemas.openxmlformats.org/drawingml/2006/main">
             <a:pPr algn="l">
-              <a:buNone/>
               <a:defRPr sz="1800" b="1">
                 <a:solidFill>
                   <a:srgbClr val="101418"/>
@@ -5918,7 +5858,7 @@
           <p:cNvPr id="6" name="rec-0-rule">
             <a:extLst xmlns:a="http://schemas.openxmlformats.org/drawingml/2006/main">
               <a:ext uri="{FF2B5EF4-FFF2-40B4-BE49-F238E27FC236}">
-                <a16:creationId xmlns:a16="http://schemas.microsoft.com/office/drawing/2014/main" id="{E2471815-CEB4-4E95-AA19-A96CC85FF945}"/>
+                <a16:creationId xmlns:a16="http://schemas.microsoft.com/office/drawing/2014/main" id="{22DFD7F0-3ACB-483E-953E-6DE1A5CD6010}"/>
               </a:ext>
             </a:extLst>
           </p:cNvPr>
@@ -5949,7 +5889,7 @@
           <p:cNvPr id="7" name="rec-0-body">
             <a:extLst xmlns:a="http://schemas.openxmlformats.org/drawingml/2006/main">
               <a:ext uri="{FF2B5EF4-FFF2-40B4-BE49-F238E27FC236}">
-                <a16:creationId xmlns:a16="http://schemas.microsoft.com/office/drawing/2014/main" id="{E41226BD-95C3-4E86-A604-696C0F2AE455}"/>
+                <a16:creationId xmlns:a16="http://schemas.microsoft.com/office/drawing/2014/main" id="{C79D9E20-3ECE-4FED-8896-853E0FC1229A}"/>
               </a:ext>
             </a:extLst>
           </p:cNvPr>
@@ -5977,7 +5917,6 @@
           <a:lstStyle xmlns:a="http://schemas.openxmlformats.org/drawingml/2006/main"/>
           <a:p xmlns:a="http://schemas.openxmlformats.org/drawingml/2006/main">
             <a:pPr algn="l">
-              <a:buNone/>
               <a:defRPr sz="1350" b="0">
                 <a:solidFill>
                   <a:srgbClr val="53606A"/>
@@ -6000,7 +5939,7 @@
           <p:cNvPr id="8" name="rec-1-number">
             <a:extLst xmlns:a="http://schemas.openxmlformats.org/drawingml/2006/main">
               <a:ext uri="{FF2B5EF4-FFF2-40B4-BE49-F238E27FC236}">
-                <a16:creationId xmlns:a16="http://schemas.microsoft.com/office/drawing/2014/main" id="{50871C28-8152-4BFA-B298-DA1133BD6E05}"/>
+                <a16:creationId xmlns:a16="http://schemas.microsoft.com/office/drawing/2014/main" id="{B6D2C461-299D-4C95-BACD-AEC64D4EEC9D}"/>
               </a:ext>
             </a:extLst>
           </p:cNvPr>
@@ -6028,7 +5967,6 @@
           <a:lstStyle xmlns:a="http://schemas.openxmlformats.org/drawingml/2006/main"/>
           <a:p xmlns:a="http://schemas.openxmlformats.org/drawingml/2006/main">
             <a:pPr algn="l">
-              <a:buNone/>
               <a:defRPr sz="1200" b="1">
                 <a:solidFill>
                   <a:srgbClr val="3D8DFF"/>
@@ -6051,7 +5989,7 @@
           <p:cNvPr id="9" name="rec-1-title">
             <a:extLst xmlns:a="http://schemas.openxmlformats.org/drawingml/2006/main">
               <a:ext uri="{FF2B5EF4-FFF2-40B4-BE49-F238E27FC236}">
-                <a16:creationId xmlns:a16="http://schemas.microsoft.com/office/drawing/2014/main" id="{30549C3D-E451-472F-8201-2A0C1AFAEF5D}"/>
+                <a16:creationId xmlns:a16="http://schemas.microsoft.com/office/drawing/2014/main" id="{59BC1887-A9D9-4D30-A229-167CD6D80800}"/>
               </a:ext>
             </a:extLst>
           </p:cNvPr>
@@ -6079,7 +6017,6 @@
           <a:lstStyle xmlns:a="http://schemas.openxmlformats.org/drawingml/2006/main"/>
           <a:p xmlns:a="http://schemas.openxmlformats.org/drawingml/2006/main">
             <a:pPr algn="l">
-              <a:buNone/>
               <a:defRPr sz="1800" b="1">
                 <a:solidFill>
                   <a:srgbClr val="101418"/>
@@ -6102,7 +6039,7 @@
           <p:cNvPr id="10" name="rec-1-rule">
             <a:extLst xmlns:a="http://schemas.openxmlformats.org/drawingml/2006/main">
               <a:ext uri="{FF2B5EF4-FFF2-40B4-BE49-F238E27FC236}">
-                <a16:creationId xmlns:a16="http://schemas.microsoft.com/office/drawing/2014/main" id="{CEB154E4-5980-40E6-BF8F-E9C335549F84}"/>
+                <a16:creationId xmlns:a16="http://schemas.microsoft.com/office/drawing/2014/main" id="{1BAB760D-E3F9-40C4-8853-ADAF7A694FAB}"/>
               </a:ext>
             </a:extLst>
           </p:cNvPr>
@@ -6133,7 +6070,7 @@
           <p:cNvPr id="11" name="rec-1-body">
             <a:extLst xmlns:a="http://schemas.openxmlformats.org/drawingml/2006/main">
               <a:ext uri="{FF2B5EF4-FFF2-40B4-BE49-F238E27FC236}">
-                <a16:creationId xmlns:a16="http://schemas.microsoft.com/office/drawing/2014/main" id="{CF1C6859-96F2-48A5-B3A1-2FB16D4D5B2E}"/>
+                <a16:creationId xmlns:a16="http://schemas.microsoft.com/office/drawing/2014/main" id="{D37C1B47-3081-4D6B-A3FD-D248D13C27F3}"/>
               </a:ext>
             </a:extLst>
           </p:cNvPr>
@@ -6161,7 +6098,6 @@
           <a:lstStyle xmlns:a="http://schemas.openxmlformats.org/drawingml/2006/main"/>
           <a:p xmlns:a="http://schemas.openxmlformats.org/drawingml/2006/main">
             <a:pPr algn="l">
-              <a:buNone/>
               <a:defRPr sz="1350" b="0">
                 <a:solidFill>
                   <a:srgbClr val="53606A"/>
@@ -6184,7 +6120,7 @@
           <p:cNvPr id="12" name="rec-2-number">
             <a:extLst xmlns:a="http://schemas.openxmlformats.org/drawingml/2006/main">
               <a:ext uri="{FF2B5EF4-FFF2-40B4-BE49-F238E27FC236}">
-                <a16:creationId xmlns:a16="http://schemas.microsoft.com/office/drawing/2014/main" id="{04094D94-1761-4961-B0BD-EEF9F046CD00}"/>
+                <a16:creationId xmlns:a16="http://schemas.microsoft.com/office/drawing/2014/main" id="{D50848B5-F977-4D66-B9AB-5698AE67ADEA}"/>
               </a:ext>
             </a:extLst>
           </p:cNvPr>
@@ -6212,7 +6148,6 @@
           <a:lstStyle xmlns:a="http://schemas.openxmlformats.org/drawingml/2006/main"/>
           <a:p xmlns:a="http://schemas.openxmlformats.org/drawingml/2006/main">
             <a:pPr algn="l">
-              <a:buNone/>
               <a:defRPr sz="1200" b="1">
                 <a:solidFill>
                   <a:srgbClr val="3D8DFF"/>
@@ -6235,7 +6170,7 @@
           <p:cNvPr id="13" name="rec-2-title">
             <a:extLst xmlns:a="http://schemas.openxmlformats.org/drawingml/2006/main">
               <a:ext uri="{FF2B5EF4-FFF2-40B4-BE49-F238E27FC236}">
-                <a16:creationId xmlns:a16="http://schemas.microsoft.com/office/drawing/2014/main" id="{AC6C0C3B-F1E2-46A3-ADEF-71D14D3C50F8}"/>
+                <a16:creationId xmlns:a16="http://schemas.microsoft.com/office/drawing/2014/main" id="{F20F63F8-EC82-4E07-A098-AD0072748AE4}"/>
               </a:ext>
             </a:extLst>
           </p:cNvPr>
@@ -6263,7 +6198,6 @@
           <a:lstStyle xmlns:a="http://schemas.openxmlformats.org/drawingml/2006/main"/>
           <a:p xmlns:a="http://schemas.openxmlformats.org/drawingml/2006/main">
             <a:pPr algn="l">
-              <a:buNone/>
               <a:defRPr sz="1800" b="1">
                 <a:solidFill>
                   <a:srgbClr val="101418"/>
@@ -6286,7 +6220,7 @@
           <p:cNvPr id="14" name="rec-2-rule">
             <a:extLst xmlns:a="http://schemas.openxmlformats.org/drawingml/2006/main">
               <a:ext uri="{FF2B5EF4-FFF2-40B4-BE49-F238E27FC236}">
-                <a16:creationId xmlns:a16="http://schemas.microsoft.com/office/drawing/2014/main" id="{09F653DC-6C28-4282-800A-C11934CD909A}"/>
+                <a16:creationId xmlns:a16="http://schemas.microsoft.com/office/drawing/2014/main" id="{44933FBA-8C1B-43D6-9720-3AABC62650A8}"/>
               </a:ext>
             </a:extLst>
           </p:cNvPr>
@@ -6317,7 +6251,7 @@
           <p:cNvPr id="15" name="rec-2-body">
             <a:extLst xmlns:a="http://schemas.openxmlformats.org/drawingml/2006/main">
               <a:ext uri="{FF2B5EF4-FFF2-40B4-BE49-F238E27FC236}">
-                <a16:creationId xmlns:a16="http://schemas.microsoft.com/office/drawing/2014/main" id="{66DFD064-C985-41C0-AB78-96B56D0EAF74}"/>
+                <a16:creationId xmlns:a16="http://schemas.microsoft.com/office/drawing/2014/main" id="{6F8779CD-3667-47A1-A9F2-C2C1253DE629}"/>
               </a:ext>
             </a:extLst>
           </p:cNvPr>
@@ -6345,7 +6279,6 @@
           <a:lstStyle xmlns:a="http://schemas.openxmlformats.org/drawingml/2006/main"/>
           <a:p xmlns:a="http://schemas.openxmlformats.org/drawingml/2006/main">
             <a:pPr algn="l">
-              <a:buNone/>
               <a:defRPr sz="1350" b="0">
                 <a:solidFill>
                   <a:srgbClr val="53606A"/>
@@ -6368,7 +6301,7 @@
           <p:cNvPr id="16" name="rec-3-number">
             <a:extLst xmlns:a="http://schemas.openxmlformats.org/drawingml/2006/main">
               <a:ext uri="{FF2B5EF4-FFF2-40B4-BE49-F238E27FC236}">
-                <a16:creationId xmlns:a16="http://schemas.microsoft.com/office/drawing/2014/main" id="{5316B282-9E28-4EFD-A149-312A92E0A0AB}"/>
+                <a16:creationId xmlns:a16="http://schemas.microsoft.com/office/drawing/2014/main" id="{A4BCD751-C7EB-4F0E-9C7F-713C81E6D807}"/>
               </a:ext>
             </a:extLst>
           </p:cNvPr>
@@ -6396,7 +6329,6 @@
           <a:lstStyle xmlns:a="http://schemas.openxmlformats.org/drawingml/2006/main"/>
           <a:p xmlns:a="http://schemas.openxmlformats.org/drawingml/2006/main">
             <a:pPr algn="l">
-              <a:buNone/>
               <a:defRPr sz="1200" b="1">
                 <a:solidFill>
                   <a:srgbClr val="3D8DFF"/>
@@ -6419,7 +6351,7 @@
           <p:cNvPr id="17" name="rec-3-title">
             <a:extLst xmlns:a="http://schemas.openxmlformats.org/drawingml/2006/main">
               <a:ext uri="{FF2B5EF4-FFF2-40B4-BE49-F238E27FC236}">
-                <a16:creationId xmlns:a16="http://schemas.microsoft.com/office/drawing/2014/main" id="{41F2CA98-B435-4AB8-9A36-7D9689EE2140}"/>
+                <a16:creationId xmlns:a16="http://schemas.microsoft.com/office/drawing/2014/main" id="{13C5A8D4-4CE3-4AF5-8521-08AFCCE2DEE5}"/>
               </a:ext>
             </a:extLst>
           </p:cNvPr>
@@ -6447,7 +6379,6 @@
           <a:lstStyle xmlns:a="http://schemas.openxmlformats.org/drawingml/2006/main"/>
           <a:p xmlns:a="http://schemas.openxmlformats.org/drawingml/2006/main">
             <a:pPr algn="l">
-              <a:buNone/>
               <a:defRPr sz="1800" b="1">
                 <a:solidFill>
                   <a:srgbClr val="101418"/>
@@ -6470,7 +6401,7 @@
           <p:cNvPr id="18" name="rec-3-rule">
             <a:extLst xmlns:a="http://schemas.openxmlformats.org/drawingml/2006/main">
               <a:ext uri="{FF2B5EF4-FFF2-40B4-BE49-F238E27FC236}">
-                <a16:creationId xmlns:a16="http://schemas.microsoft.com/office/drawing/2014/main" id="{87762FC5-1FA4-43E4-9160-CE810982D13B}"/>
+                <a16:creationId xmlns:a16="http://schemas.microsoft.com/office/drawing/2014/main" id="{E426B7E8-E290-48A5-950F-7F32D6BDF7BE}"/>
               </a:ext>
             </a:extLst>
           </p:cNvPr>
@@ -6501,7 +6432,7 @@
           <p:cNvPr id="19" name="rec-3-body">
             <a:extLst xmlns:a="http://schemas.openxmlformats.org/drawingml/2006/main">
               <a:ext uri="{FF2B5EF4-FFF2-40B4-BE49-F238E27FC236}">
-                <a16:creationId xmlns:a16="http://schemas.microsoft.com/office/drawing/2014/main" id="{F261591E-1778-414F-9480-F9FEE0418F74}"/>
+                <a16:creationId xmlns:a16="http://schemas.microsoft.com/office/drawing/2014/main" id="{5CB54FBD-D14B-4A88-BD52-6C368F393367}"/>
               </a:ext>
             </a:extLst>
           </p:cNvPr>
@@ -6529,7 +6460,6 @@
           <a:lstStyle xmlns:a="http://schemas.openxmlformats.org/drawingml/2006/main"/>
           <a:p xmlns:a="http://schemas.openxmlformats.org/drawingml/2006/main">
             <a:pPr algn="l">
-              <a:buNone/>
               <a:defRPr sz="1350" b="0">
                 <a:solidFill>
                   <a:srgbClr val="53606A"/>
@@ -6552,7 +6482,7 @@
           <p:cNvPr id="20" name="closing-band">
             <a:extLst xmlns:a="http://schemas.openxmlformats.org/drawingml/2006/main">
               <a:ext uri="{FF2B5EF4-FFF2-40B4-BE49-F238E27FC236}">
-                <a16:creationId xmlns:a16="http://schemas.microsoft.com/office/drawing/2014/main" id="{A51880BA-5CFB-413B-A110-A4558993CAF8}"/>
+                <a16:creationId xmlns:a16="http://schemas.microsoft.com/office/drawing/2014/main" id="{9A6B7FF2-3540-4DB3-8724-983ADD488D93}"/>
               </a:ext>
             </a:extLst>
           </p:cNvPr>
@@ -6583,7 +6513,7 @@
           <p:cNvPr id="21" name="closing-message">
             <a:extLst xmlns:a="http://schemas.openxmlformats.org/drawingml/2006/main">
               <a:ext uri="{FF2B5EF4-FFF2-40B4-BE49-F238E27FC236}">
-                <a16:creationId xmlns:a16="http://schemas.microsoft.com/office/drawing/2014/main" id="{939A9875-EECD-4D27-9829-D90DC8A9A18E}"/>
+                <a16:creationId xmlns:a16="http://schemas.microsoft.com/office/drawing/2014/main" id="{A45A1C5F-0DCF-435F-80D0-A94FBA89BC46}"/>
               </a:ext>
             </a:extLst>
           </p:cNvPr>
@@ -6611,7 +6541,6 @@
           <a:lstStyle xmlns:a="http://schemas.openxmlformats.org/drawingml/2006/main"/>
           <a:p xmlns:a="http://schemas.openxmlformats.org/drawingml/2006/main">
             <a:pPr algn="ctr">
-              <a:buNone/>
               <a:defRPr sz="1875" b="1">
                 <a:solidFill>
                   <a:srgbClr val="FFFFFF"/>
@@ -6632,7 +6561,7 @@
     </p:spTree>
     <p:extLst>
       <p:ext uri="{BB962C8B-B14F-4D97-AF65-F5344CB8AC3E}">
-        <p14:creationId xmlns:p14="http://schemas.microsoft.com/office/powerpoint/2010/main" val="355629038"/>
+        <p14:creationId xmlns:p14="http://schemas.microsoft.com/office/powerpoint/2010/main" val="1887603265"/>
       </p:ext>
     </p:extLst>
   </p:cSld>

</xml_diff>

<commit_message>
Crop private sidebar from evidence screenshots
</commit_message>
<xml_diff>
--- a/submission/Presentation-z5557885.pptx
+++ b/submission/Presentation-z5557885.pptx
@@ -2,18 +2,18 @@
 <file path=ppt/presentation.xml><?xml version="1.0" encoding="utf-8"?>
 <p:presentation xmlns:p="http://schemas.openxmlformats.org/presentationml/2006/main">
   <p:sldMasterIdLst>
-    <p:sldMasterId xmlns:r="http://schemas.openxmlformats.org/officeDocument/2006/relationships" id="2147483648" r:id="Re7db2b0312f949a1"/>
+    <p:sldMasterId xmlns:r="http://schemas.openxmlformats.org/officeDocument/2006/relationships" id="2147483648" r:id="Rcd44f002f87e4a43"/>
   </p:sldMasterIdLst>
   <p:notesMasterIdLst>
-    <p:notesMasterId xmlns:r="http://schemas.openxmlformats.org/officeDocument/2006/relationships" r:id="R602dcdd259d04d36"/>
+    <p:notesMasterId xmlns:r="http://schemas.openxmlformats.org/officeDocument/2006/relationships" r:id="Ra2670cb9d0d1452c"/>
   </p:notesMasterIdLst>
   <p:sldIdLst>
-    <p:sldId xmlns:r="http://schemas.openxmlformats.org/officeDocument/2006/relationships" id="256" r:id="Rfe6d67c68eac42b4"/>
-    <p:sldId xmlns:r="http://schemas.openxmlformats.org/officeDocument/2006/relationships" id="257" r:id="Rd145faaaa3904a7c"/>
-    <p:sldId xmlns:r="http://schemas.openxmlformats.org/officeDocument/2006/relationships" id="258" r:id="R23a79d3f67104d3d"/>
-    <p:sldId xmlns:r="http://schemas.openxmlformats.org/officeDocument/2006/relationships" id="259" r:id="R47c7accd549e4489"/>
-    <p:sldId xmlns:r="http://schemas.openxmlformats.org/officeDocument/2006/relationships" id="260" r:id="R8e841c161e384c5f"/>
-    <p:sldId xmlns:r="http://schemas.openxmlformats.org/officeDocument/2006/relationships" id="261" r:id="R649b9d84d28a4581"/>
+    <p:sldId xmlns:r="http://schemas.openxmlformats.org/officeDocument/2006/relationships" id="256" r:id="R1630b086a5b949c0"/>
+    <p:sldId xmlns:r="http://schemas.openxmlformats.org/officeDocument/2006/relationships" id="257" r:id="Rb2fb0dad30954e7d"/>
+    <p:sldId xmlns:r="http://schemas.openxmlformats.org/officeDocument/2006/relationships" id="258" r:id="R0e15b8ee8db1490a"/>
+    <p:sldId xmlns:r="http://schemas.openxmlformats.org/officeDocument/2006/relationships" id="259" r:id="R2711882d940941e4"/>
+    <p:sldId xmlns:r="http://schemas.openxmlformats.org/officeDocument/2006/relationships" id="260" r:id="Rdb18836c06f44cf1"/>
+    <p:sldId xmlns:r="http://schemas.openxmlformats.org/officeDocument/2006/relationships" id="261" r:id="R0ee8fc30f39a41e3"/>
   </p:sldIdLst>
   <p:sldSz cx="12192000" cy="6858000"/>
   <p:notesSz cx="6858000" cy="9144000"/>
@@ -841,7 +841,7 @@
   </p:cSld>
   <p:clrMap bg1="lt1" tx1="dk1" bg2="lt2" tx2="dk2" accent1="accent1" accent2="accent2" accent3="accent3" accent4="accent4" accent5="accent5" accent6="accent6" hlink="hlink" folHlink="folHlink"/>
   <p:sldLayoutIdLst>
-    <p:sldLayoutId xmlns:r="http://schemas.openxmlformats.org/officeDocument/2006/relationships" id="2147483649" r:id="R625f20a3a9dc46ea"/>
+    <p:sldLayoutId xmlns:r="http://schemas.openxmlformats.org/officeDocument/2006/relationships" id="2147483649" r:id="R3e8ac31b443b4982"/>
   </p:sldLayoutIdLst>
   <p:txStyles>
     <p:titleStyle>
@@ -1700,7 +1700,7 @@
           <p:cNvPr id="19" name="course-label-bg">
             <a:extLst xmlns:a="http://schemas.openxmlformats.org/drawingml/2006/main">
               <a:ext uri="{FF2B5EF4-FFF2-40B4-BE49-F238E27FC236}">
-                <a16:creationId xmlns:a16="http://schemas.microsoft.com/office/drawing/2014/main" id="{8B7A106D-F18A-46E5-9873-885097DA736E}"/>
+                <a16:creationId xmlns:a16="http://schemas.microsoft.com/office/drawing/2014/main" id="{0998282F-3D9F-4981-BD1C-F21EBFFB8642}"/>
               </a:ext>
             </a:extLst>
           </p:cNvPr>
@@ -1731,7 +1731,7 @@
           <p:cNvPr id="2" name="course-label">
             <a:extLst xmlns:a="http://schemas.openxmlformats.org/drawingml/2006/main">
               <a:ext uri="{FF2B5EF4-FFF2-40B4-BE49-F238E27FC236}">
-                <a16:creationId xmlns:a16="http://schemas.microsoft.com/office/drawing/2014/main" id="{A5D17EAF-7402-4B46-8F17-797B824FC249}"/>
+                <a16:creationId xmlns:a16="http://schemas.microsoft.com/office/drawing/2014/main" id="{A1A59E2C-5468-4076-B166-55B8AA1CB091}"/>
               </a:ext>
             </a:extLst>
           </p:cNvPr>
@@ -1781,7 +1781,7 @@
           <p:cNvPr id="3" name="cover-title">
             <a:extLst xmlns:a="http://schemas.openxmlformats.org/drawingml/2006/main">
               <a:ext uri="{FF2B5EF4-FFF2-40B4-BE49-F238E27FC236}">
-                <a16:creationId xmlns:a16="http://schemas.microsoft.com/office/drawing/2014/main" id="{97B65AD7-64C5-4488-85DC-9E621686B03D}"/>
+                <a16:creationId xmlns:a16="http://schemas.microsoft.com/office/drawing/2014/main" id="{C79C8387-07BA-4F3A-B427-E1BDBB95E176}"/>
               </a:ext>
             </a:extLst>
           </p:cNvPr>
@@ -1848,7 +1848,7 @@
           <p:cNvPr id="4" name="cover-subtitle">
             <a:extLst xmlns:a="http://schemas.openxmlformats.org/drawingml/2006/main">
               <a:ext uri="{FF2B5EF4-FFF2-40B4-BE49-F238E27FC236}">
-                <a16:creationId xmlns:a16="http://schemas.microsoft.com/office/drawing/2014/main" id="{8370FE21-C88D-41B4-8011-ADDD0A779E0B}"/>
+                <a16:creationId xmlns:a16="http://schemas.microsoft.com/office/drawing/2014/main" id="{D6D996C5-1747-4958-B71C-4D0E0E9BEA7E}"/>
               </a:ext>
             </a:extLst>
           </p:cNvPr>
@@ -1898,7 +1898,7 @@
           <p:cNvPr id="5" name="fragment-0-panel">
             <a:extLst xmlns:a="http://schemas.openxmlformats.org/drawingml/2006/main">
               <a:ext uri="{FF2B5EF4-FFF2-40B4-BE49-F238E27FC236}">
-                <a16:creationId xmlns:a16="http://schemas.microsoft.com/office/drawing/2014/main" id="{819AFCAB-F617-4D40-A5E4-C0A7719ECE85}"/>
+                <a16:creationId xmlns:a16="http://schemas.microsoft.com/office/drawing/2014/main" id="{B1C72976-2F2F-498F-A136-B67DDC15A912}"/>
               </a:ext>
             </a:extLst>
           </p:cNvPr>
@@ -1929,7 +1929,7 @@
           <p:cNvPr id="6" name="fragment-0">
             <a:extLst xmlns:a="http://schemas.openxmlformats.org/drawingml/2006/main">
               <a:ext uri="{FF2B5EF4-FFF2-40B4-BE49-F238E27FC236}">
-                <a16:creationId xmlns:a16="http://schemas.microsoft.com/office/drawing/2014/main" id="{863561B3-249B-4655-9EE2-CA97ABF41FB3}"/>
+                <a16:creationId xmlns:a16="http://schemas.microsoft.com/office/drawing/2014/main" id="{8EE9298A-BA11-4358-ACCE-F5298560D677}"/>
               </a:ext>
             </a:extLst>
           </p:cNvPr>
@@ -1979,7 +1979,7 @@
           <p:cNvPr id="7" name="fragment-1-panel">
             <a:extLst xmlns:a="http://schemas.openxmlformats.org/drawingml/2006/main">
               <a:ext uri="{FF2B5EF4-FFF2-40B4-BE49-F238E27FC236}">
-                <a16:creationId xmlns:a16="http://schemas.microsoft.com/office/drawing/2014/main" id="{37ECD8DC-CE07-499F-87EA-385C1510E6B2}"/>
+                <a16:creationId xmlns:a16="http://schemas.microsoft.com/office/drawing/2014/main" id="{3D9B357C-1C64-4559-B3ED-D33F622AC446}"/>
               </a:ext>
             </a:extLst>
           </p:cNvPr>
@@ -2010,7 +2010,7 @@
           <p:cNvPr id="8" name="fragment-1">
             <a:extLst xmlns:a="http://schemas.openxmlformats.org/drawingml/2006/main">
               <a:ext uri="{FF2B5EF4-FFF2-40B4-BE49-F238E27FC236}">
-                <a16:creationId xmlns:a16="http://schemas.microsoft.com/office/drawing/2014/main" id="{2532385D-DE14-4818-82DE-3CFA74B076D4}"/>
+                <a16:creationId xmlns:a16="http://schemas.microsoft.com/office/drawing/2014/main" id="{52DF482D-BFC8-4AA2-9BA9-944F9EDF1057}"/>
               </a:ext>
             </a:extLst>
           </p:cNvPr>
@@ -2060,7 +2060,7 @@
           <p:cNvPr id="9" name="fragment-2-panel">
             <a:extLst xmlns:a="http://schemas.openxmlformats.org/drawingml/2006/main">
               <a:ext uri="{FF2B5EF4-FFF2-40B4-BE49-F238E27FC236}">
-                <a16:creationId xmlns:a16="http://schemas.microsoft.com/office/drawing/2014/main" id="{06AE824E-BE9F-4448-BFD4-C34631FD7232}"/>
+                <a16:creationId xmlns:a16="http://schemas.microsoft.com/office/drawing/2014/main" id="{6FC75875-528B-41B9-98E2-BF152236C709}"/>
               </a:ext>
             </a:extLst>
           </p:cNvPr>
@@ -2091,7 +2091,7 @@
           <p:cNvPr id="10" name="fragment-2">
             <a:extLst xmlns:a="http://schemas.openxmlformats.org/drawingml/2006/main">
               <a:ext uri="{FF2B5EF4-FFF2-40B4-BE49-F238E27FC236}">
-                <a16:creationId xmlns:a16="http://schemas.microsoft.com/office/drawing/2014/main" id="{722776A5-5BFA-43CE-95A1-4D8BEDB3227D}"/>
+                <a16:creationId xmlns:a16="http://schemas.microsoft.com/office/drawing/2014/main" id="{7377B57D-8D4E-4700-A901-2479A008AC51}"/>
               </a:ext>
             </a:extLst>
           </p:cNvPr>
@@ -2141,7 +2141,7 @@
           <p:cNvPr id="11" name="fragment-3-panel">
             <a:extLst xmlns:a="http://schemas.openxmlformats.org/drawingml/2006/main">
               <a:ext uri="{FF2B5EF4-FFF2-40B4-BE49-F238E27FC236}">
-                <a16:creationId xmlns:a16="http://schemas.microsoft.com/office/drawing/2014/main" id="{83E7A255-69E2-4760-8FFE-74B45F595D95}"/>
+                <a16:creationId xmlns:a16="http://schemas.microsoft.com/office/drawing/2014/main" id="{62E4530B-6D39-48F9-8510-B5B942F24B5A}"/>
               </a:ext>
             </a:extLst>
           </p:cNvPr>
@@ -2172,7 +2172,7 @@
           <p:cNvPr id="12" name="fragment-3">
             <a:extLst xmlns:a="http://schemas.openxmlformats.org/drawingml/2006/main">
               <a:ext uri="{FF2B5EF4-FFF2-40B4-BE49-F238E27FC236}">
-                <a16:creationId xmlns:a16="http://schemas.microsoft.com/office/drawing/2014/main" id="{96E1744B-A81A-41C6-AD2D-58626F1C1C76}"/>
+                <a16:creationId xmlns:a16="http://schemas.microsoft.com/office/drawing/2014/main" id="{C7F7C56C-A21B-4043-A954-EA9902ED63D6}"/>
               </a:ext>
             </a:extLst>
           </p:cNvPr>
@@ -2222,7 +2222,7 @@
           <p:cNvPr id="13" name="fragment-4-panel">
             <a:extLst xmlns:a="http://schemas.openxmlformats.org/drawingml/2006/main">
               <a:ext uri="{FF2B5EF4-FFF2-40B4-BE49-F238E27FC236}">
-                <a16:creationId xmlns:a16="http://schemas.microsoft.com/office/drawing/2014/main" id="{BDE1312D-0FE5-4F93-AD45-FFE35D9F3CCC}"/>
+                <a16:creationId xmlns:a16="http://schemas.microsoft.com/office/drawing/2014/main" id="{0F8DF065-4458-4A9B-BE49-EA02CD4254B0}"/>
               </a:ext>
             </a:extLst>
           </p:cNvPr>
@@ -2253,7 +2253,7 @@
           <p:cNvPr id="14" name="fragment-4">
             <a:extLst xmlns:a="http://schemas.openxmlformats.org/drawingml/2006/main">
               <a:ext uri="{FF2B5EF4-FFF2-40B4-BE49-F238E27FC236}">
-                <a16:creationId xmlns:a16="http://schemas.microsoft.com/office/drawing/2014/main" id="{374B247F-A379-4FCD-9E43-2378E5C6187E}"/>
+                <a16:creationId xmlns:a16="http://schemas.microsoft.com/office/drawing/2014/main" id="{965DE796-CC7F-4CC4-A00C-81FF883E5FD1}"/>
               </a:ext>
             </a:extLst>
           </p:cNvPr>
@@ -2303,7 +2303,7 @@
           <p:cNvPr id="15" name="fragment-5-panel">
             <a:extLst xmlns:a="http://schemas.openxmlformats.org/drawingml/2006/main">
               <a:ext uri="{FF2B5EF4-FFF2-40B4-BE49-F238E27FC236}">
-                <a16:creationId xmlns:a16="http://schemas.microsoft.com/office/drawing/2014/main" id="{FAAC225B-2D08-422E-A7E2-0CF0CA0291FA}"/>
+                <a16:creationId xmlns:a16="http://schemas.microsoft.com/office/drawing/2014/main" id="{D4CB6FB4-A70B-4FCC-8E8B-0F59CADC07EB}"/>
               </a:ext>
             </a:extLst>
           </p:cNvPr>
@@ -2334,7 +2334,7 @@
           <p:cNvPr id="16" name="fragment-5">
             <a:extLst xmlns:a="http://schemas.openxmlformats.org/drawingml/2006/main">
               <a:ext uri="{FF2B5EF4-FFF2-40B4-BE49-F238E27FC236}">
-                <a16:creationId xmlns:a16="http://schemas.microsoft.com/office/drawing/2014/main" id="{5F3E3CAB-0071-47F9-96AC-507916E13784}"/>
+                <a16:creationId xmlns:a16="http://schemas.microsoft.com/office/drawing/2014/main" id="{1D9F1D6F-2013-4845-A9A3-4D793BDAF6EE}"/>
               </a:ext>
             </a:extLst>
           </p:cNvPr>
@@ -2384,7 +2384,7 @@
           <p:cNvPr id="17" name="cover-meta">
             <a:extLst xmlns:a="http://schemas.openxmlformats.org/drawingml/2006/main">
               <a:ext uri="{FF2B5EF4-FFF2-40B4-BE49-F238E27FC236}">
-                <a16:creationId xmlns:a16="http://schemas.microsoft.com/office/drawing/2014/main" id="{A1F5A050-26D1-4DF3-BCDD-AAE4DD0A71A3}"/>
+                <a16:creationId xmlns:a16="http://schemas.microsoft.com/office/drawing/2014/main" id="{95C54597-D430-4D7A-AA17-113031CBFAF0}"/>
               </a:ext>
             </a:extLst>
           </p:cNvPr>
@@ -2434,7 +2434,7 @@
           <p:cNvPr id="18" name="cover-takeaway">
             <a:extLst xmlns:a="http://schemas.openxmlformats.org/drawingml/2006/main">
               <a:ext uri="{FF2B5EF4-FFF2-40B4-BE49-F238E27FC236}">
-                <a16:creationId xmlns:a16="http://schemas.microsoft.com/office/drawing/2014/main" id="{EF6D9F45-0E1A-44C2-8071-52C85C93BCBC}"/>
+                <a16:creationId xmlns:a16="http://schemas.microsoft.com/office/drawing/2014/main" id="{FC186904-42B2-4AF9-AB8C-82DBE0B4653A}"/>
               </a:ext>
             </a:extLst>
           </p:cNvPr>
@@ -2482,7 +2482,7 @@
     </p:spTree>
     <p:extLst>
       <p:ext uri="{BB962C8B-B14F-4D97-AF65-F5344CB8AC3E}">
-        <p14:creationId xmlns:p14="http://schemas.microsoft.com/office/powerpoint/2010/main" val="1083164121"/>
+        <p14:creationId xmlns:p14="http://schemas.microsoft.com/office/powerpoint/2010/main" val="1262788162"/>
       </p:ext>
     </p:extLst>
   </p:cSld>
@@ -2513,7 +2513,7 @@
           <p:cNvPr id="25" name="slide-2-title">
             <a:extLst xmlns:a="http://schemas.openxmlformats.org/drawingml/2006/main">
               <a:ext uri="{FF2B5EF4-FFF2-40B4-BE49-F238E27FC236}">
-                <a16:creationId xmlns:a16="http://schemas.microsoft.com/office/drawing/2014/main" id="{C27C25DC-79E0-4214-ABAE-A996F59D9A7A}"/>
+                <a16:creationId xmlns:a16="http://schemas.microsoft.com/office/drawing/2014/main" id="{B0AF05F0-BD7C-42FA-A5B6-814CFA41D192}"/>
               </a:ext>
             </a:extLst>
           </p:cNvPr>
@@ -2563,7 +2563,7 @@
           <p:cNvPr id="2" name="slide-2-number">
             <a:extLst xmlns:a="http://schemas.openxmlformats.org/drawingml/2006/main">
               <a:ext uri="{FF2B5EF4-FFF2-40B4-BE49-F238E27FC236}">
-                <a16:creationId xmlns:a16="http://schemas.microsoft.com/office/drawing/2014/main" id="{2F3F3E9B-2726-4529-AB9B-202A26B07A45}"/>
+                <a16:creationId xmlns:a16="http://schemas.microsoft.com/office/drawing/2014/main" id="{8F083CE7-7B64-43CE-BFCD-AEC1D3F2516F}"/>
               </a:ext>
             </a:extLst>
           </p:cNvPr>
@@ -2613,7 +2613,7 @@
           <p:cNvPr id="3" name="slide-2-rule">
             <a:extLst xmlns:a="http://schemas.openxmlformats.org/drawingml/2006/main">
               <a:ext uri="{FF2B5EF4-FFF2-40B4-BE49-F238E27FC236}">
-                <a16:creationId xmlns:a16="http://schemas.microsoft.com/office/drawing/2014/main" id="{50C15724-0FF7-45B5-95B8-4073481FB675}"/>
+                <a16:creationId xmlns:a16="http://schemas.microsoft.com/office/drawing/2014/main" id="{938998CB-F944-4433-AD44-2F5DAEE51EA5}"/>
               </a:ext>
             </a:extLst>
           </p:cNvPr>
@@ -2644,7 +2644,7 @@
           <p:cNvPr id="4" name="flow-arrow-0">
             <a:extLst xmlns:a="http://schemas.openxmlformats.org/drawingml/2006/main">
               <a:ext uri="{FF2B5EF4-FFF2-40B4-BE49-F238E27FC236}">
-                <a16:creationId xmlns:a16="http://schemas.microsoft.com/office/drawing/2014/main" id="{DC4FC518-55B1-4534-844A-2324A6F932D0}"/>
+                <a16:creationId xmlns:a16="http://schemas.microsoft.com/office/drawing/2014/main" id="{C682374E-1BB4-408C-81AE-973CA9518D64}"/>
               </a:ext>
             </a:extLst>
           </p:cNvPr>
@@ -2675,7 +2675,7 @@
           <p:cNvPr id="5" name="flow-arrow-1">
             <a:extLst xmlns:a="http://schemas.openxmlformats.org/drawingml/2006/main">
               <a:ext uri="{FF2B5EF4-FFF2-40B4-BE49-F238E27FC236}">
-                <a16:creationId xmlns:a16="http://schemas.microsoft.com/office/drawing/2014/main" id="{B1358B6A-B73E-4EED-881A-8E2A2CA5F777}"/>
+                <a16:creationId xmlns:a16="http://schemas.microsoft.com/office/drawing/2014/main" id="{D3D7E16D-157E-4436-8D43-4146910C8A81}"/>
               </a:ext>
             </a:extLst>
           </p:cNvPr>
@@ -2706,7 +2706,7 @@
           <p:cNvPr id="6" name="flow-arrow-2">
             <a:extLst xmlns:a="http://schemas.openxmlformats.org/drawingml/2006/main">
               <a:ext uri="{FF2B5EF4-FFF2-40B4-BE49-F238E27FC236}">
-                <a16:creationId xmlns:a16="http://schemas.microsoft.com/office/drawing/2014/main" id="{35E783A4-DD10-463C-BF54-433F2AC2C62A}"/>
+                <a16:creationId xmlns:a16="http://schemas.microsoft.com/office/drawing/2014/main" id="{81000411-5828-47E7-86CC-0EA8F5DC5887}"/>
               </a:ext>
             </a:extLst>
           </p:cNvPr>
@@ -2737,7 +2737,7 @@
           <p:cNvPr id="7" name="flow-0-panel">
             <a:extLst xmlns:a="http://schemas.openxmlformats.org/drawingml/2006/main">
               <a:ext uri="{FF2B5EF4-FFF2-40B4-BE49-F238E27FC236}">
-                <a16:creationId xmlns:a16="http://schemas.microsoft.com/office/drawing/2014/main" id="{10E6F4CD-283F-4E90-9768-51042B0181B0}"/>
+                <a16:creationId xmlns:a16="http://schemas.microsoft.com/office/drawing/2014/main" id="{0E02A22A-5B7A-409D-98E3-8924CCE4B7E6}"/>
               </a:ext>
             </a:extLst>
           </p:cNvPr>
@@ -2768,7 +2768,7 @@
           <p:cNvPr id="8" name="flow-0-number">
             <a:extLst xmlns:a="http://schemas.openxmlformats.org/drawingml/2006/main">
               <a:ext uri="{FF2B5EF4-FFF2-40B4-BE49-F238E27FC236}">
-                <a16:creationId xmlns:a16="http://schemas.microsoft.com/office/drawing/2014/main" id="{8CA6A71D-8742-4BC9-980D-25C81EFB8B8E}"/>
+                <a16:creationId xmlns:a16="http://schemas.microsoft.com/office/drawing/2014/main" id="{EE82D1B0-8093-4EBA-9152-2478D31CF769}"/>
               </a:ext>
             </a:extLst>
           </p:cNvPr>
@@ -2818,7 +2818,7 @@
           <p:cNvPr id="9" name="flow-0-heading">
             <a:extLst xmlns:a="http://schemas.openxmlformats.org/drawingml/2006/main">
               <a:ext uri="{FF2B5EF4-FFF2-40B4-BE49-F238E27FC236}">
-                <a16:creationId xmlns:a16="http://schemas.microsoft.com/office/drawing/2014/main" id="{85B88CE4-CE8D-42D2-B209-F5DFDF060300}"/>
+                <a16:creationId xmlns:a16="http://schemas.microsoft.com/office/drawing/2014/main" id="{845D9422-A138-4683-A8F5-E267C16AB609}"/>
               </a:ext>
             </a:extLst>
           </p:cNvPr>
@@ -2868,7 +2868,7 @@
           <p:cNvPr id="10" name="flow-0-body">
             <a:extLst xmlns:a="http://schemas.openxmlformats.org/drawingml/2006/main">
               <a:ext uri="{FF2B5EF4-FFF2-40B4-BE49-F238E27FC236}">
-                <a16:creationId xmlns:a16="http://schemas.microsoft.com/office/drawing/2014/main" id="{D28215E4-1E4A-49C0-9A2B-F8AE02A02FA9}"/>
+                <a16:creationId xmlns:a16="http://schemas.microsoft.com/office/drawing/2014/main" id="{BBCE934C-B459-48F4-A126-81C162A9B716}"/>
               </a:ext>
             </a:extLst>
           </p:cNvPr>
@@ -2918,7 +2918,7 @@
           <p:cNvPr id="11" name="flow-1-panel">
             <a:extLst xmlns:a="http://schemas.openxmlformats.org/drawingml/2006/main">
               <a:ext uri="{FF2B5EF4-FFF2-40B4-BE49-F238E27FC236}">
-                <a16:creationId xmlns:a16="http://schemas.microsoft.com/office/drawing/2014/main" id="{16167B75-9675-43C1-B543-41B81DAED3FE}"/>
+                <a16:creationId xmlns:a16="http://schemas.microsoft.com/office/drawing/2014/main" id="{50EC1FF3-72DE-4870-A251-C74A39FD0039}"/>
               </a:ext>
             </a:extLst>
           </p:cNvPr>
@@ -2949,7 +2949,7 @@
           <p:cNvPr id="12" name="flow-1-number">
             <a:extLst xmlns:a="http://schemas.openxmlformats.org/drawingml/2006/main">
               <a:ext uri="{FF2B5EF4-FFF2-40B4-BE49-F238E27FC236}">
-                <a16:creationId xmlns:a16="http://schemas.microsoft.com/office/drawing/2014/main" id="{7AB388B0-9D3B-470C-B713-2A66D3080604}"/>
+                <a16:creationId xmlns:a16="http://schemas.microsoft.com/office/drawing/2014/main" id="{AF630C60-920C-48BC-A767-5010EF25A673}"/>
               </a:ext>
             </a:extLst>
           </p:cNvPr>
@@ -2999,7 +2999,7 @@
           <p:cNvPr id="13" name="flow-1-heading">
             <a:extLst xmlns:a="http://schemas.openxmlformats.org/drawingml/2006/main">
               <a:ext uri="{FF2B5EF4-FFF2-40B4-BE49-F238E27FC236}">
-                <a16:creationId xmlns:a16="http://schemas.microsoft.com/office/drawing/2014/main" id="{25C9801D-C627-4180-81A9-D2732C32BB35}"/>
+                <a16:creationId xmlns:a16="http://schemas.microsoft.com/office/drawing/2014/main" id="{9375BBB5-0407-434B-86BE-9EE077DC8B66}"/>
               </a:ext>
             </a:extLst>
           </p:cNvPr>
@@ -3049,7 +3049,7 @@
           <p:cNvPr id="14" name="flow-1-body">
             <a:extLst xmlns:a="http://schemas.openxmlformats.org/drawingml/2006/main">
               <a:ext uri="{FF2B5EF4-FFF2-40B4-BE49-F238E27FC236}">
-                <a16:creationId xmlns:a16="http://schemas.microsoft.com/office/drawing/2014/main" id="{F635560F-4A98-4A40-83E1-6BD06B3BB1C5}"/>
+                <a16:creationId xmlns:a16="http://schemas.microsoft.com/office/drawing/2014/main" id="{DEFA4C15-1B7D-4A42-BAC3-6913AA4D7528}"/>
               </a:ext>
             </a:extLst>
           </p:cNvPr>
@@ -3099,7 +3099,7 @@
           <p:cNvPr id="15" name="flow-2-panel">
             <a:extLst xmlns:a="http://schemas.openxmlformats.org/drawingml/2006/main">
               <a:ext uri="{FF2B5EF4-FFF2-40B4-BE49-F238E27FC236}">
-                <a16:creationId xmlns:a16="http://schemas.microsoft.com/office/drawing/2014/main" id="{BE19AB75-F457-4B84-BFDF-02D7CBE746FD}"/>
+                <a16:creationId xmlns:a16="http://schemas.microsoft.com/office/drawing/2014/main" id="{827080B9-B620-45C1-8326-D4CBEAD83E5B}"/>
               </a:ext>
             </a:extLst>
           </p:cNvPr>
@@ -3130,7 +3130,7 @@
           <p:cNvPr id="16" name="flow-2-number">
             <a:extLst xmlns:a="http://schemas.openxmlformats.org/drawingml/2006/main">
               <a:ext uri="{FF2B5EF4-FFF2-40B4-BE49-F238E27FC236}">
-                <a16:creationId xmlns:a16="http://schemas.microsoft.com/office/drawing/2014/main" id="{37DA0FBE-1B09-4910-B9D7-096CCA245E06}"/>
+                <a16:creationId xmlns:a16="http://schemas.microsoft.com/office/drawing/2014/main" id="{F63F80D1-6A09-4366-AA79-2751711710E4}"/>
               </a:ext>
             </a:extLst>
           </p:cNvPr>
@@ -3180,7 +3180,7 @@
           <p:cNvPr id="17" name="flow-2-heading">
             <a:extLst xmlns:a="http://schemas.openxmlformats.org/drawingml/2006/main">
               <a:ext uri="{FF2B5EF4-FFF2-40B4-BE49-F238E27FC236}">
-                <a16:creationId xmlns:a16="http://schemas.microsoft.com/office/drawing/2014/main" id="{7AAA00DD-B13A-409D-8328-DD3597120F49}"/>
+                <a16:creationId xmlns:a16="http://schemas.microsoft.com/office/drawing/2014/main" id="{C36055DE-60D9-4D99-951D-A05291934CDE}"/>
               </a:ext>
             </a:extLst>
           </p:cNvPr>
@@ -3230,7 +3230,7 @@
           <p:cNvPr id="18" name="flow-2-body">
             <a:extLst xmlns:a="http://schemas.openxmlformats.org/drawingml/2006/main">
               <a:ext uri="{FF2B5EF4-FFF2-40B4-BE49-F238E27FC236}">
-                <a16:creationId xmlns:a16="http://schemas.microsoft.com/office/drawing/2014/main" id="{E8CBD3FE-4D4C-4E7A-AA55-CFA73F051FB5}"/>
+                <a16:creationId xmlns:a16="http://schemas.microsoft.com/office/drawing/2014/main" id="{65D3666A-9DEC-4D57-8E1A-EF5332508B01}"/>
               </a:ext>
             </a:extLst>
           </p:cNvPr>
@@ -3280,7 +3280,7 @@
           <p:cNvPr id="19" name="flow-3-panel">
             <a:extLst xmlns:a="http://schemas.openxmlformats.org/drawingml/2006/main">
               <a:ext uri="{FF2B5EF4-FFF2-40B4-BE49-F238E27FC236}">
-                <a16:creationId xmlns:a16="http://schemas.microsoft.com/office/drawing/2014/main" id="{867D6E20-54E7-47E5-A325-6057270DFFF4}"/>
+                <a16:creationId xmlns:a16="http://schemas.microsoft.com/office/drawing/2014/main" id="{98188184-9135-4024-A6D3-37D1FA73767D}"/>
               </a:ext>
             </a:extLst>
           </p:cNvPr>
@@ -3311,7 +3311,7 @@
           <p:cNvPr id="20" name="flow-3-number">
             <a:extLst xmlns:a="http://schemas.openxmlformats.org/drawingml/2006/main">
               <a:ext uri="{FF2B5EF4-FFF2-40B4-BE49-F238E27FC236}">
-                <a16:creationId xmlns:a16="http://schemas.microsoft.com/office/drawing/2014/main" id="{7DF999C1-7017-46DC-882D-BEC2775994AC}"/>
+                <a16:creationId xmlns:a16="http://schemas.microsoft.com/office/drawing/2014/main" id="{FDF7CCDA-84D3-41E0-91E8-B5D1DBFF7CF7}"/>
               </a:ext>
             </a:extLst>
           </p:cNvPr>
@@ -3361,7 +3361,7 @@
           <p:cNvPr id="21" name="flow-3-heading">
             <a:extLst xmlns:a="http://schemas.openxmlformats.org/drawingml/2006/main">
               <a:ext uri="{FF2B5EF4-FFF2-40B4-BE49-F238E27FC236}">
-                <a16:creationId xmlns:a16="http://schemas.microsoft.com/office/drawing/2014/main" id="{ADDBE1EC-D0F7-4E25-8B73-BA9BDE8261AB}"/>
+                <a16:creationId xmlns:a16="http://schemas.microsoft.com/office/drawing/2014/main" id="{54C2F881-50D0-4015-8C5C-95660B94D211}"/>
               </a:ext>
             </a:extLst>
           </p:cNvPr>
@@ -3411,7 +3411,7 @@
           <p:cNvPr id="22" name="flow-3-body">
             <a:extLst xmlns:a="http://schemas.openxmlformats.org/drawingml/2006/main">
               <a:ext uri="{FF2B5EF4-FFF2-40B4-BE49-F238E27FC236}">
-                <a16:creationId xmlns:a16="http://schemas.microsoft.com/office/drawing/2014/main" id="{136A3998-19B7-470C-B379-64429558B900}"/>
+                <a16:creationId xmlns:a16="http://schemas.microsoft.com/office/drawing/2014/main" id="{35E42925-D849-49CD-9A35-CB0BCACA731F}"/>
               </a:ext>
             </a:extLst>
           </p:cNvPr>
@@ -3461,7 +3461,7 @@
           <p:cNvPr id="23" name="linddun">
             <a:extLst xmlns:a="http://schemas.openxmlformats.org/drawingml/2006/main">
               <a:ext uri="{FF2B5EF4-FFF2-40B4-BE49-F238E27FC236}">
-                <a16:creationId xmlns:a16="http://schemas.microsoft.com/office/drawing/2014/main" id="{13BE897B-FB25-40B1-A1BA-B11E92DEFCF7}"/>
+                <a16:creationId xmlns:a16="http://schemas.microsoft.com/office/drawing/2014/main" id="{BC51B504-EF72-4D23-BE28-17A5DB946046}"/>
               </a:ext>
             </a:extLst>
           </p:cNvPr>
@@ -3511,7 +3511,7 @@
           <p:cNvPr id="24" name="scope">
             <a:extLst xmlns:a="http://schemas.openxmlformats.org/drawingml/2006/main">
               <a:ext uri="{FF2B5EF4-FFF2-40B4-BE49-F238E27FC236}">
-                <a16:creationId xmlns:a16="http://schemas.microsoft.com/office/drawing/2014/main" id="{99925CEF-2F3D-409C-AE62-392B381E7694}"/>
+                <a16:creationId xmlns:a16="http://schemas.microsoft.com/office/drawing/2014/main" id="{55FCDA03-EDAB-44F9-9FD7-D7819DAD3B13}"/>
               </a:ext>
             </a:extLst>
           </p:cNvPr>
@@ -3559,7 +3559,7 @@
     </p:spTree>
     <p:extLst>
       <p:ext uri="{BB962C8B-B14F-4D97-AF65-F5344CB8AC3E}">
-        <p14:creationId xmlns:p14="http://schemas.microsoft.com/office/powerpoint/2010/main" val="1862135816"/>
+        <p14:creationId xmlns:p14="http://schemas.microsoft.com/office/powerpoint/2010/main" val="1027926169"/>
       </p:ext>
     </p:extLst>
   </p:cSld>
@@ -3590,7 +3590,7 @@
           <p:cNvPr id="23" name="slide-3-title">
             <a:extLst xmlns:a="http://schemas.openxmlformats.org/drawingml/2006/main">
               <a:ext uri="{FF2B5EF4-FFF2-40B4-BE49-F238E27FC236}">
-                <a16:creationId xmlns:a16="http://schemas.microsoft.com/office/drawing/2014/main" id="{CF0103D1-7500-4172-B8F6-A31961BCAFAE}"/>
+                <a16:creationId xmlns:a16="http://schemas.microsoft.com/office/drawing/2014/main" id="{5627870B-1F52-4A02-AEBE-28D812B9D050}"/>
               </a:ext>
             </a:extLst>
           </p:cNvPr>
@@ -3640,7 +3640,7 @@
           <p:cNvPr id="2" name="slide-3-number">
             <a:extLst xmlns:a="http://schemas.openxmlformats.org/drawingml/2006/main">
               <a:ext uri="{FF2B5EF4-FFF2-40B4-BE49-F238E27FC236}">
-                <a16:creationId xmlns:a16="http://schemas.microsoft.com/office/drawing/2014/main" id="{3E3D1880-9E8E-446E-AF90-94683067A82B}"/>
+                <a16:creationId xmlns:a16="http://schemas.microsoft.com/office/drawing/2014/main" id="{70280BE6-FBA2-43ED-B4D4-586716966154}"/>
               </a:ext>
             </a:extLst>
           </p:cNvPr>
@@ -3690,7 +3690,7 @@
           <p:cNvPr id="3" name="slide-3-rule">
             <a:extLst xmlns:a="http://schemas.openxmlformats.org/drawingml/2006/main">
               <a:ext uri="{FF2B5EF4-FFF2-40B4-BE49-F238E27FC236}">
-                <a16:creationId xmlns:a16="http://schemas.microsoft.com/office/drawing/2014/main" id="{A7DA0AB7-C4B8-4CBC-9779-3D411B0B4504}"/>
+                <a16:creationId xmlns:a16="http://schemas.microsoft.com/office/drawing/2014/main" id="{1E535789-48E6-4221-9BF8-E2BC57C2FAC6}"/>
               </a:ext>
             </a:extLst>
           </p:cNvPr>
@@ -3721,7 +3721,7 @@
           <p:cNvPr id="4" name="profiles-panel">
             <a:extLst xmlns:a="http://schemas.openxmlformats.org/drawingml/2006/main">
               <a:ext uri="{FF2B5EF4-FFF2-40B4-BE49-F238E27FC236}">
-                <a16:creationId xmlns:a16="http://schemas.microsoft.com/office/drawing/2014/main" id="{A446391B-BAFD-4051-9371-C0E44DC7CE35}"/>
+                <a16:creationId xmlns:a16="http://schemas.microsoft.com/office/drawing/2014/main" id="{5C25F1F3-74FC-4DA3-9202-CC64D9F4A3FE}"/>
               </a:ext>
             </a:extLst>
           </p:cNvPr>
@@ -3752,7 +3752,7 @@
           <p:cNvPr id="5" name="profiles-accent">
             <a:extLst xmlns:a="http://schemas.openxmlformats.org/drawingml/2006/main">
               <a:ext uri="{FF2B5EF4-FFF2-40B4-BE49-F238E27FC236}">
-                <a16:creationId xmlns:a16="http://schemas.microsoft.com/office/drawing/2014/main" id="{B169FE19-F5CB-446C-91AE-EE639D3BF8BF}"/>
+                <a16:creationId xmlns:a16="http://schemas.microsoft.com/office/drawing/2014/main" id="{822FA2B8-6331-4B66-AEA8-CD8671424AE5}"/>
               </a:ext>
             </a:extLst>
           </p:cNvPr>
@@ -3783,7 +3783,7 @@
           <p:cNvPr id="6" name="profiles-value">
             <a:extLst xmlns:a="http://schemas.openxmlformats.org/drawingml/2006/main">
               <a:ext uri="{FF2B5EF4-FFF2-40B4-BE49-F238E27FC236}">
-                <a16:creationId xmlns:a16="http://schemas.microsoft.com/office/drawing/2014/main" id="{8F0FC5E0-C21F-49C8-B5AA-0F8D8641138F}"/>
+                <a16:creationId xmlns:a16="http://schemas.microsoft.com/office/drawing/2014/main" id="{C8095881-11D7-461F-A3A0-0C2918C74AF0}"/>
               </a:ext>
             </a:extLst>
           </p:cNvPr>
@@ -3833,7 +3833,7 @@
           <p:cNvPr id="7" name="profiles-label">
             <a:extLst xmlns:a="http://schemas.openxmlformats.org/drawingml/2006/main">
               <a:ext uri="{FF2B5EF4-FFF2-40B4-BE49-F238E27FC236}">
-                <a16:creationId xmlns:a16="http://schemas.microsoft.com/office/drawing/2014/main" id="{6AC5043B-1A83-40FF-9528-AD6DC990F6D2}"/>
+                <a16:creationId xmlns:a16="http://schemas.microsoft.com/office/drawing/2014/main" id="{893C55D4-0E89-47FA-8601-B766B6F237BD}"/>
               </a:ext>
             </a:extLst>
           </p:cNvPr>
@@ -3883,7 +3883,7 @@
           <p:cNvPr id="8" name="prompts-panel">
             <a:extLst xmlns:a="http://schemas.openxmlformats.org/drawingml/2006/main">
               <a:ext uri="{FF2B5EF4-FFF2-40B4-BE49-F238E27FC236}">
-                <a16:creationId xmlns:a16="http://schemas.microsoft.com/office/drawing/2014/main" id="{0DBE084B-CA21-4D38-8DCD-4CCAD07B4A5D}"/>
+                <a16:creationId xmlns:a16="http://schemas.microsoft.com/office/drawing/2014/main" id="{50B63F52-B29D-45BE-B738-80583C51FE79}"/>
               </a:ext>
             </a:extLst>
           </p:cNvPr>
@@ -3914,7 +3914,7 @@
           <p:cNvPr id="9" name="prompts-accent">
             <a:extLst xmlns:a="http://schemas.openxmlformats.org/drawingml/2006/main">
               <a:ext uri="{FF2B5EF4-FFF2-40B4-BE49-F238E27FC236}">
-                <a16:creationId xmlns:a16="http://schemas.microsoft.com/office/drawing/2014/main" id="{699C4731-CFA3-422E-8023-90BF2516740B}"/>
+                <a16:creationId xmlns:a16="http://schemas.microsoft.com/office/drawing/2014/main" id="{972F4BD6-9710-414A-927D-3A89FBECA72D}"/>
               </a:ext>
             </a:extLst>
           </p:cNvPr>
@@ -3945,7 +3945,7 @@
           <p:cNvPr id="10" name="prompts-value">
             <a:extLst xmlns:a="http://schemas.openxmlformats.org/drawingml/2006/main">
               <a:ext uri="{FF2B5EF4-FFF2-40B4-BE49-F238E27FC236}">
-                <a16:creationId xmlns:a16="http://schemas.microsoft.com/office/drawing/2014/main" id="{16A22899-6F42-495B-93B0-B154F8B469E0}"/>
+                <a16:creationId xmlns:a16="http://schemas.microsoft.com/office/drawing/2014/main" id="{6EEFC379-C4B4-456A-9FE4-D7BD1815B267}"/>
               </a:ext>
             </a:extLst>
           </p:cNvPr>
@@ -3995,7 +3995,7 @@
           <p:cNvPr id="11" name="prompts-label">
             <a:extLst xmlns:a="http://schemas.openxmlformats.org/drawingml/2006/main">
               <a:ext uri="{FF2B5EF4-FFF2-40B4-BE49-F238E27FC236}">
-                <a16:creationId xmlns:a16="http://schemas.microsoft.com/office/drawing/2014/main" id="{AE7303BE-0ABF-4DAD-ADE7-4A82216DB744}"/>
+                <a16:creationId xmlns:a16="http://schemas.microsoft.com/office/drawing/2014/main" id="{C2A23177-8F59-455F-B01A-26843B8C8BC6}"/>
               </a:ext>
             </a:extLst>
           </p:cNvPr>
@@ -4045,7 +4045,7 @@
           <p:cNvPr id="12" name="baseline-panel">
             <a:extLst xmlns:a="http://schemas.openxmlformats.org/drawingml/2006/main">
               <a:ext uri="{FF2B5EF4-FFF2-40B4-BE49-F238E27FC236}">
-                <a16:creationId xmlns:a16="http://schemas.microsoft.com/office/drawing/2014/main" id="{F32949A0-A7A8-4BAD-9596-95EFDB926570}"/>
+                <a16:creationId xmlns:a16="http://schemas.microsoft.com/office/drawing/2014/main" id="{431FFB67-CD86-44CA-8691-E71C6C451459}"/>
               </a:ext>
             </a:extLst>
           </p:cNvPr>
@@ -4076,7 +4076,7 @@
           <p:cNvPr id="13" name="baseline-accent">
             <a:extLst xmlns:a="http://schemas.openxmlformats.org/drawingml/2006/main">
               <a:ext uri="{FF2B5EF4-FFF2-40B4-BE49-F238E27FC236}">
-                <a16:creationId xmlns:a16="http://schemas.microsoft.com/office/drawing/2014/main" id="{4D3F1457-58BA-45AE-B469-1C52DBE5D31E}"/>
+                <a16:creationId xmlns:a16="http://schemas.microsoft.com/office/drawing/2014/main" id="{7B50C53B-0E18-40AD-8945-8974F463280C}"/>
               </a:ext>
             </a:extLst>
           </p:cNvPr>
@@ -4107,7 +4107,7 @@
           <p:cNvPr id="14" name="baseline-value">
             <a:extLst xmlns:a="http://schemas.openxmlformats.org/drawingml/2006/main">
               <a:ext uri="{FF2B5EF4-FFF2-40B4-BE49-F238E27FC236}">
-                <a16:creationId xmlns:a16="http://schemas.microsoft.com/office/drawing/2014/main" id="{3EC445B8-6565-4357-B2FD-17779B487C9A}"/>
+                <a16:creationId xmlns:a16="http://schemas.microsoft.com/office/drawing/2014/main" id="{79231F91-ACDD-4F93-A80E-99F6D5454C3F}"/>
               </a:ext>
             </a:extLst>
           </p:cNvPr>
@@ -4157,7 +4157,7 @@
           <p:cNvPr id="15" name="baseline-label">
             <a:extLst xmlns:a="http://schemas.openxmlformats.org/drawingml/2006/main">
               <a:ext uri="{FF2B5EF4-FFF2-40B4-BE49-F238E27FC236}">
-                <a16:creationId xmlns:a16="http://schemas.microsoft.com/office/drawing/2014/main" id="{DDB06FF9-E494-46C0-A2A3-EF03D98005E0}"/>
+                <a16:creationId xmlns:a16="http://schemas.microsoft.com/office/drawing/2014/main" id="{87568E33-9D98-4AC0-B889-F914B101481E}"/>
               </a:ext>
             </a:extLst>
           </p:cNvPr>
@@ -4207,7 +4207,7 @@
           <p:cNvPr id="16" name="mitigation-panel">
             <a:extLst xmlns:a="http://schemas.openxmlformats.org/drawingml/2006/main">
               <a:ext uri="{FF2B5EF4-FFF2-40B4-BE49-F238E27FC236}">
-                <a16:creationId xmlns:a16="http://schemas.microsoft.com/office/drawing/2014/main" id="{965E33FC-67FC-48A7-8A78-FE73C623290A}"/>
+                <a16:creationId xmlns:a16="http://schemas.microsoft.com/office/drawing/2014/main" id="{9B6B5BDB-0594-4299-ABE3-EF92968458C1}"/>
               </a:ext>
             </a:extLst>
           </p:cNvPr>
@@ -4238,7 +4238,7 @@
           <p:cNvPr id="17" name="mitigation-accent">
             <a:extLst xmlns:a="http://schemas.openxmlformats.org/drawingml/2006/main">
               <a:ext uri="{FF2B5EF4-FFF2-40B4-BE49-F238E27FC236}">
-                <a16:creationId xmlns:a16="http://schemas.microsoft.com/office/drawing/2014/main" id="{840D22EB-0024-4197-B77B-82CAE454810C}"/>
+                <a16:creationId xmlns:a16="http://schemas.microsoft.com/office/drawing/2014/main" id="{D3905794-E55D-4F36-8B9F-6C1EAB658983}"/>
               </a:ext>
             </a:extLst>
           </p:cNvPr>
@@ -4269,7 +4269,7 @@
           <p:cNvPr id="18" name="mitigation-value">
             <a:extLst xmlns:a="http://schemas.openxmlformats.org/drawingml/2006/main">
               <a:ext uri="{FF2B5EF4-FFF2-40B4-BE49-F238E27FC236}">
-                <a16:creationId xmlns:a16="http://schemas.microsoft.com/office/drawing/2014/main" id="{F4EEA5B9-EAFD-41A7-9B99-021F5761E200}"/>
+                <a16:creationId xmlns:a16="http://schemas.microsoft.com/office/drawing/2014/main" id="{89A64AA1-9B19-4F9C-9E95-4C4BBC97133C}"/>
               </a:ext>
             </a:extLst>
           </p:cNvPr>
@@ -4319,7 +4319,7 @@
           <p:cNvPr id="19" name="mitigation-label">
             <a:extLst xmlns:a="http://schemas.openxmlformats.org/drawingml/2006/main">
               <a:ext uri="{FF2B5EF4-FFF2-40B4-BE49-F238E27FC236}">
-                <a16:creationId xmlns:a16="http://schemas.microsoft.com/office/drawing/2014/main" id="{2F76C50D-ABAE-49C9-80B0-7EFA919B9290}"/>
+                <a16:creationId xmlns:a16="http://schemas.microsoft.com/office/drawing/2014/main" id="{2CCFD007-2A4B-447F-9CDF-6130B7CC8037}"/>
               </a:ext>
             </a:extLst>
           </p:cNvPr>
@@ -4373,13 +4373,13 @@
           <p:nvPr/>
         </p:nvPicPr>
         <p:blipFill>
-          <a:blip xmlns:r="http://schemas.openxmlformats.org/officeDocument/2006/relationships" xmlns:a="http://schemas.openxmlformats.org/drawingml/2006/main" r:embed="R52727c9038594ff3"/>
+          <a:blip xmlns:r="http://schemas.openxmlformats.org/officeDocument/2006/relationships" xmlns:a="http://schemas.openxmlformats.org/drawingml/2006/main" r:embed="Rb8dd998982284f48"/>
           <a:stretch xmlns:a="http://schemas.openxmlformats.org/drawingml/2006/main"/>
         </p:blipFill>
         <p:spPr>
           <a:xfrm xmlns:a="http://schemas.openxmlformats.org/drawingml/2006/main">
-            <a:off x="5143500" y="1623435"/>
-            <a:ext cx="6591300" cy="3382530"/>
+            <a:off x="5429011" y="1466850"/>
+            <a:ext cx="6020278" cy="3695700"/>
           </a:xfrm>
           <a:prstGeom xmlns:a="http://schemas.openxmlformats.org/drawingml/2006/main" prst="rect">
             <a:avLst/>
@@ -4391,7 +4391,7 @@
           <p:cNvPr id="21" name="method-caption">
             <a:extLst xmlns:a="http://schemas.openxmlformats.org/drawingml/2006/main">
               <a:ext uri="{FF2B5EF4-FFF2-40B4-BE49-F238E27FC236}">
-                <a16:creationId xmlns:a16="http://schemas.microsoft.com/office/drawing/2014/main" id="{6711CE1E-C2A6-461B-86CD-20448A0AAF28}"/>
+                <a16:creationId xmlns:a16="http://schemas.microsoft.com/office/drawing/2014/main" id="{DE668A24-01F8-4CC3-8D07-99847EEBF12A}"/>
               </a:ext>
             </a:extLst>
           </p:cNvPr>
@@ -4441,7 +4441,7 @@
           <p:cNvPr id="22" name="method-model">
             <a:extLst xmlns:a="http://schemas.openxmlformats.org/drawingml/2006/main">
               <a:ext uri="{FF2B5EF4-FFF2-40B4-BE49-F238E27FC236}">
-                <a16:creationId xmlns:a16="http://schemas.microsoft.com/office/drawing/2014/main" id="{26A9463C-FA12-4EBF-B112-4EFDD60C8434}"/>
+                <a16:creationId xmlns:a16="http://schemas.microsoft.com/office/drawing/2014/main" id="{EEDF736A-8647-4E09-AE11-9A2AA7C7661F}"/>
               </a:ext>
             </a:extLst>
           </p:cNvPr>
@@ -4489,7 +4489,7 @@
     </p:spTree>
     <p:extLst>
       <p:ext uri="{BB962C8B-B14F-4D97-AF65-F5344CB8AC3E}">
-        <p14:creationId xmlns:p14="http://schemas.microsoft.com/office/powerpoint/2010/main" val="472455524"/>
+        <p14:creationId xmlns:p14="http://schemas.microsoft.com/office/powerpoint/2010/main" val="89983974"/>
       </p:ext>
     </p:extLst>
   </p:cSld>
@@ -4520,7 +4520,7 @@
           <p:cNvPr id="12" name="slide-4-title">
             <a:extLst xmlns:a="http://schemas.openxmlformats.org/drawingml/2006/main">
               <a:ext uri="{FF2B5EF4-FFF2-40B4-BE49-F238E27FC236}">
-                <a16:creationId xmlns:a16="http://schemas.microsoft.com/office/drawing/2014/main" id="{5177AE07-BF90-41A7-A274-8E156D9A5F29}"/>
+                <a16:creationId xmlns:a16="http://schemas.microsoft.com/office/drawing/2014/main" id="{0D91D267-6A9C-49B5-A03D-70707E16AE8D}"/>
               </a:ext>
             </a:extLst>
           </p:cNvPr>
@@ -4570,7 +4570,7 @@
           <p:cNvPr id="2" name="slide-4-number">
             <a:extLst xmlns:a="http://schemas.openxmlformats.org/drawingml/2006/main">
               <a:ext uri="{FF2B5EF4-FFF2-40B4-BE49-F238E27FC236}">
-                <a16:creationId xmlns:a16="http://schemas.microsoft.com/office/drawing/2014/main" id="{4D4144CA-95AB-49B0-B2E8-0AB62841F3AD}"/>
+                <a16:creationId xmlns:a16="http://schemas.microsoft.com/office/drawing/2014/main" id="{CB5B0A85-BB33-4760-994A-10CCCCB23335}"/>
               </a:ext>
             </a:extLst>
           </p:cNvPr>
@@ -4620,7 +4620,7 @@
           <p:cNvPr id="3" name="slide-4-rule">
             <a:extLst xmlns:a="http://schemas.openxmlformats.org/drawingml/2006/main">
               <a:ext uri="{FF2B5EF4-FFF2-40B4-BE49-F238E27FC236}">
-                <a16:creationId xmlns:a16="http://schemas.microsoft.com/office/drawing/2014/main" id="{CAC2B587-2C30-47B9-8A2B-115C634E3CDA}"/>
+                <a16:creationId xmlns:a16="http://schemas.microsoft.com/office/drawing/2014/main" id="{8D13F827-0E0B-4B6D-A382-6217789771E1}"/>
               </a:ext>
             </a:extLst>
           </p:cNvPr>
@@ -4658,7 +4658,7 @@
         </p:xfrm>
         <a:graphic xmlns:a="http://schemas.openxmlformats.org/drawingml/2006/main">
           <a:graphicData uri="http://schemas.openxmlformats.org/drawingml/2006/chart">
-            <c:chart xmlns:r="http://schemas.openxmlformats.org/officeDocument/2006/relationships" xmlns:c="http://schemas.openxmlformats.org/drawingml/2006/chart" r:id="Rd39966e1e48f4442"/>
+            <c:chart xmlns:r="http://schemas.openxmlformats.org/officeDocument/2006/relationships" xmlns:c="http://schemas.openxmlformats.org/drawingml/2006/chart" r:id="Rc80d8ee44d4c4b76"/>
           </a:graphicData>
         </a:graphic>
       </p:graphicFrame>
@@ -4667,7 +4667,7 @@
           <p:cNvPr id="5" name="result-callout">
             <a:extLst xmlns:a="http://schemas.openxmlformats.org/drawingml/2006/main">
               <a:ext uri="{FF2B5EF4-FFF2-40B4-BE49-F238E27FC236}">
-                <a16:creationId xmlns:a16="http://schemas.microsoft.com/office/drawing/2014/main" id="{1740E78B-8B86-4767-96BA-F38737E10C69}"/>
+                <a16:creationId xmlns:a16="http://schemas.microsoft.com/office/drawing/2014/main" id="{85104056-4DB1-4CF4-9E53-068AC375D95D}"/>
               </a:ext>
             </a:extLst>
           </p:cNvPr>
@@ -4698,7 +4698,7 @@
           <p:cNvPr id="6" name="result-value">
             <a:extLst xmlns:a="http://schemas.openxmlformats.org/drawingml/2006/main">
               <a:ext uri="{FF2B5EF4-FFF2-40B4-BE49-F238E27FC236}">
-                <a16:creationId xmlns:a16="http://schemas.microsoft.com/office/drawing/2014/main" id="{B6B6EB66-179E-492A-8CBA-A2BCDD578D70}"/>
+                <a16:creationId xmlns:a16="http://schemas.microsoft.com/office/drawing/2014/main" id="{47C8CC87-2D05-4DF9-AE3F-982661BFC2A2}"/>
               </a:ext>
             </a:extLst>
           </p:cNvPr>
@@ -4748,7 +4748,7 @@
           <p:cNvPr id="7" name="result-copy">
             <a:extLst xmlns:a="http://schemas.openxmlformats.org/drawingml/2006/main">
               <a:ext uri="{FF2B5EF4-FFF2-40B4-BE49-F238E27FC236}">
-                <a16:creationId xmlns:a16="http://schemas.microsoft.com/office/drawing/2014/main" id="{68102DE2-8274-4F18-9792-1C47888C4F87}"/>
+                <a16:creationId xmlns:a16="http://schemas.microsoft.com/office/drawing/2014/main" id="{8B733558-4B2A-470E-815E-5F9F0B6EFAD3}"/>
               </a:ext>
             </a:extLst>
           </p:cNvPr>
@@ -4798,7 +4798,7 @@
           <p:cNvPr id="8" name="confidence-callout">
             <a:extLst xmlns:a="http://schemas.openxmlformats.org/drawingml/2006/main">
               <a:ext uri="{FF2B5EF4-FFF2-40B4-BE49-F238E27FC236}">
-                <a16:creationId xmlns:a16="http://schemas.microsoft.com/office/drawing/2014/main" id="{61A554CF-E1C3-419E-AD7D-A55677FFA089}"/>
+                <a16:creationId xmlns:a16="http://schemas.microsoft.com/office/drawing/2014/main" id="{1E586544-6F72-4BA4-A959-742483DF9707}"/>
               </a:ext>
             </a:extLst>
           </p:cNvPr>
@@ -4829,7 +4829,7 @@
           <p:cNvPr id="9" name="confidence-value">
             <a:extLst xmlns:a="http://schemas.openxmlformats.org/drawingml/2006/main">
               <a:ext uri="{FF2B5EF4-FFF2-40B4-BE49-F238E27FC236}">
-                <a16:creationId xmlns:a16="http://schemas.microsoft.com/office/drawing/2014/main" id="{04121FFB-AA42-4A5C-AEF6-A69888FF7114}"/>
+                <a16:creationId xmlns:a16="http://schemas.microsoft.com/office/drawing/2014/main" id="{75B9E83B-B9D4-49EB-B389-0E6349DF232A}"/>
               </a:ext>
             </a:extLst>
           </p:cNvPr>
@@ -4879,7 +4879,7 @@
           <p:cNvPr id="10" name="confidence-copy">
             <a:extLst xmlns:a="http://schemas.openxmlformats.org/drawingml/2006/main">
               <a:ext uri="{FF2B5EF4-FFF2-40B4-BE49-F238E27FC236}">
-                <a16:creationId xmlns:a16="http://schemas.microsoft.com/office/drawing/2014/main" id="{0CBCAD9F-B342-4524-A704-5B1C9364141B}"/>
+                <a16:creationId xmlns:a16="http://schemas.microsoft.com/office/drawing/2014/main" id="{D642D41D-4934-485F-8E3C-BC2683BDD269}"/>
               </a:ext>
             </a:extLst>
           </p:cNvPr>
@@ -4929,7 +4929,7 @@
           <p:cNvPr id="11" name="result-footnote">
             <a:extLst xmlns:a="http://schemas.openxmlformats.org/drawingml/2006/main">
               <a:ext uri="{FF2B5EF4-FFF2-40B4-BE49-F238E27FC236}">
-                <a16:creationId xmlns:a16="http://schemas.microsoft.com/office/drawing/2014/main" id="{088CB3A7-E2D6-46E0-8264-EB27576514A5}"/>
+                <a16:creationId xmlns:a16="http://schemas.microsoft.com/office/drawing/2014/main" id="{1B84CD65-F2AE-49D7-AAAA-105B991DB955}"/>
               </a:ext>
             </a:extLst>
           </p:cNvPr>
@@ -4977,7 +4977,7 @@
     </p:spTree>
     <p:extLst>
       <p:ext uri="{BB962C8B-B14F-4D97-AF65-F5344CB8AC3E}">
-        <p14:creationId xmlns:p14="http://schemas.microsoft.com/office/powerpoint/2010/main" val="788351671"/>
+        <p14:creationId xmlns:p14="http://schemas.microsoft.com/office/powerpoint/2010/main" val="932656670"/>
       </p:ext>
     </p:extLst>
   </p:cSld>
@@ -5008,7 +5008,7 @@
           <p:cNvPr id="15" name="slide-5-title">
             <a:extLst xmlns:a="http://schemas.openxmlformats.org/drawingml/2006/main">
               <a:ext uri="{FF2B5EF4-FFF2-40B4-BE49-F238E27FC236}">
-                <a16:creationId xmlns:a16="http://schemas.microsoft.com/office/drawing/2014/main" id="{CA8E061A-4A82-4A51-AAFB-544DC35B9B98}"/>
+                <a16:creationId xmlns:a16="http://schemas.microsoft.com/office/drawing/2014/main" id="{91B1507B-EC30-4361-A5A0-B1C39C7A40A5}"/>
               </a:ext>
             </a:extLst>
           </p:cNvPr>
@@ -5058,7 +5058,7 @@
           <p:cNvPr id="2" name="slide-5-number">
             <a:extLst xmlns:a="http://schemas.openxmlformats.org/drawingml/2006/main">
               <a:ext uri="{FF2B5EF4-FFF2-40B4-BE49-F238E27FC236}">
-                <a16:creationId xmlns:a16="http://schemas.microsoft.com/office/drawing/2014/main" id="{A1305CDA-5842-479D-BCC6-17AA67D1AA40}"/>
+                <a16:creationId xmlns:a16="http://schemas.microsoft.com/office/drawing/2014/main" id="{F2ADD1C6-18CF-46F5-84A0-A6DF72944C9D}"/>
               </a:ext>
             </a:extLst>
           </p:cNvPr>
@@ -5108,7 +5108,7 @@
           <p:cNvPr id="3" name="slide-5-rule">
             <a:extLst xmlns:a="http://schemas.openxmlformats.org/drawingml/2006/main">
               <a:ext uri="{FF2B5EF4-FFF2-40B4-BE49-F238E27FC236}">
-                <a16:creationId xmlns:a16="http://schemas.microsoft.com/office/drawing/2014/main" id="{9CAF9D3B-C3D3-46D5-AF0B-F3F0D7D8E5DC}"/>
+                <a16:creationId xmlns:a16="http://schemas.microsoft.com/office/drawing/2014/main" id="{5F005BEC-CC42-4BA2-8409-365907AB80ED}"/>
               </a:ext>
             </a:extLst>
           </p:cNvPr>
@@ -5146,7 +5146,7 @@
         </p:xfrm>
         <a:graphic xmlns:a="http://schemas.openxmlformats.org/drawingml/2006/main">
           <a:graphicData uri="http://schemas.openxmlformats.org/drawingml/2006/chart">
-            <c:chart xmlns:r="http://schemas.openxmlformats.org/officeDocument/2006/relationships" xmlns:c="http://schemas.openxmlformats.org/drawingml/2006/chart" r:id="R91e4d109f0044f35"/>
+            <c:chart xmlns:r="http://schemas.openxmlformats.org/officeDocument/2006/relationships" xmlns:c="http://schemas.openxmlformats.org/drawingml/2006/chart" r:id="Ra6f6703d3a16445b"/>
           </a:graphicData>
         </a:graphic>
       </p:graphicFrame>
@@ -5155,7 +5155,7 @@
           <p:cNvPr id="5" name="finding-0-panel">
             <a:extLst xmlns:a="http://schemas.openxmlformats.org/drawingml/2006/main">
               <a:ext uri="{FF2B5EF4-FFF2-40B4-BE49-F238E27FC236}">
-                <a16:creationId xmlns:a16="http://schemas.microsoft.com/office/drawing/2014/main" id="{0AAE9CC5-6DCB-44B6-8979-1E2E37C2E131}"/>
+                <a16:creationId xmlns:a16="http://schemas.microsoft.com/office/drawing/2014/main" id="{809003F1-E3C1-45E5-B4D8-0718831D5817}"/>
               </a:ext>
             </a:extLst>
           </p:cNvPr>
@@ -5186,7 +5186,7 @@
           <p:cNvPr id="6" name="finding-0-title">
             <a:extLst xmlns:a="http://schemas.openxmlformats.org/drawingml/2006/main">
               <a:ext uri="{FF2B5EF4-FFF2-40B4-BE49-F238E27FC236}">
-                <a16:creationId xmlns:a16="http://schemas.microsoft.com/office/drawing/2014/main" id="{8F80B17E-F43B-4CA5-8DBB-E907EA155265}"/>
+                <a16:creationId xmlns:a16="http://schemas.microsoft.com/office/drawing/2014/main" id="{412DEB43-758F-4F79-A43C-FEB1B8A08DA4}"/>
               </a:ext>
             </a:extLst>
           </p:cNvPr>
@@ -5236,7 +5236,7 @@
           <p:cNvPr id="7" name="finding-0-body">
             <a:extLst xmlns:a="http://schemas.openxmlformats.org/drawingml/2006/main">
               <a:ext uri="{FF2B5EF4-FFF2-40B4-BE49-F238E27FC236}">
-                <a16:creationId xmlns:a16="http://schemas.microsoft.com/office/drawing/2014/main" id="{2971C9EE-7778-457F-B5FD-FB0C522002C4}"/>
+                <a16:creationId xmlns:a16="http://schemas.microsoft.com/office/drawing/2014/main" id="{76E419B0-6661-44D3-9E8E-66DDD22F00AC}"/>
               </a:ext>
             </a:extLst>
           </p:cNvPr>
@@ -5286,7 +5286,7 @@
           <p:cNvPr id="8" name="finding-1-panel">
             <a:extLst xmlns:a="http://schemas.openxmlformats.org/drawingml/2006/main">
               <a:ext uri="{FF2B5EF4-FFF2-40B4-BE49-F238E27FC236}">
-                <a16:creationId xmlns:a16="http://schemas.microsoft.com/office/drawing/2014/main" id="{4EB592A6-BCC0-4286-A307-15B4008335FE}"/>
+                <a16:creationId xmlns:a16="http://schemas.microsoft.com/office/drawing/2014/main" id="{6EF92666-EDF0-4A10-870A-A7937F56E405}"/>
               </a:ext>
             </a:extLst>
           </p:cNvPr>
@@ -5317,7 +5317,7 @@
           <p:cNvPr id="9" name="finding-1-title">
             <a:extLst xmlns:a="http://schemas.openxmlformats.org/drawingml/2006/main">
               <a:ext uri="{FF2B5EF4-FFF2-40B4-BE49-F238E27FC236}">
-                <a16:creationId xmlns:a16="http://schemas.microsoft.com/office/drawing/2014/main" id="{43F976D3-24E7-49E5-BE4D-1399295EBE07}"/>
+                <a16:creationId xmlns:a16="http://schemas.microsoft.com/office/drawing/2014/main" id="{923A56AA-74BB-4CE0-89A6-A9B0929C4B55}"/>
               </a:ext>
             </a:extLst>
           </p:cNvPr>
@@ -5367,7 +5367,7 @@
           <p:cNvPr id="10" name="finding-1-body">
             <a:extLst xmlns:a="http://schemas.openxmlformats.org/drawingml/2006/main">
               <a:ext uri="{FF2B5EF4-FFF2-40B4-BE49-F238E27FC236}">
-                <a16:creationId xmlns:a16="http://schemas.microsoft.com/office/drawing/2014/main" id="{5954F0B3-4640-4B8F-8B04-AC4CFCE0FB02}"/>
+                <a16:creationId xmlns:a16="http://schemas.microsoft.com/office/drawing/2014/main" id="{633FD807-5ABF-4E1A-ADE1-207EEA19ED34}"/>
               </a:ext>
             </a:extLst>
           </p:cNvPr>
@@ -5417,7 +5417,7 @@
           <p:cNvPr id="11" name="finding-2-panel">
             <a:extLst xmlns:a="http://schemas.openxmlformats.org/drawingml/2006/main">
               <a:ext uri="{FF2B5EF4-FFF2-40B4-BE49-F238E27FC236}">
-                <a16:creationId xmlns:a16="http://schemas.microsoft.com/office/drawing/2014/main" id="{912B610B-C2CF-4ECA-8BAC-AE4E8363C367}"/>
+                <a16:creationId xmlns:a16="http://schemas.microsoft.com/office/drawing/2014/main" id="{276F15ED-1EA2-4FAE-95C0-63A64AA0B32C}"/>
               </a:ext>
             </a:extLst>
           </p:cNvPr>
@@ -5448,7 +5448,7 @@
           <p:cNvPr id="12" name="finding-2-title">
             <a:extLst xmlns:a="http://schemas.openxmlformats.org/drawingml/2006/main">
               <a:ext uri="{FF2B5EF4-FFF2-40B4-BE49-F238E27FC236}">
-                <a16:creationId xmlns:a16="http://schemas.microsoft.com/office/drawing/2014/main" id="{9A199862-A105-4333-AC76-DD2664377B22}"/>
+                <a16:creationId xmlns:a16="http://schemas.microsoft.com/office/drawing/2014/main" id="{B65634D4-09DD-4DFF-BB9E-D2B6D547A1A5}"/>
               </a:ext>
             </a:extLst>
           </p:cNvPr>
@@ -5498,7 +5498,7 @@
           <p:cNvPr id="13" name="finding-2-body">
             <a:extLst xmlns:a="http://schemas.openxmlformats.org/drawingml/2006/main">
               <a:ext uri="{FF2B5EF4-FFF2-40B4-BE49-F238E27FC236}">
-                <a16:creationId xmlns:a16="http://schemas.microsoft.com/office/drawing/2014/main" id="{529CB17C-C55F-4893-92AD-7F2A40381BCE}"/>
+                <a16:creationId xmlns:a16="http://schemas.microsoft.com/office/drawing/2014/main" id="{F02E16F5-095F-4A24-BEE1-69D655FB4AD1}"/>
               </a:ext>
             </a:extLst>
           </p:cNvPr>
@@ -5548,7 +5548,7 @@
           <p:cNvPr id="14" name="mitigation-footnote">
             <a:extLst xmlns:a="http://schemas.openxmlformats.org/drawingml/2006/main">
               <a:ext uri="{FF2B5EF4-FFF2-40B4-BE49-F238E27FC236}">
-                <a16:creationId xmlns:a16="http://schemas.microsoft.com/office/drawing/2014/main" id="{7E67D18C-14B9-4534-9ECE-1FDF846EE019}"/>
+                <a16:creationId xmlns:a16="http://schemas.microsoft.com/office/drawing/2014/main" id="{C391295F-4A8B-4957-8777-758038D1E429}"/>
               </a:ext>
             </a:extLst>
           </p:cNvPr>
@@ -5596,7 +5596,7 @@
     </p:spTree>
     <p:extLst>
       <p:ext uri="{BB962C8B-B14F-4D97-AF65-F5344CB8AC3E}">
-        <p14:creationId xmlns:p14="http://schemas.microsoft.com/office/powerpoint/2010/main" val="2133355930"/>
+        <p14:creationId xmlns:p14="http://schemas.microsoft.com/office/powerpoint/2010/main" val="517892439"/>
       </p:ext>
     </p:extLst>
   </p:cSld>
@@ -5627,7 +5627,7 @@
           <p:cNvPr id="22" name="slide-6-title">
             <a:extLst xmlns:a="http://schemas.openxmlformats.org/drawingml/2006/main">
               <a:ext uri="{FF2B5EF4-FFF2-40B4-BE49-F238E27FC236}">
-                <a16:creationId xmlns:a16="http://schemas.microsoft.com/office/drawing/2014/main" id="{65030833-ABE2-4A87-B659-B817930E9771}"/>
+                <a16:creationId xmlns:a16="http://schemas.microsoft.com/office/drawing/2014/main" id="{204B0FAD-71BE-496F-9F2E-76716A67656A}"/>
               </a:ext>
             </a:extLst>
           </p:cNvPr>
@@ -5677,7 +5677,7 @@
           <p:cNvPr id="2" name="slide-6-number">
             <a:extLst xmlns:a="http://schemas.openxmlformats.org/drawingml/2006/main">
               <a:ext uri="{FF2B5EF4-FFF2-40B4-BE49-F238E27FC236}">
-                <a16:creationId xmlns:a16="http://schemas.microsoft.com/office/drawing/2014/main" id="{1858E37D-0591-4DEF-BB33-05C6EC5EA849}"/>
+                <a16:creationId xmlns:a16="http://schemas.microsoft.com/office/drawing/2014/main" id="{5F8C80DF-E327-4CA6-AB6A-93AD5A8341B9}"/>
               </a:ext>
             </a:extLst>
           </p:cNvPr>
@@ -5727,7 +5727,7 @@
           <p:cNvPr id="3" name="slide-6-rule">
             <a:extLst xmlns:a="http://schemas.openxmlformats.org/drawingml/2006/main">
               <a:ext uri="{FF2B5EF4-FFF2-40B4-BE49-F238E27FC236}">
-                <a16:creationId xmlns:a16="http://schemas.microsoft.com/office/drawing/2014/main" id="{BA671149-44EB-4483-8EBA-D22C84D9C4A0}"/>
+                <a16:creationId xmlns:a16="http://schemas.microsoft.com/office/drawing/2014/main" id="{0D846526-0D67-408A-AB73-094B9186952F}"/>
               </a:ext>
             </a:extLst>
           </p:cNvPr>
@@ -5758,7 +5758,7 @@
           <p:cNvPr id="4" name="rec-0-number">
             <a:extLst xmlns:a="http://schemas.openxmlformats.org/drawingml/2006/main">
               <a:ext uri="{FF2B5EF4-FFF2-40B4-BE49-F238E27FC236}">
-                <a16:creationId xmlns:a16="http://schemas.microsoft.com/office/drawing/2014/main" id="{C6CD347A-8A0C-461B-AAB4-651FED8661E4}"/>
+                <a16:creationId xmlns:a16="http://schemas.microsoft.com/office/drawing/2014/main" id="{D53DC4DC-48F7-4FC7-A138-71399366B9F2}"/>
               </a:ext>
             </a:extLst>
           </p:cNvPr>
@@ -5808,7 +5808,7 @@
           <p:cNvPr id="5" name="rec-0-title">
             <a:extLst xmlns:a="http://schemas.openxmlformats.org/drawingml/2006/main">
               <a:ext uri="{FF2B5EF4-FFF2-40B4-BE49-F238E27FC236}">
-                <a16:creationId xmlns:a16="http://schemas.microsoft.com/office/drawing/2014/main" id="{D6B9E1B4-9617-4954-BE9D-6C1A2B3F8558}"/>
+                <a16:creationId xmlns:a16="http://schemas.microsoft.com/office/drawing/2014/main" id="{5B41012D-F130-4002-8345-B4CC081AD7B0}"/>
               </a:ext>
             </a:extLst>
           </p:cNvPr>
@@ -5858,7 +5858,7 @@
           <p:cNvPr id="6" name="rec-0-rule">
             <a:extLst xmlns:a="http://schemas.openxmlformats.org/drawingml/2006/main">
               <a:ext uri="{FF2B5EF4-FFF2-40B4-BE49-F238E27FC236}">
-                <a16:creationId xmlns:a16="http://schemas.microsoft.com/office/drawing/2014/main" id="{22DFD7F0-3ACB-483E-953E-6DE1A5CD6010}"/>
+                <a16:creationId xmlns:a16="http://schemas.microsoft.com/office/drawing/2014/main" id="{A89378A3-9FD3-40B4-B100-552925FB3E77}"/>
               </a:ext>
             </a:extLst>
           </p:cNvPr>
@@ -5889,7 +5889,7 @@
           <p:cNvPr id="7" name="rec-0-body">
             <a:extLst xmlns:a="http://schemas.openxmlformats.org/drawingml/2006/main">
               <a:ext uri="{FF2B5EF4-FFF2-40B4-BE49-F238E27FC236}">
-                <a16:creationId xmlns:a16="http://schemas.microsoft.com/office/drawing/2014/main" id="{C79D9E20-3ECE-4FED-8896-853E0FC1229A}"/>
+                <a16:creationId xmlns:a16="http://schemas.microsoft.com/office/drawing/2014/main" id="{2A573C18-4B80-4861-A947-D005C04E46FA}"/>
               </a:ext>
             </a:extLst>
           </p:cNvPr>
@@ -5939,7 +5939,7 @@
           <p:cNvPr id="8" name="rec-1-number">
             <a:extLst xmlns:a="http://schemas.openxmlformats.org/drawingml/2006/main">
               <a:ext uri="{FF2B5EF4-FFF2-40B4-BE49-F238E27FC236}">
-                <a16:creationId xmlns:a16="http://schemas.microsoft.com/office/drawing/2014/main" id="{B6D2C461-299D-4C95-BACD-AEC64D4EEC9D}"/>
+                <a16:creationId xmlns:a16="http://schemas.microsoft.com/office/drawing/2014/main" id="{D43D2C50-6BFC-499F-AD52-E3133DEB75D5}"/>
               </a:ext>
             </a:extLst>
           </p:cNvPr>
@@ -5989,7 +5989,7 @@
           <p:cNvPr id="9" name="rec-1-title">
             <a:extLst xmlns:a="http://schemas.openxmlformats.org/drawingml/2006/main">
               <a:ext uri="{FF2B5EF4-FFF2-40B4-BE49-F238E27FC236}">
-                <a16:creationId xmlns:a16="http://schemas.microsoft.com/office/drawing/2014/main" id="{59BC1887-A9D9-4D30-A229-167CD6D80800}"/>
+                <a16:creationId xmlns:a16="http://schemas.microsoft.com/office/drawing/2014/main" id="{46E1EC08-2EAA-4457-82CB-1EA4FC512D30}"/>
               </a:ext>
             </a:extLst>
           </p:cNvPr>
@@ -6039,7 +6039,7 @@
           <p:cNvPr id="10" name="rec-1-rule">
             <a:extLst xmlns:a="http://schemas.openxmlformats.org/drawingml/2006/main">
               <a:ext uri="{FF2B5EF4-FFF2-40B4-BE49-F238E27FC236}">
-                <a16:creationId xmlns:a16="http://schemas.microsoft.com/office/drawing/2014/main" id="{1BAB760D-E3F9-40C4-8853-ADAF7A694FAB}"/>
+                <a16:creationId xmlns:a16="http://schemas.microsoft.com/office/drawing/2014/main" id="{EA09183E-D30D-478C-B336-BAEA000C9E97}"/>
               </a:ext>
             </a:extLst>
           </p:cNvPr>
@@ -6070,7 +6070,7 @@
           <p:cNvPr id="11" name="rec-1-body">
             <a:extLst xmlns:a="http://schemas.openxmlformats.org/drawingml/2006/main">
               <a:ext uri="{FF2B5EF4-FFF2-40B4-BE49-F238E27FC236}">
-                <a16:creationId xmlns:a16="http://schemas.microsoft.com/office/drawing/2014/main" id="{D37C1B47-3081-4D6B-A3FD-D248D13C27F3}"/>
+                <a16:creationId xmlns:a16="http://schemas.microsoft.com/office/drawing/2014/main" id="{90FF0E26-6161-46C6-8806-5F4A0EFBA489}"/>
               </a:ext>
             </a:extLst>
           </p:cNvPr>
@@ -6120,7 +6120,7 @@
           <p:cNvPr id="12" name="rec-2-number">
             <a:extLst xmlns:a="http://schemas.openxmlformats.org/drawingml/2006/main">
               <a:ext uri="{FF2B5EF4-FFF2-40B4-BE49-F238E27FC236}">
-                <a16:creationId xmlns:a16="http://schemas.microsoft.com/office/drawing/2014/main" id="{D50848B5-F977-4D66-B9AB-5698AE67ADEA}"/>
+                <a16:creationId xmlns:a16="http://schemas.microsoft.com/office/drawing/2014/main" id="{BB69E854-F317-432C-809D-7212216743A8}"/>
               </a:ext>
             </a:extLst>
           </p:cNvPr>
@@ -6170,7 +6170,7 @@
           <p:cNvPr id="13" name="rec-2-title">
             <a:extLst xmlns:a="http://schemas.openxmlformats.org/drawingml/2006/main">
               <a:ext uri="{FF2B5EF4-FFF2-40B4-BE49-F238E27FC236}">
-                <a16:creationId xmlns:a16="http://schemas.microsoft.com/office/drawing/2014/main" id="{F20F63F8-EC82-4E07-A098-AD0072748AE4}"/>
+                <a16:creationId xmlns:a16="http://schemas.microsoft.com/office/drawing/2014/main" id="{EE58BF7A-CB3D-4268-9D62-824BB1EE2AC7}"/>
               </a:ext>
             </a:extLst>
           </p:cNvPr>
@@ -6220,7 +6220,7 @@
           <p:cNvPr id="14" name="rec-2-rule">
             <a:extLst xmlns:a="http://schemas.openxmlformats.org/drawingml/2006/main">
               <a:ext uri="{FF2B5EF4-FFF2-40B4-BE49-F238E27FC236}">
-                <a16:creationId xmlns:a16="http://schemas.microsoft.com/office/drawing/2014/main" id="{44933FBA-8C1B-43D6-9720-3AABC62650A8}"/>
+                <a16:creationId xmlns:a16="http://schemas.microsoft.com/office/drawing/2014/main" id="{C737F3F2-9386-4F4A-B11B-13433ECF258A}"/>
               </a:ext>
             </a:extLst>
           </p:cNvPr>
@@ -6251,7 +6251,7 @@
           <p:cNvPr id="15" name="rec-2-body">
             <a:extLst xmlns:a="http://schemas.openxmlformats.org/drawingml/2006/main">
               <a:ext uri="{FF2B5EF4-FFF2-40B4-BE49-F238E27FC236}">
-                <a16:creationId xmlns:a16="http://schemas.microsoft.com/office/drawing/2014/main" id="{6F8779CD-3667-47A1-A9F2-C2C1253DE629}"/>
+                <a16:creationId xmlns:a16="http://schemas.microsoft.com/office/drawing/2014/main" id="{8A0C826F-C1EE-4DD4-AF94-5A104B8AB535}"/>
               </a:ext>
             </a:extLst>
           </p:cNvPr>
@@ -6301,7 +6301,7 @@
           <p:cNvPr id="16" name="rec-3-number">
             <a:extLst xmlns:a="http://schemas.openxmlformats.org/drawingml/2006/main">
               <a:ext uri="{FF2B5EF4-FFF2-40B4-BE49-F238E27FC236}">
-                <a16:creationId xmlns:a16="http://schemas.microsoft.com/office/drawing/2014/main" id="{A4BCD751-C7EB-4F0E-9C7F-713C81E6D807}"/>
+                <a16:creationId xmlns:a16="http://schemas.microsoft.com/office/drawing/2014/main" id="{3162B984-871C-493E-A153-117665FE7AC5}"/>
               </a:ext>
             </a:extLst>
           </p:cNvPr>
@@ -6351,7 +6351,7 @@
           <p:cNvPr id="17" name="rec-3-title">
             <a:extLst xmlns:a="http://schemas.openxmlformats.org/drawingml/2006/main">
               <a:ext uri="{FF2B5EF4-FFF2-40B4-BE49-F238E27FC236}">
-                <a16:creationId xmlns:a16="http://schemas.microsoft.com/office/drawing/2014/main" id="{13C5A8D4-4CE3-4AF5-8521-08AFCCE2DEE5}"/>
+                <a16:creationId xmlns:a16="http://schemas.microsoft.com/office/drawing/2014/main" id="{68B8DB3E-293B-44EC-9FC2-7EA2BA3FD98E}"/>
               </a:ext>
             </a:extLst>
           </p:cNvPr>
@@ -6401,7 +6401,7 @@
           <p:cNvPr id="18" name="rec-3-rule">
             <a:extLst xmlns:a="http://schemas.openxmlformats.org/drawingml/2006/main">
               <a:ext uri="{FF2B5EF4-FFF2-40B4-BE49-F238E27FC236}">
-                <a16:creationId xmlns:a16="http://schemas.microsoft.com/office/drawing/2014/main" id="{E426B7E8-E290-48A5-950F-7F32D6BDF7BE}"/>
+                <a16:creationId xmlns:a16="http://schemas.microsoft.com/office/drawing/2014/main" id="{9A4B7329-1974-4A10-B957-3558FFBB052E}"/>
               </a:ext>
             </a:extLst>
           </p:cNvPr>
@@ -6432,7 +6432,7 @@
           <p:cNvPr id="19" name="rec-3-body">
             <a:extLst xmlns:a="http://schemas.openxmlformats.org/drawingml/2006/main">
               <a:ext uri="{FF2B5EF4-FFF2-40B4-BE49-F238E27FC236}">
-                <a16:creationId xmlns:a16="http://schemas.microsoft.com/office/drawing/2014/main" id="{5CB54FBD-D14B-4A88-BD52-6C368F393367}"/>
+                <a16:creationId xmlns:a16="http://schemas.microsoft.com/office/drawing/2014/main" id="{0C3CE2C7-BF0A-4B34-8A9F-C3EA69861415}"/>
               </a:ext>
             </a:extLst>
           </p:cNvPr>
@@ -6482,7 +6482,7 @@
           <p:cNvPr id="20" name="closing-band">
             <a:extLst xmlns:a="http://schemas.openxmlformats.org/drawingml/2006/main">
               <a:ext uri="{FF2B5EF4-FFF2-40B4-BE49-F238E27FC236}">
-                <a16:creationId xmlns:a16="http://schemas.microsoft.com/office/drawing/2014/main" id="{9A6B7FF2-3540-4DB3-8724-983ADD488D93}"/>
+                <a16:creationId xmlns:a16="http://schemas.microsoft.com/office/drawing/2014/main" id="{F4354C07-42B0-4FEE-B0D1-6EED9E8DE8F3}"/>
               </a:ext>
             </a:extLst>
           </p:cNvPr>
@@ -6513,7 +6513,7 @@
           <p:cNvPr id="21" name="closing-message">
             <a:extLst xmlns:a="http://schemas.openxmlformats.org/drawingml/2006/main">
               <a:ext uri="{FF2B5EF4-FFF2-40B4-BE49-F238E27FC236}">
-                <a16:creationId xmlns:a16="http://schemas.microsoft.com/office/drawing/2014/main" id="{A45A1C5F-0DCF-435F-80D0-A94FBA89BC46}"/>
+                <a16:creationId xmlns:a16="http://schemas.microsoft.com/office/drawing/2014/main" id="{36C15AA7-CBDE-47E9-A2A6-59CB10C71F68}"/>
               </a:ext>
             </a:extLst>
           </p:cNvPr>
@@ -6561,7 +6561,7 @@
     </p:spTree>
     <p:extLst>
       <p:ext uri="{BB962C8B-B14F-4D97-AF65-F5344CB8AC3E}">
-        <p14:creationId xmlns:p14="http://schemas.microsoft.com/office/powerpoint/2010/main" val="1887603265"/>
+        <p14:creationId xmlns:p14="http://schemas.microsoft.com/office/powerpoint/2010/main" val="409516898"/>
       </p:ext>
     </p:extLst>
   </p:cSld>

</xml_diff>